<commit_message>
Deck: baseline label on the wording ladder; hemispheres label fits its window
</commit_message>
<xml_diff>
--- a/deck/IPHR_Reproduction.pptx
+++ b/deck/IPHR_Reproduction.pptx
@@ -9572,7 +9572,7 @@
         </p:blipFill>
         <p:spPr>
           <a:xfrm>
-            <a:off x="444500" y="3810000"/>
+            <a:off x="317500" y="3810000"/>
             <a:ext cx="1111250" cy="1111250"/>
           </a:xfrm>
           <a:prstGeom prst="rect">
@@ -9596,7 +9596,7 @@
         </p:blipFill>
         <p:spPr>
           <a:xfrm>
-            <a:off x="1746250" y="4159250"/>
+            <a:off x="1524000" y="4159250"/>
             <a:ext cx="2667000" cy="381000"/>
           </a:xfrm>
           <a:prstGeom prst="rect">
@@ -39621,7 +39621,7 @@
         </p:blipFill>
         <p:spPr>
           <a:xfrm>
-            <a:off x="444500" y="3810000"/>
+            <a:off x="317500" y="3810000"/>
             <a:ext cx="1111250" cy="1111250"/>
           </a:xfrm>
           <a:prstGeom prst="rect">
@@ -39645,7 +39645,7 @@
         </p:blipFill>
         <p:spPr>
           <a:xfrm>
-            <a:off x="1746250" y="4159250"/>
+            <a:off x="1524000" y="4159250"/>
             <a:ext cx="2667000" cy="381000"/>
           </a:xfrm>
           <a:prstGeom prst="rect">
@@ -41511,7 +41511,7 @@
         </p:blipFill>
         <p:spPr>
           <a:xfrm>
-            <a:off x="444500" y="3810000"/>
+            <a:off x="317500" y="3810000"/>
             <a:ext cx="1111250" cy="1111250"/>
           </a:xfrm>
           <a:prstGeom prst="rect">
@@ -41535,7 +41535,7 @@
         </p:blipFill>
         <p:spPr>
           <a:xfrm>
-            <a:off x="1746250" y="4159250"/>
+            <a:off x="1524000" y="4159250"/>
             <a:ext cx="2667000" cy="381000"/>
           </a:xfrm>
           <a:prstGeom prst="rect">
@@ -42029,7 +42029,7 @@
         </p:blipFill>
         <p:spPr>
           <a:xfrm>
-            <a:off x="444500" y="3810000"/>
+            <a:off x="317500" y="3810000"/>
             <a:ext cx="1111250" cy="1111250"/>
           </a:xfrm>
           <a:prstGeom prst="rect">
@@ -42053,7 +42053,7 @@
         </p:blipFill>
         <p:spPr>
           <a:xfrm>
-            <a:off x="1746250" y="4159250"/>
+            <a:off x="1524000" y="4159250"/>
             <a:ext cx="2667000" cy="381000"/>
           </a:xfrm>
           <a:prstGeom prst="rect">

</xml_diff>

<commit_message>
Deck: art review fixes (collisions, colour use, lean values, legends, larger props), DeepSeek cutoff slide; talk: DeepSeek line, 'by about as much', 'three discrepancies'
</commit_message>
<xml_diff>
--- a/deck/IPHR_Reproduction.pptx
+++ b/deck/IPHR_Reproduction.pptx
@@ -1492,7 +1492,7 @@
           <a:p/>
           <a:p>
             <a:r>
-              <a:t>NEXT: We also found three small discrepancies.</a:t>
+              <a:t>NEXT: We also found three discrepancies.</a:t>
             </a:r>
           </a:p>
         </p:txBody>
@@ -1562,7 +1562,7 @@
           <a:lstStyle/>
           <a:p>
             <a:r>
-              <a:t>We also found three small discrepancies.</a:t>
+              <a:t>We also found three discrepancies.</a:t>
             </a:r>
           </a:p>
           <a:p/>
@@ -2556,7 +2556,7 @@
           <a:p/>
           <a:p>
             <a:r>
-              <a:t>NEXT: The rest may be a different model behind the same name.</a:t>
+              <a:t>NEXT: The rest may be chance, since its leans sit close to the cutoff.</a:t>
             </a:r>
           </a:p>
         </p:txBody>
@@ -2626,7 +2626,7 @@
           <a:lstStyle/>
           <a:p>
             <a:r>
-              <a:t>The rest may be a different model behind the same name.</a:t>
+              <a:t>The rest may be chance, since its leans sit close to the cutoff.</a:t>
             </a:r>
           </a:p>
           <a:p/>
@@ -2860,7 +2860,7 @@
           <a:p/>
           <a:p>
             <a:r>
-              <a:t>NEXT: It did so just as often on pairs that went against its lean.</a:t>
+              <a:t>NEXT: It did so by about as much on pairs that went against its lean.</a:t>
             </a:r>
           </a:p>
         </p:txBody>
@@ -2930,7 +2930,7 @@
           <a:lstStyle/>
           <a:p>
             <a:r>
-              <a:t>It did so just as often on pairs that went against its lean.</a:t>
+              <a:t>It did so by about as much on pairs that went against its lean.</a:t>
             </a:r>
           </a:p>
           <a:p/>
@@ -10469,7 +10469,7 @@
         </p:blipFill>
         <p:spPr>
           <a:xfrm>
-            <a:off x="63500" y="5334000"/>
+            <a:off x="254000" y="5334000"/>
             <a:ext cx="1968500" cy="698500"/>
           </a:xfrm>
           <a:prstGeom prst="rect">
@@ -10493,7 +10493,7 @@
         </p:blipFill>
         <p:spPr>
           <a:xfrm>
-            <a:off x="2286000" y="5334000"/>
+            <a:off x="2476500" y="5334000"/>
             <a:ext cx="1714500" cy="698500"/>
           </a:xfrm>
           <a:prstGeom prst="rect">
@@ -10517,7 +10517,7 @@
         </p:blipFill>
         <p:spPr>
           <a:xfrm>
-            <a:off x="4254500" y="5334000"/>
+            <a:off x="4445000" y="5334000"/>
             <a:ext cx="2127250" cy="698500"/>
           </a:xfrm>
           <a:prstGeom prst="rect">
@@ -10541,7 +10541,7 @@
         </p:blipFill>
         <p:spPr>
           <a:xfrm>
-            <a:off x="6635750" y="5334000"/>
+            <a:off x="6826250" y="5334000"/>
             <a:ext cx="2095500" cy="698500"/>
           </a:xfrm>
           <a:prstGeom prst="rect">
@@ -13889,7 +13889,7 @@
         </p:blipFill>
         <p:spPr>
           <a:xfrm>
-            <a:off x="7632700" y="368300"/>
+            <a:off x="6946900" y="863600"/>
             <a:ext cx="1219200" cy="279400"/>
           </a:xfrm>
           <a:prstGeom prst="rect">
@@ -14657,8 +14657,8 @@
         </p:blipFill>
         <p:spPr>
           <a:xfrm>
-            <a:off x="7493000" y="-254000"/>
-            <a:ext cx="2317750" cy="4667250"/>
+            <a:off x="6794500" y="254000"/>
+            <a:ext cx="3016250" cy="4159250"/>
           </a:xfrm>
           <a:prstGeom prst="rect">
             <a:avLst/>
@@ -15032,7 +15032,7 @@
         <p:spPr>
           <a:xfrm>
             <a:off x="6959600" y="2095500"/>
-            <a:ext cx="2565400" cy="381000"/>
+            <a:ext cx="1498600" cy="381000"/>
           </a:xfrm>
           <a:prstGeom prst="rect">
             <a:avLst/>
@@ -15209,7 +15209,7 @@
       </p:pic>
       <p:pic>
         <p:nvPicPr>
-          <p:cNvPr id="23" name="!!ch_f2v0" descr="image.png"/>
+          <p:cNvPr id="23" name="!!ch_f2l1" descr="image.png"/>
           <p:cNvPicPr>
             <a:picLocks noChangeAspect="1"/>
           </p:cNvPicPr>
@@ -15217,30 +15217,6 @@
         </p:nvPicPr>
         <p:blipFill>
           <a:blip r:embed="rId22"/>
-          <a:stretch>
-            <a:fillRect/>
-          </a:stretch>
-        </p:blipFill>
-        <p:spPr>
-          <a:xfrm>
-            <a:off x="7632700" y="368300"/>
-            <a:ext cx="1219200" cy="279400"/>
-          </a:xfrm>
-          <a:prstGeom prst="rect">
-            <a:avLst/>
-          </a:prstGeom>
-        </p:spPr>
-      </p:pic>
-      <p:pic>
-        <p:nvPicPr>
-          <p:cNvPr id="24" name="!!ch_f2l1" descr="image.png"/>
-          <p:cNvPicPr>
-            <a:picLocks noChangeAspect="1"/>
-          </p:cNvPicPr>
-          <p:nvPr/>
-        </p:nvPicPr>
-        <p:blipFill>
-          <a:blip r:embed="rId23"/>
           <a:stretch>
             <a:fillRect/>
           </a:stretch>
@@ -15257,14 +15233,14 @@
       </p:pic>
       <p:pic>
         <p:nvPicPr>
-          <p:cNvPr id="25" name="!!ch_f2b1" descr="image.png"/>
-          <p:cNvPicPr>
-            <a:picLocks noChangeAspect="1"/>
-          </p:cNvPicPr>
-          <p:nvPr/>
-        </p:nvPicPr>
-        <p:blipFill>
-          <a:blip r:embed="rId24"/>
+          <p:cNvPr id="24" name="!!ch_f2b1" descr="image.png"/>
+          <p:cNvPicPr>
+            <a:picLocks noChangeAspect="1"/>
+          </p:cNvPicPr>
+          <p:nvPr/>
+        </p:nvPicPr>
+        <p:blipFill>
+          <a:blip r:embed="rId23"/>
           <a:stretch>
             <a:fillRect/>
           </a:stretch>
@@ -15281,14 +15257,14 @@
       </p:pic>
       <p:pic>
         <p:nvPicPr>
-          <p:cNvPr id="26" name="!!ch_f2l2" descr="image.png"/>
-          <p:cNvPicPr>
-            <a:picLocks noChangeAspect="1"/>
-          </p:cNvPicPr>
-          <p:nvPr/>
-        </p:nvPicPr>
-        <p:blipFill>
-          <a:blip r:embed="rId25"/>
+          <p:cNvPr id="25" name="!!ch_f2l2" descr="image.png"/>
+          <p:cNvPicPr>
+            <a:picLocks noChangeAspect="1"/>
+          </p:cNvPicPr>
+          <p:nvPr/>
+        </p:nvPicPr>
+        <p:blipFill>
+          <a:blip r:embed="rId24"/>
           <a:stretch>
             <a:fillRect/>
           </a:stretch>
@@ -15305,14 +15281,14 @@
       </p:pic>
       <p:pic>
         <p:nvPicPr>
-          <p:cNvPr id="27" name="!!ch_f2b2" descr="image.png"/>
-          <p:cNvPicPr>
-            <a:picLocks noChangeAspect="1"/>
-          </p:cNvPicPr>
-          <p:nvPr/>
-        </p:nvPicPr>
-        <p:blipFill>
-          <a:blip r:embed="rId26"/>
+          <p:cNvPr id="26" name="!!ch_f2b2" descr="image.png"/>
+          <p:cNvPicPr>
+            <a:picLocks noChangeAspect="1"/>
+          </p:cNvPicPr>
+          <p:nvPr/>
+        </p:nvPicPr>
+        <p:blipFill>
+          <a:blip r:embed="rId25"/>
           <a:stretch>
             <a:fillRect/>
           </a:stretch>
@@ -15329,14 +15305,14 @@
       </p:pic>
       <p:pic>
         <p:nvPicPr>
-          <p:cNvPr id="28" name="!!ch_f2l3" descr="image.png"/>
-          <p:cNvPicPr>
-            <a:picLocks noChangeAspect="1"/>
-          </p:cNvPicPr>
-          <p:nvPr/>
-        </p:nvPicPr>
-        <p:blipFill>
-          <a:blip r:embed="rId27"/>
+          <p:cNvPr id="27" name="!!ch_f2l3" descr="image.png"/>
+          <p:cNvPicPr>
+            <a:picLocks noChangeAspect="1"/>
+          </p:cNvPicPr>
+          <p:nvPr/>
+        </p:nvPicPr>
+        <p:blipFill>
+          <a:blip r:embed="rId26"/>
           <a:stretch>
             <a:fillRect/>
           </a:stretch>
@@ -15353,14 +15329,14 @@
       </p:pic>
       <p:pic>
         <p:nvPicPr>
-          <p:cNvPr id="29" name="!!ch_f2b3" descr="image.png"/>
-          <p:cNvPicPr>
-            <a:picLocks noChangeAspect="1"/>
-          </p:cNvPicPr>
-          <p:nvPr/>
-        </p:nvPicPr>
-        <p:blipFill>
-          <a:blip r:embed="rId28"/>
+          <p:cNvPr id="28" name="!!ch_f2b3" descr="image.png"/>
+          <p:cNvPicPr>
+            <a:picLocks noChangeAspect="1"/>
+          </p:cNvPicPr>
+          <p:nvPr/>
+        </p:nvPicPr>
+        <p:blipFill>
+          <a:blip r:embed="rId27"/>
           <a:stretch>
             <a:fillRect/>
           </a:stretch>
@@ -15377,14 +15353,14 @@
       </p:pic>
       <p:pic>
         <p:nvPicPr>
-          <p:cNvPr id="30" name="!!ch_f2l4" descr="image.png"/>
-          <p:cNvPicPr>
-            <a:picLocks noChangeAspect="1"/>
-          </p:cNvPicPr>
-          <p:nvPr/>
-        </p:nvPicPr>
-        <p:blipFill>
-          <a:blip r:embed="rId29"/>
+          <p:cNvPr id="29" name="!!ch_f2l4" descr="image.png"/>
+          <p:cNvPicPr>
+            <a:picLocks noChangeAspect="1"/>
+          </p:cNvPicPr>
+          <p:nvPr/>
+        </p:nvPicPr>
+        <p:blipFill>
+          <a:blip r:embed="rId28"/>
           <a:stretch>
             <a:fillRect/>
           </a:stretch>
@@ -15401,14 +15377,14 @@
       </p:pic>
       <p:pic>
         <p:nvPicPr>
-          <p:cNvPr id="31" name="!!ch_f2b4" descr="image.png"/>
-          <p:cNvPicPr>
-            <a:picLocks noChangeAspect="1"/>
-          </p:cNvPicPr>
-          <p:nvPr/>
-        </p:nvPicPr>
-        <p:blipFill>
-          <a:blip r:embed="rId30"/>
+          <p:cNvPr id="30" name="!!ch_f2b4" descr="image.png"/>
+          <p:cNvPicPr>
+            <a:picLocks noChangeAspect="1"/>
+          </p:cNvPicPr>
+          <p:nvPr/>
+        </p:nvPicPr>
+        <p:blipFill>
+          <a:blip r:embed="rId29"/>
           <a:stretch>
             <a:fillRect/>
           </a:stretch>
@@ -15425,14 +15401,14 @@
       </p:pic>
       <p:pic>
         <p:nvPicPr>
-          <p:cNvPr id="32" name="!!ch_f2l5" descr="image.png"/>
-          <p:cNvPicPr>
-            <a:picLocks noChangeAspect="1"/>
-          </p:cNvPicPr>
-          <p:nvPr/>
-        </p:nvPicPr>
-        <p:blipFill>
-          <a:blip r:embed="rId31"/>
+          <p:cNvPr id="31" name="!!ch_f2l5" descr="image.png"/>
+          <p:cNvPicPr>
+            <a:picLocks noChangeAspect="1"/>
+          </p:cNvPicPr>
+          <p:nvPr/>
+        </p:nvPicPr>
+        <p:blipFill>
+          <a:blip r:embed="rId30"/>
           <a:stretch>
             <a:fillRect/>
           </a:stretch>
@@ -15449,14 +15425,14 @@
       </p:pic>
       <p:pic>
         <p:nvPicPr>
-          <p:cNvPr id="33" name="!!ch_f2b5" descr="image.png"/>
-          <p:cNvPicPr>
-            <a:picLocks noChangeAspect="1"/>
-          </p:cNvPicPr>
-          <p:nvPr/>
-        </p:nvPicPr>
-        <p:blipFill>
-          <a:blip r:embed="rId32"/>
+          <p:cNvPr id="32" name="!!ch_f2b5" descr="image.png"/>
+          <p:cNvPicPr>
+            <a:picLocks noChangeAspect="1"/>
+          </p:cNvPicPr>
+          <p:nvPr/>
+        </p:nvPicPr>
+        <p:blipFill>
+          <a:blip r:embed="rId31"/>
           <a:stretch>
             <a:fillRect/>
           </a:stretch>
@@ -15473,14 +15449,14 @@
       </p:pic>
       <p:pic>
         <p:nvPicPr>
-          <p:cNvPr id="34" name="!!ch_f2l6" descr="image.png"/>
-          <p:cNvPicPr>
-            <a:picLocks noChangeAspect="1"/>
-          </p:cNvPicPr>
-          <p:nvPr/>
-        </p:nvPicPr>
-        <p:blipFill>
-          <a:blip r:embed="rId33"/>
+          <p:cNvPr id="33" name="!!ch_f2l6" descr="image.png"/>
+          <p:cNvPicPr>
+            <a:picLocks noChangeAspect="1"/>
+          </p:cNvPicPr>
+          <p:nvPr/>
+        </p:nvPicPr>
+        <p:blipFill>
+          <a:blip r:embed="rId32"/>
           <a:stretch>
             <a:fillRect/>
           </a:stretch>
@@ -15497,14 +15473,14 @@
       </p:pic>
       <p:pic>
         <p:nvPicPr>
-          <p:cNvPr id="35" name="!!ch_f2b6" descr="image.png"/>
-          <p:cNvPicPr>
-            <a:picLocks noChangeAspect="1"/>
-          </p:cNvPicPr>
-          <p:nvPr/>
-        </p:nvPicPr>
-        <p:blipFill>
-          <a:blip r:embed="rId32"/>
+          <p:cNvPr id="34" name="!!ch_f2b6" descr="image.png"/>
+          <p:cNvPicPr>
+            <a:picLocks noChangeAspect="1"/>
+          </p:cNvPicPr>
+          <p:nvPr/>
+        </p:nvPicPr>
+        <p:blipFill>
+          <a:blip r:embed="rId31"/>
           <a:stretch>
             <a:fillRect/>
           </a:stretch>
@@ -15521,14 +15497,14 @@
       </p:pic>
       <p:pic>
         <p:nvPicPr>
-          <p:cNvPr id="36" name="!!ch_f2l7" descr="image.png"/>
-          <p:cNvPicPr>
-            <a:picLocks noChangeAspect="1"/>
-          </p:cNvPicPr>
-          <p:nvPr/>
-        </p:nvPicPr>
-        <p:blipFill>
-          <a:blip r:embed="rId34"/>
+          <p:cNvPr id="35" name="!!ch_f2l7" descr="image.png"/>
+          <p:cNvPicPr>
+            <a:picLocks noChangeAspect="1"/>
+          </p:cNvPicPr>
+          <p:nvPr/>
+        </p:nvPicPr>
+        <p:blipFill>
+          <a:blip r:embed="rId33"/>
           <a:stretch>
             <a:fillRect/>
           </a:stretch>
@@ -15545,14 +15521,14 @@
       </p:pic>
       <p:pic>
         <p:nvPicPr>
-          <p:cNvPr id="37" name="!!ch_f2b7" descr="image.png"/>
-          <p:cNvPicPr>
-            <a:picLocks noChangeAspect="1"/>
-          </p:cNvPicPr>
-          <p:nvPr/>
-        </p:nvPicPr>
-        <p:blipFill>
-          <a:blip r:embed="rId35"/>
+          <p:cNvPr id="36" name="!!ch_f2b7" descr="image.png"/>
+          <p:cNvPicPr>
+            <a:picLocks noChangeAspect="1"/>
+          </p:cNvPicPr>
+          <p:nvPr/>
+        </p:nvPicPr>
+        <p:blipFill>
+          <a:blip r:embed="rId34"/>
           <a:stretch>
             <a:fillRect/>
           </a:stretch>
@@ -15569,14 +15545,14 @@
       </p:pic>
       <p:pic>
         <p:nvPicPr>
-          <p:cNvPr id="38" name="!!ch_f2l8" descr="image.png"/>
-          <p:cNvPicPr>
-            <a:picLocks noChangeAspect="1"/>
-          </p:cNvPicPr>
-          <p:nvPr/>
-        </p:nvPicPr>
-        <p:blipFill>
-          <a:blip r:embed="rId36"/>
+          <p:cNvPr id="37" name="!!ch_f2l8" descr="image.png"/>
+          <p:cNvPicPr>
+            <a:picLocks noChangeAspect="1"/>
+          </p:cNvPicPr>
+          <p:nvPr/>
+        </p:nvPicPr>
+        <p:blipFill>
+          <a:blip r:embed="rId35"/>
           <a:stretch>
             <a:fillRect/>
           </a:stretch>
@@ -15593,14 +15569,14 @@
       </p:pic>
       <p:pic>
         <p:nvPicPr>
-          <p:cNvPr id="39" name="!!ch_f2b8" descr="image.png"/>
-          <p:cNvPicPr>
-            <a:picLocks noChangeAspect="1"/>
-          </p:cNvPicPr>
-          <p:nvPr/>
-        </p:nvPicPr>
-        <p:blipFill>
-          <a:blip r:embed="rId37"/>
+          <p:cNvPr id="38" name="!!ch_f2b8" descr="image.png"/>
+          <p:cNvPicPr>
+            <a:picLocks noChangeAspect="1"/>
+          </p:cNvPicPr>
+          <p:nvPr/>
+        </p:nvPicPr>
+        <p:blipFill>
+          <a:blip r:embed="rId36"/>
           <a:stretch>
             <a:fillRect/>
           </a:stretch>
@@ -15617,14 +15593,14 @@
       </p:pic>
       <p:pic>
         <p:nvPicPr>
-          <p:cNvPr id="40" name="!!ch_f2l9" descr="image.png"/>
-          <p:cNvPicPr>
-            <a:picLocks noChangeAspect="1"/>
-          </p:cNvPicPr>
-          <p:nvPr/>
-        </p:nvPicPr>
-        <p:blipFill>
-          <a:blip r:embed="rId38"/>
+          <p:cNvPr id="39" name="!!ch_f2l9" descr="image.png"/>
+          <p:cNvPicPr>
+            <a:picLocks noChangeAspect="1"/>
+          </p:cNvPicPr>
+          <p:nvPr/>
+        </p:nvPicPr>
+        <p:blipFill>
+          <a:blip r:embed="rId37"/>
           <a:stretch>
             <a:fillRect/>
           </a:stretch>
@@ -15641,14 +15617,14 @@
       </p:pic>
       <p:pic>
         <p:nvPicPr>
-          <p:cNvPr id="41" name="!!ch_f2b9" descr="image.png"/>
-          <p:cNvPicPr>
-            <a:picLocks noChangeAspect="1"/>
-          </p:cNvPicPr>
-          <p:nvPr/>
-        </p:nvPicPr>
-        <p:blipFill>
-          <a:blip r:embed="rId39"/>
+          <p:cNvPr id="40" name="!!ch_f2b9" descr="image.png"/>
+          <p:cNvPicPr>
+            <a:picLocks noChangeAspect="1"/>
+          </p:cNvPicPr>
+          <p:nvPr/>
+        </p:nvPicPr>
+        <p:blipFill>
+          <a:blip r:embed="rId38"/>
           <a:stretch>
             <a:fillRect/>
           </a:stretch>
@@ -15665,14 +15641,14 @@
       </p:pic>
       <p:pic>
         <p:nvPicPr>
-          <p:cNvPr id="42" name="!!ch_f2l10" descr="image.png"/>
-          <p:cNvPicPr>
-            <a:picLocks noChangeAspect="1"/>
-          </p:cNvPicPr>
-          <p:nvPr/>
-        </p:nvPicPr>
-        <p:blipFill>
-          <a:blip r:embed="rId40"/>
+          <p:cNvPr id="41" name="!!ch_f2l10" descr="image.png"/>
+          <p:cNvPicPr>
+            <a:picLocks noChangeAspect="1"/>
+          </p:cNvPicPr>
+          <p:nvPr/>
+        </p:nvPicPr>
+        <p:blipFill>
+          <a:blip r:embed="rId39"/>
           <a:stretch>
             <a:fillRect/>
           </a:stretch>
@@ -15689,14 +15665,14 @@
       </p:pic>
       <p:pic>
         <p:nvPicPr>
-          <p:cNvPr id="43" name="!!ch_f2b10" descr="image.png"/>
-          <p:cNvPicPr>
-            <a:picLocks noChangeAspect="1"/>
-          </p:cNvPicPr>
-          <p:nvPr/>
-        </p:nvPicPr>
-        <p:blipFill>
-          <a:blip r:embed="rId39"/>
+          <p:cNvPr id="42" name="!!ch_f2b10" descr="image.png"/>
+          <p:cNvPicPr>
+            <a:picLocks noChangeAspect="1"/>
+          </p:cNvPicPr>
+          <p:nvPr/>
+        </p:nvPicPr>
+        <p:blipFill>
+          <a:blip r:embed="rId38"/>
           <a:stretch>
             <a:fillRect/>
           </a:stretch>
@@ -15713,14 +15689,14 @@
       </p:pic>
       <p:pic>
         <p:nvPicPr>
-          <p:cNvPr id="44" name="!!ch_f2l11" descr="image.png"/>
-          <p:cNvPicPr>
-            <a:picLocks noChangeAspect="1"/>
-          </p:cNvPicPr>
-          <p:nvPr/>
-        </p:nvPicPr>
-        <p:blipFill>
-          <a:blip r:embed="rId41"/>
+          <p:cNvPr id="43" name="!!ch_f2l11" descr="image.png"/>
+          <p:cNvPicPr>
+            <a:picLocks noChangeAspect="1"/>
+          </p:cNvPicPr>
+          <p:nvPr/>
+        </p:nvPicPr>
+        <p:blipFill>
+          <a:blip r:embed="rId40"/>
           <a:stretch>
             <a:fillRect/>
           </a:stretch>
@@ -15737,14 +15713,14 @@
       </p:pic>
       <p:pic>
         <p:nvPicPr>
-          <p:cNvPr id="45" name="!!ch_f2b11" descr="image.png"/>
-          <p:cNvPicPr>
-            <a:picLocks noChangeAspect="1"/>
-          </p:cNvPicPr>
-          <p:nvPr/>
-        </p:nvPicPr>
-        <p:blipFill>
-          <a:blip r:embed="rId42"/>
+          <p:cNvPr id="44" name="!!ch_f2b11" descr="image.png"/>
+          <p:cNvPicPr>
+            <a:picLocks noChangeAspect="1"/>
+          </p:cNvPicPr>
+          <p:nvPr/>
+        </p:nvPicPr>
+        <p:blipFill>
+          <a:blip r:embed="rId41"/>
           <a:stretch>
             <a:fillRect/>
           </a:stretch>
@@ -15761,14 +15737,14 @@
       </p:pic>
       <p:pic>
         <p:nvPicPr>
-          <p:cNvPr id="46" name="!!ch_f2l12" descr="image.png"/>
-          <p:cNvPicPr>
-            <a:picLocks noChangeAspect="1"/>
-          </p:cNvPicPr>
-          <p:nvPr/>
-        </p:nvPicPr>
-        <p:blipFill>
-          <a:blip r:embed="rId43"/>
+          <p:cNvPr id="45" name="!!ch_f2l12" descr="image.png"/>
+          <p:cNvPicPr>
+            <a:picLocks noChangeAspect="1"/>
+          </p:cNvPicPr>
+          <p:nvPr/>
+        </p:nvPicPr>
+        <p:blipFill>
+          <a:blip r:embed="rId42"/>
           <a:stretch>
             <a:fillRect/>
           </a:stretch>
@@ -15785,14 +15761,14 @@
       </p:pic>
       <p:pic>
         <p:nvPicPr>
-          <p:cNvPr id="47" name="!!ch_f2b12" descr="image.png"/>
-          <p:cNvPicPr>
-            <a:picLocks noChangeAspect="1"/>
-          </p:cNvPicPr>
-          <p:nvPr/>
-        </p:nvPicPr>
-        <p:blipFill>
-          <a:blip r:embed="rId42"/>
+          <p:cNvPr id="46" name="!!ch_f2b12" descr="image.png"/>
+          <p:cNvPicPr>
+            <a:picLocks noChangeAspect="1"/>
+          </p:cNvPicPr>
+          <p:nvPr/>
+        </p:nvPicPr>
+        <p:blipFill>
+          <a:blip r:embed="rId41"/>
           <a:stretch>
             <a:fillRect/>
           </a:stretch>
@@ -15809,14 +15785,14 @@
       </p:pic>
       <p:pic>
         <p:nvPicPr>
-          <p:cNvPr id="48" name="!!ch_f2l13" descr="image.png"/>
-          <p:cNvPicPr>
-            <a:picLocks noChangeAspect="1"/>
-          </p:cNvPicPr>
-          <p:nvPr/>
-        </p:nvPicPr>
-        <p:blipFill>
-          <a:blip r:embed="rId44"/>
+          <p:cNvPr id="47" name="!!ch_f2l13" descr="image.png"/>
+          <p:cNvPicPr>
+            <a:picLocks noChangeAspect="1"/>
+          </p:cNvPicPr>
+          <p:nvPr/>
+        </p:nvPicPr>
+        <p:blipFill>
+          <a:blip r:embed="rId43"/>
           <a:stretch>
             <a:fillRect/>
           </a:stretch>
@@ -15833,14 +15809,14 @@
       </p:pic>
       <p:pic>
         <p:nvPicPr>
-          <p:cNvPr id="49" name="!!ch_f2b13" descr="image.png"/>
-          <p:cNvPicPr>
-            <a:picLocks noChangeAspect="1"/>
-          </p:cNvPicPr>
-          <p:nvPr/>
-        </p:nvPicPr>
-        <p:blipFill>
-          <a:blip r:embed="rId45"/>
+          <p:cNvPr id="48" name="!!ch_f2b13" descr="image.png"/>
+          <p:cNvPicPr>
+            <a:picLocks noChangeAspect="1"/>
+          </p:cNvPicPr>
+          <p:nvPr/>
+        </p:nvPicPr>
+        <p:blipFill>
+          <a:blip r:embed="rId44"/>
           <a:stretch>
             <a:fillRect/>
           </a:stretch>
@@ -15857,14 +15833,14 @@
       </p:pic>
       <p:pic>
         <p:nvPicPr>
-          <p:cNvPr id="50" name="!!ch_f2l14" descr="image.png"/>
-          <p:cNvPicPr>
-            <a:picLocks noChangeAspect="1"/>
-          </p:cNvPicPr>
-          <p:nvPr/>
-        </p:nvPicPr>
-        <p:blipFill>
-          <a:blip r:embed="rId46"/>
+          <p:cNvPr id="49" name="!!ch_f2l14" descr="image.png"/>
+          <p:cNvPicPr>
+            <a:picLocks noChangeAspect="1"/>
+          </p:cNvPicPr>
+          <p:nvPr/>
+        </p:nvPicPr>
+        <p:blipFill>
+          <a:blip r:embed="rId45"/>
           <a:stretch>
             <a:fillRect/>
           </a:stretch>
@@ -15881,14 +15857,14 @@
       </p:pic>
       <p:pic>
         <p:nvPicPr>
-          <p:cNvPr id="51" name="!!ch_f2b14" descr="image.png"/>
-          <p:cNvPicPr>
-            <a:picLocks noChangeAspect="1"/>
-          </p:cNvPicPr>
-          <p:nvPr/>
-        </p:nvPicPr>
-        <p:blipFill>
-          <a:blip r:embed="rId47"/>
+          <p:cNvPr id="50" name="!!ch_f2b14" descr="image.png"/>
+          <p:cNvPicPr>
+            <a:picLocks noChangeAspect="1"/>
+          </p:cNvPicPr>
+          <p:nvPr/>
+        </p:nvPicPr>
+        <p:blipFill>
+          <a:blip r:embed="rId46"/>
           <a:stretch>
             <a:fillRect/>
           </a:stretch>
@@ -15905,14 +15881,14 @@
       </p:pic>
       <p:pic>
         <p:nvPicPr>
-          <p:cNvPr id="52" name="!!ch_f2l15" descr="image.png"/>
-          <p:cNvPicPr>
-            <a:picLocks noChangeAspect="1"/>
-          </p:cNvPicPr>
-          <p:nvPr/>
-        </p:nvPicPr>
-        <p:blipFill>
-          <a:blip r:embed="rId48"/>
+          <p:cNvPr id="51" name="!!ch_f2l15" descr="image.png"/>
+          <p:cNvPicPr>
+            <a:picLocks noChangeAspect="1"/>
+          </p:cNvPicPr>
+          <p:nvPr/>
+        </p:nvPicPr>
+        <p:blipFill>
+          <a:blip r:embed="rId47"/>
           <a:stretch>
             <a:fillRect/>
           </a:stretch>
@@ -15929,14 +15905,14 @@
       </p:pic>
       <p:pic>
         <p:nvPicPr>
-          <p:cNvPr id="53" name="!!ch_f2b15" descr="image.png"/>
-          <p:cNvPicPr>
-            <a:picLocks noChangeAspect="1"/>
-          </p:cNvPicPr>
-          <p:nvPr/>
-        </p:nvPicPr>
-        <p:blipFill>
-          <a:blip r:embed="rId47"/>
+          <p:cNvPr id="52" name="!!ch_f2b15" descr="image.png"/>
+          <p:cNvPicPr>
+            <a:picLocks noChangeAspect="1"/>
+          </p:cNvPicPr>
+          <p:nvPr/>
+        </p:nvPicPr>
+        <p:blipFill>
+          <a:blip r:embed="rId46"/>
           <a:stretch>
             <a:fillRect/>
           </a:stretch>
@@ -15953,7 +15929,31 @@
       </p:pic>
       <p:pic>
         <p:nvPicPr>
-          <p:cNvPr id="54" name="!!ch_f2key" descr="image.png"/>
+          <p:cNvPr id="53" name="!!ch_f2key" descr="image.png"/>
+          <p:cNvPicPr>
+            <a:picLocks noChangeAspect="1"/>
+          </p:cNvPicPr>
+          <p:nvPr/>
+        </p:nvPicPr>
+        <p:blipFill>
+          <a:blip r:embed="rId48"/>
+          <a:stretch>
+            <a:fillRect/>
+          </a:stretch>
+        </p:blipFill>
+        <p:spPr>
+          <a:xfrm>
+            <a:off x="7061200" y="2159000"/>
+            <a:ext cx="1270000" cy="304800"/>
+          </a:xfrm>
+          <a:prstGeom prst="rect">
+            <a:avLst/>
+          </a:prstGeom>
+        </p:spPr>
+      </p:pic>
+      <p:pic>
+        <p:nvPicPr>
+          <p:cNvPr id="54" name="!!ch_f2br" descr="image.png"/>
           <p:cNvPicPr>
             <a:picLocks noChangeAspect="1"/>
           </p:cNvPicPr>
@@ -15961,30 +15961,6 @@
         </p:nvPicPr>
         <p:blipFill>
           <a:blip r:embed="rId49"/>
-          <a:stretch>
-            <a:fillRect/>
-          </a:stretch>
-        </p:blipFill>
-        <p:spPr>
-          <a:xfrm>
-            <a:off x="7061200" y="2159000"/>
-            <a:ext cx="2336800" cy="304800"/>
-          </a:xfrm>
-          <a:prstGeom prst="rect">
-            <a:avLst/>
-          </a:prstGeom>
-        </p:spPr>
-      </p:pic>
-      <p:pic>
-        <p:nvPicPr>
-          <p:cNvPr id="55" name="!!ch_f2br" descr="image.png"/>
-          <p:cNvPicPr>
-            <a:picLocks noChangeAspect="1"/>
-          </p:cNvPicPr>
-          <p:nvPr/>
-        </p:nvPicPr>
-        <p:blipFill>
-          <a:blip r:embed="rId50"/>
           <a:stretch>
             <a:fillRect/>
           </a:stretch>
@@ -16001,14 +15977,14 @@
       </p:pic>
       <p:pic>
         <p:nvPicPr>
-          <p:cNvPr id="56" name="!!ch_f2brl" descr="image.png"/>
-          <p:cNvPicPr>
-            <a:picLocks noChangeAspect="1"/>
-          </p:cNvPicPr>
-          <p:nvPr/>
-        </p:nvPicPr>
-        <p:blipFill>
-          <a:blip r:embed="rId51"/>
+          <p:cNvPr id="55" name="!!ch_f2brl" descr="image.png"/>
+          <p:cNvPicPr>
+            <a:picLocks noChangeAspect="1"/>
+          </p:cNvPicPr>
+          <p:nvPr/>
+        </p:nvPicPr>
+        <p:blipFill>
+          <a:blip r:embed="rId50"/>
           <a:stretch>
             <a:fillRect/>
           </a:stretch>
@@ -16025,14 +16001,14 @@
       </p:pic>
       <p:pic>
         <p:nvPicPr>
-          <p:cNvPr id="57" name="!!robot" descr="image.png"/>
-          <p:cNvPicPr>
-            <a:picLocks noChangeAspect="1"/>
-          </p:cNvPicPr>
-          <p:nvPr/>
-        </p:nvPicPr>
-        <p:blipFill>
-          <a:blip r:embed="rId52"/>
+          <p:cNvPr id="56" name="!!robot" descr="image.png"/>
+          <p:cNvPicPr>
+            <a:picLocks noChangeAspect="1"/>
+          </p:cNvPicPr>
+          <p:nvPr/>
+        </p:nvPicPr>
+        <p:blipFill>
+          <a:blip r:embed="rId51"/>
           <a:stretch>
             <a:fillRect/>
           </a:stretch>
@@ -17742,8 +17718,8 @@
         </p:blipFill>
         <p:spPr>
           <a:xfrm>
-            <a:off x="1079500" y="5397500"/>
-            <a:ext cx="2032000" cy="444500"/>
+            <a:off x="698500" y="4762500"/>
+            <a:ext cx="2540000" cy="1079500"/>
           </a:xfrm>
           <a:prstGeom prst="rect">
             <a:avLst/>
@@ -17766,8 +17742,8 @@
         </p:blipFill>
         <p:spPr>
           <a:xfrm>
-            <a:off x="4191000" y="5397500"/>
-            <a:ext cx="2032000" cy="444500"/>
+            <a:off x="3873500" y="4762500"/>
+            <a:ext cx="2540000" cy="1079500"/>
           </a:xfrm>
           <a:prstGeom prst="rect">
             <a:avLst/>
@@ -17790,8 +17766,8 @@
         </p:blipFill>
         <p:spPr>
           <a:xfrm>
-            <a:off x="7302500" y="5397500"/>
-            <a:ext cx="2032000" cy="444500"/>
+            <a:off x="7048500" y="4762500"/>
+            <a:ext cx="2540000" cy="1079500"/>
           </a:xfrm>
           <a:prstGeom prst="rect">
             <a:avLst/>
@@ -17814,8 +17790,8 @@
         </p:blipFill>
         <p:spPr>
           <a:xfrm>
-            <a:off x="1301750" y="3365500"/>
-            <a:ext cx="1587500" cy="2032000"/>
+            <a:off x="984250" y="2222500"/>
+            <a:ext cx="1968500" cy="2540000"/>
           </a:xfrm>
           <a:prstGeom prst="rect">
             <a:avLst/>
@@ -17838,8 +17814,8 @@
         </p:blipFill>
         <p:spPr>
           <a:xfrm>
-            <a:off x="4032250" y="3873500"/>
-            <a:ext cx="2349500" cy="1524000"/>
+            <a:off x="3778250" y="2984500"/>
+            <a:ext cx="2730500" cy="1778000"/>
           </a:xfrm>
           <a:prstGeom prst="rect">
             <a:avLst/>
@@ -17862,8 +17838,8 @@
         </p:blipFill>
         <p:spPr>
           <a:xfrm>
-            <a:off x="7620000" y="4381500"/>
-            <a:ext cx="1397000" cy="1016000"/>
+            <a:off x="7461250" y="3492500"/>
+            <a:ext cx="1746250" cy="1270000"/>
           </a:xfrm>
           <a:prstGeom prst="rect">
             <a:avLst/>
@@ -17910,7 +17886,7 @@
         </p:blipFill>
         <p:spPr>
           <a:xfrm>
-            <a:off x="1270000" y="2794000"/>
+            <a:off x="1143000" y="1651000"/>
             <a:ext cx="1682750" cy="381000"/>
           </a:xfrm>
           <a:prstGeom prst="rect">
@@ -17934,7 +17910,7 @@
         </p:blipFill>
         <p:spPr>
           <a:xfrm>
-            <a:off x="4127500" y="3365500"/>
+            <a:off x="4064000" y="2476500"/>
             <a:ext cx="2190750" cy="317500"/>
           </a:xfrm>
           <a:prstGeom prst="rect">
@@ -17958,7 +17934,7 @@
         </p:blipFill>
         <p:spPr>
           <a:xfrm>
-            <a:off x="7112000" y="3810000"/>
+            <a:off x="7112000" y="2921000"/>
             <a:ext cx="2413000" cy="381000"/>
           </a:xfrm>
           <a:prstGeom prst="rect">
@@ -17983,7 +17959,7 @@
         <p:spPr>
           <a:xfrm>
             <a:off x="254000" y="6159500"/>
-            <a:ext cx="5778500" cy="635000"/>
+            <a:ext cx="4635500" cy="635000"/>
           </a:xfrm>
           <a:prstGeom prst="rect">
             <a:avLst/>
@@ -18394,7 +18370,7 @@
         </p:blipFill>
         <p:spPr>
           <a:xfrm>
-            <a:off x="5905500" y="5842000"/>
+            <a:off x="6350000" y="5842000"/>
             <a:ext cx="3175000" cy="190500"/>
           </a:xfrm>
           <a:prstGeom prst="rect">
@@ -18442,8 +18418,8 @@
         </p:blipFill>
         <p:spPr>
           <a:xfrm>
-            <a:off x="2095500" y="3048000"/>
-            <a:ext cx="4254500" cy="2794000"/>
+            <a:off x="1651000" y="2413000"/>
+            <a:ext cx="5143500" cy="3429000"/>
           </a:xfrm>
           <a:prstGeom prst="rect">
             <a:avLst/>
@@ -18466,7 +18442,7 @@
         </p:blipFill>
         <p:spPr>
           <a:xfrm>
-            <a:off x="5905500" y="3111500"/>
+            <a:off x="6350000" y="3111500"/>
             <a:ext cx="3556000" cy="2730500"/>
           </a:xfrm>
           <a:prstGeom prst="rect">
@@ -18490,7 +18466,7 @@
         </p:blipFill>
         <p:spPr>
           <a:xfrm>
-            <a:off x="1047750" y="2571750"/>
+            <a:off x="825500" y="2000250"/>
             <a:ext cx="1968500" cy="635000"/>
           </a:xfrm>
           <a:prstGeom prst="rect">
@@ -18514,7 +18490,7 @@
         </p:blipFill>
         <p:spPr>
           <a:xfrm>
-            <a:off x="4857750" y="2571750"/>
+            <a:off x="5080000" y="2000250"/>
             <a:ext cx="2349500" cy="635000"/>
           </a:xfrm>
           <a:prstGeom prst="rect">
@@ -18538,7 +18514,7 @@
         </p:blipFill>
         <p:spPr>
           <a:xfrm>
-            <a:off x="1968500" y="5397500"/>
+            <a:off x="1524000" y="5207000"/>
             <a:ext cx="635000" cy="317500"/>
           </a:xfrm>
           <a:prstGeom prst="rect">
@@ -18562,7 +18538,7 @@
         </p:blipFill>
         <p:spPr>
           <a:xfrm>
-            <a:off x="5524500" y="5397500"/>
+            <a:off x="5969000" y="5207000"/>
             <a:ext cx="635000" cy="317500"/>
           </a:xfrm>
           <a:prstGeom prst="rect">
@@ -20078,7 +20054,7 @@
         </p:blipFill>
         <p:spPr>
           <a:xfrm>
-            <a:off x="9017000" y="4159250"/>
+            <a:off x="8636000" y="4508500"/>
             <a:ext cx="1270000" cy="952500"/>
           </a:xfrm>
           <a:prstGeom prst="rect">
@@ -21737,8 +21713,8 @@
         </p:blipFill>
         <p:spPr>
           <a:xfrm>
-            <a:off x="952500" y="4699000"/>
-            <a:ext cx="2286000" cy="920750"/>
+            <a:off x="762000" y="4699000"/>
+            <a:ext cx="2698750" cy="1047750"/>
           </a:xfrm>
           <a:prstGeom prst="rect">
             <a:avLst/>
@@ -21762,7 +21738,7 @@
         <p:spPr>
           <a:xfrm>
             <a:off x="3683000" y="4699000"/>
-            <a:ext cx="2286000" cy="920750"/>
+            <a:ext cx="2286000" cy="1047750"/>
           </a:xfrm>
           <a:prstGeom prst="rect">
             <a:avLst/>
@@ -21786,7 +21762,7 @@
         <p:spPr>
           <a:xfrm>
             <a:off x="6413500" y="4699000"/>
-            <a:ext cx="2286000" cy="920750"/>
+            <a:ext cx="2286000" cy="1047750"/>
           </a:xfrm>
           <a:prstGeom prst="rect">
             <a:avLst/>
@@ -21810,7 +21786,7 @@
         <p:spPr>
           <a:xfrm>
             <a:off x="9144000" y="4699000"/>
-            <a:ext cx="2286000" cy="920750"/>
+            <a:ext cx="2286000" cy="1047750"/>
           </a:xfrm>
           <a:prstGeom prst="rect">
             <a:avLst/>
@@ -23459,7 +23435,7 @@
       </p:pic>
       <p:pic>
         <p:nvPicPr>
-          <p:cNvPr id="3" name="!!floor" descr="image.png"/>
+          <p:cNvPr id="3" name="!!cfloor" descr="image.png"/>
           <p:cNvPicPr>
             <a:picLocks noChangeAspect="1"/>
           </p:cNvPicPr>
@@ -23473,17 +23449,17 @@
         </p:blipFill>
         <p:spPr>
           <a:xfrm>
-            <a:off x="857250" y="5842000"/>
-            <a:ext cx="10477500" cy="190500"/>
-          </a:xfrm>
-          <a:prstGeom prst="rect">
-            <a:avLst/>
-          </a:prstGeom>
-        </p:spPr>
-      </p:pic>
-      <p:pic>
-        <p:nvPicPr>
-          <p:cNvPr id="4" name="!!robot" descr="image.png"/>
+            <a:off x="8699500" y="5842000"/>
+            <a:ext cx="3175000" cy="190500"/>
+          </a:xfrm>
+          <a:prstGeom prst="rect">
+            <a:avLst/>
+          </a:prstGeom>
+        </p:spPr>
+      </p:pic>
+      <p:pic>
+        <p:nvPicPr>
+          <p:cNvPr id="4" name="!!ch_bd" descr="image.png"/>
           <p:cNvPicPr>
             <a:picLocks noChangeAspect="1"/>
           </p:cNvPicPr>
@@ -23497,17 +23473,17 @@
         </p:blipFill>
         <p:spPr>
           <a:xfrm>
-            <a:off x="1174750" y="1746250"/>
-            <a:ext cx="5334000" cy="4095750"/>
-          </a:xfrm>
-          <a:prstGeom prst="rect">
-            <a:avLst/>
-          </a:prstGeom>
-        </p:spPr>
-      </p:pic>
-      <p:pic>
-        <p:nvPicPr>
-          <p:cNvPr id="5" name="!!ds_new" descr="image.png"/>
+            <a:off x="698500" y="444500"/>
+            <a:ext cx="7874000" cy="5080000"/>
+          </a:xfrm>
+          <a:prstGeom prst="rect">
+            <a:avLst/>
+          </a:prstGeom>
+        </p:spPr>
+      </p:pic>
+      <p:pic>
+        <p:nvPicPr>
+          <p:cNvPr id="5" name="!!stand" descr="image.png"/>
           <p:cNvPicPr>
             <a:picLocks noChangeAspect="1"/>
           </p:cNvPicPr>
@@ -23521,17 +23497,17 @@
         </p:blipFill>
         <p:spPr>
           <a:xfrm>
-            <a:off x="6254750" y="1746250"/>
-            <a:ext cx="5334000" cy="4095750"/>
-          </a:xfrm>
-          <a:prstGeom prst="rect">
-            <a:avLst/>
-          </a:prstGeom>
-        </p:spPr>
-      </p:pic>
-      <p:pic>
-        <p:nvPicPr>
-          <p:cNvPr id="6" name="!!bracket" descr="image.png"/>
+            <a:off x="190500" y="4826000"/>
+            <a:ext cx="8382000" cy="1016000"/>
+          </a:xfrm>
+          <a:prstGeom prst="rect">
+            <a:avLst/>
+          </a:prstGeom>
+        </p:spPr>
+      </p:pic>
+      <p:pic>
+        <p:nvPicPr>
+          <p:cNvPr id="6" name="!!ch_dsax" descr="image.png"/>
           <p:cNvPicPr>
             <a:picLocks noChangeAspect="1"/>
           </p:cNvPicPr>
@@ -23545,17 +23521,17 @@
         </p:blipFill>
         <p:spPr>
           <a:xfrm>
-            <a:off x="3524250" y="762000"/>
-            <a:ext cx="5207000" cy="381000"/>
-          </a:xfrm>
-          <a:prstGeom prst="rect">
-            <a:avLst/>
-          </a:prstGeom>
-        </p:spPr>
-      </p:pic>
-      <p:pic>
-        <p:nvPicPr>
-          <p:cNvPr id="7" name="!!t_dsrun0" descr="image.png"/>
+            <a:off x="3937000" y="2286000"/>
+            <a:ext cx="63500" cy="2349500"/>
+          </a:xfrm>
+          <a:prstGeom prst="rect">
+            <a:avLst/>
+          </a:prstGeom>
+        </p:spPr>
+      </p:pic>
+      <p:pic>
+        <p:nvPicPr>
+          <p:cNvPr id="7" name="!!ch_dsaxh" descr="image.png"/>
           <p:cNvPicPr>
             <a:picLocks noChangeAspect="1"/>
           </p:cNvPicPr>
@@ -23569,17 +23545,17 @@
         </p:blipFill>
         <p:spPr>
           <a:xfrm>
-            <a:off x="2222500" y="1143000"/>
-            <a:ext cx="2698750" cy="635000"/>
-          </a:xfrm>
-          <a:prstGeom prst="rect">
-            <a:avLst/>
-          </a:prstGeom>
-        </p:spPr>
-      </p:pic>
-      <p:pic>
-        <p:nvPicPr>
-          <p:cNvPr id="8" name="!!t_dsrun1" descr="image.png"/>
+            <a:off x="3937000" y="4572000"/>
+            <a:ext cx="3810000" cy="63500"/>
+          </a:xfrm>
+          <a:prstGeom prst="rect">
+            <a:avLst/>
+          </a:prstGeom>
+        </p:spPr>
+      </p:pic>
+      <p:pic>
+        <p:nvPicPr>
+          <p:cNvPr id="8" name="!!ch_bdt" descr="image.png"/>
           <p:cNvPicPr>
             <a:picLocks noChangeAspect="1"/>
           </p:cNvPicPr>
@@ -23593,17 +23569,17 @@
         </p:blipFill>
         <p:spPr>
           <a:xfrm>
-            <a:off x="7715250" y="1143000"/>
-            <a:ext cx="1873250" cy="635000"/>
-          </a:xfrm>
-          <a:prstGeom prst="rect">
-            <a:avLst/>
-          </a:prstGeom>
-        </p:spPr>
-      </p:pic>
-      <p:pic>
-        <p:nvPicPr>
-          <p:cNvPr id="9" name="!!t_dsname" descr="image.png"/>
+            <a:off x="1117600" y="800100"/>
+            <a:ext cx="6667500" cy="457200"/>
+          </a:xfrm>
+          <a:prstGeom prst="rect">
+            <a:avLst/>
+          </a:prstGeom>
+        </p:spPr>
+      </p:pic>
+      <p:pic>
+        <p:nvPicPr>
+          <p:cNvPr id="9" name="!!ch_dslg" descr="image.png"/>
           <p:cNvPicPr>
             <a:picLocks noChangeAspect="1"/>
           </p:cNvPicPr>
@@ -23617,17 +23593,17 @@
         </p:blipFill>
         <p:spPr>
           <a:xfrm>
-            <a:off x="4635500" y="127000"/>
-            <a:ext cx="2952750" cy="635000"/>
-          </a:xfrm>
-          <a:prstGeom prst="rect">
-            <a:avLst/>
-          </a:prstGeom>
-        </p:spPr>
-      </p:pic>
-      <p:pic>
-        <p:nvPicPr>
-          <p:cNvPr id="10" name="!!cue" descr="image.png"/>
+            <a:off x="1117600" y="1473200"/>
+            <a:ext cx="6121400" cy="304800"/>
+          </a:xfrm>
+          <a:prstGeom prst="rect">
+            <a:avLst/>
+          </a:prstGeom>
+        </p:spPr>
+      </p:pic>
+      <p:pic>
+        <p:nvPicPr>
+          <p:cNvPr id="10" name="!!ch_dslg2" descr="image.png"/>
           <p:cNvPicPr>
             <a:picLocks noChangeAspect="1"/>
           </p:cNvPicPr>
@@ -23641,8 +23617,368 @@
         </p:blipFill>
         <p:spPr>
           <a:xfrm>
+            <a:off x="1117600" y="1981200"/>
+            <a:ext cx="1879600" cy="254000"/>
+          </a:xfrm>
+          <a:prstGeom prst="rect">
+            <a:avLst/>
+          </a:prstGeom>
+        </p:spPr>
+      </p:pic>
+      <p:pic>
+        <p:nvPicPr>
+          <p:cNvPr id="11" name="!!ch_dsc0" descr="image.png"/>
+          <p:cNvPicPr>
+            <a:picLocks noChangeAspect="1"/>
+          </p:cNvPicPr>
+          <p:nvPr/>
+        </p:nvPicPr>
+        <p:blipFill>
+          <a:blip r:embed="rId11"/>
+          <a:stretch>
+            <a:fillRect/>
+          </a:stretch>
+        </p:blipFill>
+        <p:spPr>
+          <a:xfrm>
+            <a:off x="1117600" y="2717800"/>
+            <a:ext cx="2540000" cy="254000"/>
+          </a:xfrm>
+          <a:prstGeom prst="rect">
+            <a:avLst/>
+          </a:prstGeom>
+        </p:spPr>
+      </p:pic>
+      <p:pic>
+        <p:nvPicPr>
+          <p:cNvPr id="12" name="!!ch_dsb1" descr="image.png"/>
+          <p:cNvPicPr>
+            <a:picLocks noChangeAspect="1"/>
+          </p:cNvPicPr>
+          <p:nvPr/>
+        </p:nvPicPr>
+        <p:blipFill>
+          <a:blip r:embed="rId12"/>
+          <a:stretch>
+            <a:fillRect/>
+          </a:stretch>
+        </p:blipFill>
+        <p:spPr>
+          <a:xfrm>
+            <a:off x="4000500" y="2438400"/>
+            <a:ext cx="2222500" cy="355600"/>
+          </a:xfrm>
+          <a:prstGeom prst="rect">
+            <a:avLst/>
+          </a:prstGeom>
+        </p:spPr>
+      </p:pic>
+      <p:pic>
+        <p:nvPicPr>
+          <p:cNvPr id="13" name="!!ch_dsv1" descr="image.png"/>
+          <p:cNvPicPr>
+            <a:picLocks noChangeAspect="1"/>
+          </p:cNvPicPr>
+          <p:nvPr/>
+        </p:nvPicPr>
+        <p:blipFill>
+          <a:blip r:embed="rId13"/>
+          <a:stretch>
+            <a:fillRect/>
+          </a:stretch>
+        </p:blipFill>
+        <p:spPr>
+          <a:xfrm>
+            <a:off x="6400800" y="2425700"/>
+            <a:ext cx="419100" cy="381000"/>
+          </a:xfrm>
+          <a:prstGeom prst="rect">
+            <a:avLst/>
+          </a:prstGeom>
+        </p:spPr>
+      </p:pic>
+      <p:pic>
+        <p:nvPicPr>
+          <p:cNvPr id="14" name="!!ch_dsb2" descr="image.png"/>
+          <p:cNvPicPr>
+            <a:picLocks noChangeAspect="1"/>
+          </p:cNvPicPr>
+          <p:nvPr/>
+        </p:nvPicPr>
+        <p:blipFill>
+          <a:blip r:embed="rId14"/>
+          <a:stretch>
+            <a:fillRect/>
+          </a:stretch>
+        </p:blipFill>
+        <p:spPr>
+          <a:xfrm>
+            <a:off x="4000500" y="2895600"/>
+            <a:ext cx="1079500" cy="355600"/>
+          </a:xfrm>
+          <a:prstGeom prst="rect">
+            <a:avLst/>
+          </a:prstGeom>
+        </p:spPr>
+      </p:pic>
+      <p:pic>
+        <p:nvPicPr>
+          <p:cNvPr id="15" name="!!ch_dsv2" descr="image.png"/>
+          <p:cNvPicPr>
+            <a:picLocks noChangeAspect="1"/>
+          </p:cNvPicPr>
+          <p:nvPr/>
+        </p:nvPicPr>
+        <p:blipFill>
+          <a:blip r:embed="rId15"/>
+          <a:stretch>
+            <a:fillRect/>
+          </a:stretch>
+        </p:blipFill>
+        <p:spPr>
+          <a:xfrm>
+            <a:off x="5257800" y="2882900"/>
+            <a:ext cx="266700" cy="381000"/>
+          </a:xfrm>
+          <a:prstGeom prst="rect">
+            <a:avLst/>
+          </a:prstGeom>
+        </p:spPr>
+      </p:pic>
+      <p:pic>
+        <p:nvPicPr>
+          <p:cNvPr id="16" name="!!ch_dsc1" descr="image.png"/>
+          <p:cNvPicPr>
+            <a:picLocks noChangeAspect="1"/>
+          </p:cNvPicPr>
+          <p:nvPr/>
+        </p:nvPicPr>
+        <p:blipFill>
+          <a:blip r:embed="rId16"/>
+          <a:stretch>
+            <a:fillRect/>
+          </a:stretch>
+        </p:blipFill>
+        <p:spPr>
+          <a:xfrm>
+            <a:off x="1117600" y="3886200"/>
+            <a:ext cx="2463800" cy="254000"/>
+          </a:xfrm>
+          <a:prstGeom prst="rect">
+            <a:avLst/>
+          </a:prstGeom>
+        </p:spPr>
+      </p:pic>
+      <p:pic>
+        <p:nvPicPr>
+          <p:cNvPr id="17" name="!!ch_dsb3" descr="image.png"/>
+          <p:cNvPicPr>
+            <a:picLocks noChangeAspect="1"/>
+          </p:cNvPicPr>
+          <p:nvPr/>
+        </p:nvPicPr>
+        <p:blipFill>
+          <a:blip r:embed="rId17"/>
+          <a:stretch>
+            <a:fillRect/>
+          </a:stretch>
+        </p:blipFill>
+        <p:spPr>
+          <a:xfrm>
+            <a:off x="4000500" y="3606800"/>
+            <a:ext cx="381000" cy="355600"/>
+          </a:xfrm>
+          <a:prstGeom prst="rect">
+            <a:avLst/>
+          </a:prstGeom>
+        </p:spPr>
+      </p:pic>
+      <p:pic>
+        <p:nvPicPr>
+          <p:cNvPr id="18" name="!!ch_dsv3" descr="image.png"/>
+          <p:cNvPicPr>
+            <a:picLocks noChangeAspect="1"/>
+          </p:cNvPicPr>
+          <p:nvPr/>
+        </p:nvPicPr>
+        <p:blipFill>
+          <a:blip r:embed="rId18"/>
+          <a:stretch>
+            <a:fillRect/>
+          </a:stretch>
+        </p:blipFill>
+        <p:spPr>
+          <a:xfrm>
+            <a:off x="4559300" y="3594100"/>
+            <a:ext cx="266700" cy="381000"/>
+          </a:xfrm>
+          <a:prstGeom prst="rect">
+            <a:avLst/>
+          </a:prstGeom>
+        </p:spPr>
+      </p:pic>
+      <p:pic>
+        <p:nvPicPr>
+          <p:cNvPr id="19" name="!!ch_dsb4" descr="image.png"/>
+          <p:cNvPicPr>
+            <a:picLocks noChangeAspect="1"/>
+          </p:cNvPicPr>
+          <p:nvPr/>
+        </p:nvPicPr>
+        <p:blipFill>
+          <a:blip r:embed="rId19"/>
+          <a:stretch>
+            <a:fillRect/>
+          </a:stretch>
+        </p:blipFill>
+        <p:spPr>
+          <a:xfrm>
+            <a:off x="4000500" y="4064000"/>
+            <a:ext cx="571500" cy="355600"/>
+          </a:xfrm>
+          <a:prstGeom prst="rect">
+            <a:avLst/>
+          </a:prstGeom>
+        </p:spPr>
+      </p:pic>
+      <p:pic>
+        <p:nvPicPr>
+          <p:cNvPr id="20" name="!!ch_dsv4" descr="image.png"/>
+          <p:cNvPicPr>
+            <a:picLocks noChangeAspect="1"/>
+          </p:cNvPicPr>
+          <p:nvPr/>
+        </p:nvPicPr>
+        <p:blipFill>
+          <a:blip r:embed="rId20"/>
+          <a:stretch>
+            <a:fillRect/>
+          </a:stretch>
+        </p:blipFill>
+        <p:spPr>
+          <a:xfrm>
+            <a:off x="4749800" y="4051300"/>
+            <a:ext cx="266700" cy="381000"/>
+          </a:xfrm>
+          <a:prstGeom prst="rect">
+            <a:avLst/>
+          </a:prstGeom>
+        </p:spPr>
+      </p:pic>
+      <p:pic>
+        <p:nvPicPr>
+          <p:cNvPr id="21" name="!!ch_dst0" descr="image.png"/>
+          <p:cNvPicPr>
+            <a:picLocks noChangeAspect="1"/>
+          </p:cNvPicPr>
+          <p:nvPr/>
+        </p:nvPicPr>
+        <p:blipFill>
+          <a:blip r:embed="rId21"/>
+          <a:stretch>
+            <a:fillRect/>
+          </a:stretch>
+        </p:blipFill>
+        <p:spPr>
+          <a:xfrm>
+            <a:off x="3911600" y="4749800"/>
+            <a:ext cx="152400" cy="254000"/>
+          </a:xfrm>
+          <a:prstGeom prst="rect">
+            <a:avLst/>
+          </a:prstGeom>
+        </p:spPr>
+      </p:pic>
+      <p:pic>
+        <p:nvPicPr>
+          <p:cNvPr id="22" name="!!ch_dst10" descr="image.png"/>
+          <p:cNvPicPr>
+            <a:picLocks noChangeAspect="1"/>
+          </p:cNvPicPr>
+          <p:nvPr/>
+        </p:nvPicPr>
+        <p:blipFill>
+          <a:blip r:embed="rId22"/>
+          <a:stretch>
+            <a:fillRect/>
+          </a:stretch>
+        </p:blipFill>
+        <p:spPr>
+          <a:xfrm>
+            <a:off x="5702300" y="4749800"/>
+            <a:ext cx="254000" cy="254000"/>
+          </a:xfrm>
+          <a:prstGeom prst="rect">
+            <a:avLst/>
+          </a:prstGeom>
+        </p:spPr>
+      </p:pic>
+      <p:pic>
+        <p:nvPicPr>
+          <p:cNvPr id="23" name="!!ch_dst20" descr="image.png"/>
+          <p:cNvPicPr>
+            <a:picLocks noChangeAspect="1"/>
+          </p:cNvPicPr>
+          <p:nvPr/>
+        </p:nvPicPr>
+        <p:blipFill>
+          <a:blip r:embed="rId23"/>
+          <a:stretch>
+            <a:fillRect/>
+          </a:stretch>
+        </p:blipFill>
+        <p:spPr>
+          <a:xfrm>
+            <a:off x="7493000" y="4749800"/>
+            <a:ext cx="355600" cy="254000"/>
+          </a:xfrm>
+          <a:prstGeom prst="rect">
+            <a:avLst/>
+          </a:prstGeom>
+        </p:spPr>
+      </p:pic>
+      <p:pic>
+        <p:nvPicPr>
+          <p:cNvPr id="24" name="!!robot" descr="image.png"/>
+          <p:cNvPicPr>
+            <a:picLocks noChangeAspect="1"/>
+          </p:cNvPicPr>
+          <p:nvPr/>
+        </p:nvPicPr>
+        <p:blipFill>
+          <a:blip r:embed="rId24"/>
+          <a:stretch>
+            <a:fillRect/>
+          </a:stretch>
+        </p:blipFill>
+        <p:spPr>
+          <a:xfrm>
+            <a:off x="8699500" y="3111500"/>
+            <a:ext cx="3556000" cy="2730500"/>
+          </a:xfrm>
+          <a:prstGeom prst="rect">
+            <a:avLst/>
+          </a:prstGeom>
+        </p:spPr>
+      </p:pic>
+      <p:pic>
+        <p:nvPicPr>
+          <p:cNvPr id="25" name="!!cue" descr="image.png"/>
+          <p:cNvPicPr>
+            <a:picLocks noChangeAspect="1"/>
+          </p:cNvPicPr>
+          <p:nvPr/>
+        </p:nvPicPr>
+        <p:blipFill>
+          <a:blip r:embed="rId25"/>
+          <a:stretch>
+            <a:fillRect/>
+          </a:stretch>
+        </p:blipFill>
+        <p:spPr>
+          <a:xfrm>
             <a:off x="254000" y="6159500"/>
-            <a:ext cx="7524750" cy="635000"/>
+            <a:ext cx="5683250" cy="635000"/>
           </a:xfrm>
           <a:prstGeom prst="rect">
             <a:avLst/>
@@ -24178,7 +24514,7 @@
         </p:blipFill>
         <p:spPr>
           <a:xfrm>
-            <a:off x="317500" y="5842000"/>
+            <a:off x="63500" y="5842000"/>
             <a:ext cx="3175000" cy="190500"/>
           </a:xfrm>
           <a:prstGeom prst="rect">
@@ -24562,7 +24898,7 @@
         </p:blipFill>
         <p:spPr>
           <a:xfrm>
-            <a:off x="317500" y="3111500"/>
+            <a:off x="63500" y="3111500"/>
             <a:ext cx="3556000" cy="2730500"/>
           </a:xfrm>
           <a:prstGeom prst="rect">
@@ -24672,7 +25008,7 @@
         </p:blipFill>
         <p:spPr>
           <a:xfrm>
-            <a:off x="317500" y="5842000"/>
+            <a:off x="63500" y="5842000"/>
             <a:ext cx="3175000" cy="190500"/>
           </a:xfrm>
           <a:prstGeom prst="rect">
@@ -25176,7 +25512,7 @@
         </p:blipFill>
         <p:spPr>
           <a:xfrm>
-            <a:off x="317500" y="3111500"/>
+            <a:off x="63500" y="3111500"/>
             <a:ext cx="3556000" cy="2730500"/>
           </a:xfrm>
           <a:prstGeom prst="rect">
@@ -25201,7 +25537,7 @@
         <p:spPr>
           <a:xfrm>
             <a:off x="254000" y="6159500"/>
-            <a:ext cx="6731000" cy="635000"/>
+            <a:ext cx="7112000" cy="635000"/>
           </a:xfrm>
           <a:prstGeom prst="rect">
             <a:avLst/>
@@ -29263,8 +29599,8 @@
         </p:blipFill>
         <p:spPr>
           <a:xfrm>
-            <a:off x="762000" y="3079750"/>
-            <a:ext cx="3556000" cy="1174750"/>
+            <a:off x="254000" y="2190750"/>
+            <a:ext cx="4445000" cy="1174750"/>
           </a:xfrm>
           <a:prstGeom prst="rect">
             <a:avLst/>
@@ -29287,8 +29623,8 @@
         </p:blipFill>
         <p:spPr>
           <a:xfrm>
-            <a:off x="8731250" y="2254250"/>
-            <a:ext cx="2000250" cy="2000250"/>
+            <a:off x="8540750" y="857250"/>
+            <a:ext cx="2508250" cy="2508250"/>
           </a:xfrm>
           <a:prstGeom prst="rect">
             <a:avLst/>
@@ -29335,7 +29671,7 @@
         </p:blipFill>
         <p:spPr>
           <a:xfrm>
-            <a:off x="381000" y="4635500"/>
+            <a:off x="317500" y="3746500"/>
             <a:ext cx="4318000" cy="381000"/>
           </a:xfrm>
           <a:prstGeom prst="rect">
@@ -29359,7 +29695,7 @@
         </p:blipFill>
         <p:spPr>
           <a:xfrm>
-            <a:off x="7715250" y="4635500"/>
+            <a:off x="7778750" y="3746500"/>
             <a:ext cx="4032250" cy="381000"/>
           </a:xfrm>
           <a:prstGeom prst="rect">
@@ -30002,7 +30338,7 @@
         </p:blipFill>
         <p:spPr>
           <a:xfrm>
-            <a:off x="2952750" y="571500"/>
+            <a:off x="2952750" y="444500"/>
             <a:ext cx="5048250" cy="381000"/>
           </a:xfrm>
           <a:prstGeom prst="rect">
@@ -30026,7 +30362,7 @@
         </p:blipFill>
         <p:spPr>
           <a:xfrm>
-            <a:off x="8318500" y="444500"/>
+            <a:off x="8318500" y="317500"/>
             <a:ext cx="952500" cy="635000"/>
           </a:xfrm>
           <a:prstGeom prst="rect">
@@ -30036,7 +30372,7 @@
       </p:pic>
       <p:pic>
         <p:nvPicPr>
-          <p:cNvPr id="18" name="!!cue" descr="image.png"/>
+          <p:cNvPr id="18" name="!!t_four" descr="image.png"/>
           <p:cNvPicPr>
             <a:picLocks noChangeAspect="1"/>
           </p:cNvPicPr>
@@ -30044,6 +30380,30 @@
         </p:nvPicPr>
         <p:blipFill>
           <a:blip r:embed="rId18"/>
+          <a:stretch>
+            <a:fillRect/>
+          </a:stretch>
+        </p:blipFill>
+        <p:spPr>
+          <a:xfrm>
+            <a:off x="3238500" y="1016000"/>
+            <a:ext cx="5715000" cy="317500"/>
+          </a:xfrm>
+          <a:prstGeom prst="rect">
+            <a:avLst/>
+          </a:prstGeom>
+        </p:spPr>
+      </p:pic>
+      <p:pic>
+        <p:nvPicPr>
+          <p:cNvPr id="19" name="!!cue" descr="image.png"/>
+          <p:cNvPicPr>
+            <a:picLocks noChangeAspect="1"/>
+          </p:cNvPicPr>
+          <p:nvPr/>
+        </p:nvPicPr>
+        <p:blipFill>
+          <a:blip r:embed="rId19"/>
           <a:stretch>
             <a:fillRect/>
           </a:stretch>
@@ -30448,7 +30808,7 @@
         </p:blipFill>
         <p:spPr>
           <a:xfrm>
-            <a:off x="2095500" y="571500"/>
+            <a:off x="2095500" y="444500"/>
             <a:ext cx="5048250" cy="381000"/>
           </a:xfrm>
           <a:prstGeom prst="rect">
@@ -30472,7 +30832,7 @@
         </p:blipFill>
         <p:spPr>
           <a:xfrm>
-            <a:off x="7461250" y="444500"/>
+            <a:off x="7461250" y="317500"/>
             <a:ext cx="2667000" cy="635000"/>
           </a:xfrm>
           <a:prstGeom prst="rect">
@@ -30482,7 +30842,7 @@
       </p:pic>
       <p:pic>
         <p:nvPicPr>
-          <p:cNvPr id="18" name="!!cue" descr="image.png"/>
+          <p:cNvPr id="18" name="!!t_four" descr="image.png"/>
           <p:cNvPicPr>
             <a:picLocks noChangeAspect="1"/>
           </p:cNvPicPr>
@@ -30490,6 +30850,30 @@
         </p:nvPicPr>
         <p:blipFill>
           <a:blip r:embed="rId15"/>
+          <a:stretch>
+            <a:fillRect/>
+          </a:stretch>
+        </p:blipFill>
+        <p:spPr>
+          <a:xfrm>
+            <a:off x="3238500" y="1016000"/>
+            <a:ext cx="5715000" cy="317500"/>
+          </a:xfrm>
+          <a:prstGeom prst="rect">
+            <a:avLst/>
+          </a:prstGeom>
+        </p:spPr>
+      </p:pic>
+      <p:pic>
+        <p:nvPicPr>
+          <p:cNvPr id="19" name="!!cue" descr="image.png"/>
+          <p:cNvPicPr>
+            <a:picLocks noChangeAspect="1"/>
+          </p:cNvPicPr>
+          <p:nvPr/>
+        </p:nvPicPr>
+        <p:blipFill>
+          <a:blip r:embed="rId16"/>
           <a:stretch>
             <a:fillRect/>
           </a:stretch>
@@ -30654,8 +31038,8 @@
         </p:blipFill>
         <p:spPr>
           <a:xfrm>
-            <a:off x="3619500" y="2743200"/>
-            <a:ext cx="63500" cy="1739900"/>
+            <a:off x="3619500" y="2895600"/>
+            <a:ext cx="63500" cy="1663700"/>
           </a:xfrm>
           <a:prstGeom prst="rect">
             <a:avLst/>
@@ -31498,8 +31882,8 @@
         </p:blipFill>
         <p:spPr>
           <a:xfrm>
-            <a:off x="3619500" y="2743200"/>
-            <a:ext cx="63500" cy="1739900"/>
+            <a:off x="3619500" y="2895600"/>
+            <a:ext cx="63500" cy="1663700"/>
           </a:xfrm>
           <a:prstGeom prst="rect">
             <a:avLst/>
@@ -31968,8 +32352,8 @@
         </p:blipFill>
         <p:spPr>
           <a:xfrm>
-            <a:off x="3619500" y="2743200"/>
-            <a:ext cx="63500" cy="1739900"/>
+            <a:off x="3619500" y="2895600"/>
+            <a:ext cx="63500" cy="1663700"/>
           </a:xfrm>
           <a:prstGeom prst="rect">
             <a:avLst/>
@@ -32463,7 +32847,7 @@
         <p:spPr>
           <a:xfrm>
             <a:off x="698500" y="762000"/>
-            <a:ext cx="4762500" cy="3683000"/>
+            <a:ext cx="4762500" cy="4191000"/>
           </a:xfrm>
           <a:prstGeom prst="rect">
             <a:avLst/>
@@ -32511,7 +32895,7 @@
         <p:spPr>
           <a:xfrm>
             <a:off x="952500" y="2794000"/>
-            <a:ext cx="4254500" cy="1460500"/>
+            <a:ext cx="4254500" cy="1968500"/>
           </a:xfrm>
           <a:prstGeom prst="rect">
             <a:avLst/>
@@ -32568,7 +32952,7 @@
       </p:pic>
       <p:pic>
         <p:nvPicPr>
-          <p:cNvPr id="10" name="!!t_nums" descr="image.png"/>
+          <p:cNvPr id="10" name="!!cue" descr="image.png"/>
           <p:cNvPicPr>
             <a:picLocks noChangeAspect="1"/>
           </p:cNvPicPr>
@@ -32576,54 +32960,6 @@
         </p:nvPicPr>
         <p:blipFill>
           <a:blip r:embed="rId10"/>
-          <a:stretch>
-            <a:fillRect/>
-          </a:stretch>
-        </p:blipFill>
-        <p:spPr>
-          <a:xfrm>
-            <a:off x="5842000" y="1968500"/>
-            <a:ext cx="2476500" cy="317500"/>
-          </a:xfrm>
-          <a:prstGeom prst="rect">
-            <a:avLst/>
-          </a:prstGeom>
-        </p:spPr>
-      </p:pic>
-      <p:pic>
-        <p:nvPicPr>
-          <p:cNvPr id="11" name="!!leader" descr="image.png"/>
-          <p:cNvPicPr>
-            <a:picLocks noChangeAspect="1"/>
-          </p:cNvPicPr>
-          <p:nvPr/>
-        </p:nvPicPr>
-        <p:blipFill>
-          <a:blip r:embed="rId11"/>
-          <a:stretch>
-            <a:fillRect/>
-          </a:stretch>
-        </p:blipFill>
-        <p:spPr>
-          <a:xfrm>
-            <a:off x="3746500" y="2127250"/>
-            <a:ext cx="2000250" cy="1174750"/>
-          </a:xfrm>
-          <a:prstGeom prst="rect">
-            <a:avLst/>
-          </a:prstGeom>
-        </p:spPr>
-      </p:pic>
-      <p:pic>
-        <p:nvPicPr>
-          <p:cNvPr id="12" name="!!cue" descr="image.png"/>
-          <p:cNvPicPr>
-            <a:picLocks noChangeAspect="1"/>
-          </p:cNvPicPr>
-          <p:nvPr/>
-        </p:nvPicPr>
-        <p:blipFill>
-          <a:blip r:embed="rId12"/>
           <a:stretch>
             <a:fillRect/>
           </a:stretch>
@@ -32740,7 +33076,7 @@
         </p:blipFill>
         <p:spPr>
           <a:xfrm>
-            <a:off x="5905500" y="3397250"/>
+            <a:off x="5334000" y="3397250"/>
             <a:ext cx="3175000" cy="2444750"/>
           </a:xfrm>
           <a:prstGeom prst="rect">
@@ -32994,7 +33330,7 @@
         </p:blipFill>
         <p:spPr>
           <a:xfrm>
-            <a:off x="6254750" y="3397250"/>
+            <a:off x="5873750" y="3397250"/>
             <a:ext cx="3175000" cy="2444750"/>
           </a:xfrm>
           <a:prstGeom prst="rect">
@@ -36702,8 +37038,8 @@
         </p:blipFill>
         <p:spPr>
           <a:xfrm>
-            <a:off x="7080250" y="4572000"/>
-            <a:ext cx="2222500" cy="317500"/>
+            <a:off x="6572250" y="5143500"/>
+            <a:ext cx="3016250" cy="635000"/>
           </a:xfrm>
           <a:prstGeom prst="rect">
             <a:avLst/>
@@ -37153,7 +37489,7 @@
         </p:blipFill>
         <p:spPr>
           <a:xfrm>
-            <a:off x="7270750" y="4953000"/>
+            <a:off x="6762750" y="4953000"/>
             <a:ext cx="3175000" cy="635000"/>
           </a:xfrm>
           <a:prstGeom prst="rect">
@@ -37177,7 +37513,7 @@
         </p:blipFill>
         <p:spPr>
           <a:xfrm>
-            <a:off x="825500" y="4953000"/>
+            <a:off x="190500" y="4953000"/>
             <a:ext cx="5175250" cy="635000"/>
           </a:xfrm>
           <a:prstGeom prst="rect">
@@ -37187,7 +37523,7 @@
       </p:pic>
       <p:pic>
         <p:nvPicPr>
-          <p:cNvPr id="8" name="!!cue" descr="image.png"/>
+          <p:cNvPr id="8" name="!!t_ans0" descr="image.png"/>
           <p:cNvPicPr>
             <a:picLocks noChangeAspect="1"/>
           </p:cNvPicPr>
@@ -37195,6 +37531,54 @@
         </p:nvPicPr>
         <p:blipFill>
           <a:blip r:embed="rId8"/>
+          <a:stretch>
+            <a:fillRect/>
+          </a:stretch>
+        </p:blipFill>
+        <p:spPr>
+          <a:xfrm>
+            <a:off x="5524500" y="4984750"/>
+            <a:ext cx="1079500" cy="571500"/>
+          </a:xfrm>
+          <a:prstGeom prst="rect">
+            <a:avLst/>
+          </a:prstGeom>
+        </p:spPr>
+      </p:pic>
+      <p:pic>
+        <p:nvPicPr>
+          <p:cNvPr id="9" name="!!t_ans1" descr="image.png"/>
+          <p:cNvPicPr>
+            <a:picLocks noChangeAspect="1"/>
+          </p:cNvPicPr>
+          <p:nvPr/>
+        </p:nvPicPr>
+        <p:blipFill>
+          <a:blip r:embed="rId9"/>
+          <a:stretch>
+            <a:fillRect/>
+          </a:stretch>
+        </p:blipFill>
+        <p:spPr>
+          <a:xfrm>
+            <a:off x="10096500" y="4984750"/>
+            <a:ext cx="857250" cy="571500"/>
+          </a:xfrm>
+          <a:prstGeom prst="rect">
+            <a:avLst/>
+          </a:prstGeom>
+        </p:spPr>
+      </p:pic>
+      <p:pic>
+        <p:nvPicPr>
+          <p:cNvPr id="10" name="!!cue" descr="image.png"/>
+          <p:cNvPicPr>
+            <a:picLocks noChangeAspect="1"/>
+          </p:cNvPicPr>
+          <p:nvPr/>
+        </p:nvPicPr>
+        <p:blipFill>
+          <a:blip r:embed="rId10"/>
           <a:stretch>
             <a:fillRect/>
           </a:stretch>
@@ -37988,7 +38372,7 @@
       </p:pic>
       <p:pic>
         <p:nvPicPr>
-          <p:cNvPr id="8" name="!!ch_bdt" descr="image.png"/>
+          <p:cNvPr id="8" name="!!ch_f2kp" descr="image.png"/>
           <p:cNvPicPr>
             <a:picLocks noChangeAspect="1"/>
           </p:cNvPicPr>
@@ -37996,6 +38380,30 @@
         </p:nvPicPr>
         <p:blipFill>
           <a:blip r:embed="rId7"/>
+          <a:stretch>
+            <a:fillRect/>
+          </a:stretch>
+        </p:blipFill>
+        <p:spPr>
+          <a:xfrm>
+            <a:off x="6286500" y="1422400"/>
+            <a:ext cx="2540000" cy="838200"/>
+          </a:xfrm>
+          <a:prstGeom prst="rect">
+            <a:avLst/>
+          </a:prstGeom>
+        </p:spPr>
+      </p:pic>
+      <p:pic>
+        <p:nvPicPr>
+          <p:cNvPr id="9" name="!!ch_bdt" descr="image.png"/>
+          <p:cNvPicPr>
+            <a:picLocks noChangeAspect="1"/>
+          </p:cNvPicPr>
+          <p:nvPr/>
+        </p:nvPicPr>
+        <p:blipFill>
+          <a:blip r:embed="rId8"/>
           <a:stretch>
             <a:fillRect/>
           </a:stretch>
@@ -38012,14 +38420,14 @@
       </p:pic>
       <p:pic>
         <p:nvPicPr>
-          <p:cNvPr id="9" name="!!ch_bds" descr="image.png"/>
-          <p:cNvPicPr>
-            <a:picLocks noChangeAspect="1"/>
-          </p:cNvPicPr>
-          <p:nvPr/>
-        </p:nvPicPr>
-        <p:blipFill>
-          <a:blip r:embed="rId8"/>
+          <p:cNvPr id="10" name="!!ch_bds" descr="image.png"/>
+          <p:cNvPicPr>
+            <a:picLocks noChangeAspect="1"/>
+          </p:cNvPicPr>
+          <p:nvPr/>
+        </p:nvPicPr>
+        <p:blipFill>
+          <a:blip r:embed="rId9"/>
           <a:stretch>
             <a:fillRect/>
           </a:stretch>
@@ -38036,21 +38444,21 @@
       </p:pic>
       <p:pic>
         <p:nvPicPr>
-          <p:cNvPr id="10" name="!!ch_f2y5" descr="image.png"/>
-          <p:cNvPicPr>
-            <a:picLocks noChangeAspect="1"/>
-          </p:cNvPicPr>
-          <p:nvPr/>
-        </p:nvPicPr>
-        <p:blipFill>
-          <a:blip r:embed="rId9"/>
-          <a:stretch>
-            <a:fillRect/>
-          </a:stretch>
-        </p:blipFill>
-        <p:spPr>
-          <a:xfrm>
-            <a:off x="4953000" y="5435600"/>
+          <p:cNvPr id="11" name="!!ch_f2y5" descr="image.png"/>
+          <p:cNvPicPr>
+            <a:picLocks noChangeAspect="1"/>
+          </p:cNvPicPr>
+          <p:nvPr/>
+        </p:nvPicPr>
+        <p:blipFill>
+          <a:blip r:embed="rId10"/>
+          <a:stretch>
+            <a:fillRect/>
+          </a:stretch>
+        </p:blipFill>
+        <p:spPr>
+          <a:xfrm>
+            <a:off x="5676900" y="5435600"/>
             <a:ext cx="457200" cy="254000"/>
           </a:xfrm>
           <a:prstGeom prst="rect">
@@ -38060,21 +38468,21 @@
       </p:pic>
       <p:pic>
         <p:nvPicPr>
-          <p:cNvPr id="11" name="!!ch_f2y10" descr="image.png"/>
-          <p:cNvPicPr>
-            <a:picLocks noChangeAspect="1"/>
-          </p:cNvPicPr>
-          <p:nvPr/>
-        </p:nvPicPr>
-        <p:blipFill>
-          <a:blip r:embed="rId10"/>
-          <a:stretch>
-            <a:fillRect/>
-          </a:stretch>
-        </p:blipFill>
-        <p:spPr>
-          <a:xfrm>
-            <a:off x="6057900" y="5435600"/>
+          <p:cNvPr id="12" name="!!ch_f2y10" descr="image.png"/>
+          <p:cNvPicPr>
+            <a:picLocks noChangeAspect="1"/>
+          </p:cNvPicPr>
+          <p:nvPr/>
+        </p:nvPicPr>
+        <p:blipFill>
+          <a:blip r:embed="rId11"/>
+          <a:stretch>
+            <a:fillRect/>
+          </a:stretch>
+        </p:blipFill>
+        <p:spPr>
+          <a:xfrm>
+            <a:off x="6883400" y="5435600"/>
             <a:ext cx="558800" cy="254000"/>
           </a:xfrm>
           <a:prstGeom prst="rect">
@@ -38084,14 +38492,14 @@
       </p:pic>
       <p:pic>
         <p:nvPicPr>
-          <p:cNvPr id="12" name="!!ch_f2n" descr="image.png"/>
-          <p:cNvPicPr>
-            <a:picLocks noChangeAspect="1"/>
-          </p:cNvPicPr>
-          <p:nvPr/>
-        </p:nvPicPr>
-        <p:blipFill>
-          <a:blip r:embed="rId11"/>
+          <p:cNvPr id="13" name="!!ch_f2n" descr="image.png"/>
+          <p:cNvPicPr>
+            <a:picLocks noChangeAspect="1"/>
+          </p:cNvPicPr>
+          <p:nvPr/>
+        </p:nvPicPr>
+        <p:blipFill>
+          <a:blip r:embed="rId12"/>
           <a:stretch>
             <a:fillRect/>
           </a:stretch>
@@ -38108,14 +38516,14 @@
       </p:pic>
       <p:pic>
         <p:nvPicPr>
-          <p:cNvPr id="13" name="!!ch_f2l0" descr="image.png"/>
-          <p:cNvPicPr>
-            <a:picLocks noChangeAspect="1"/>
-          </p:cNvPicPr>
-          <p:nvPr/>
-        </p:nvPicPr>
-        <p:blipFill>
-          <a:blip r:embed="rId12"/>
+          <p:cNvPr id="14" name="!!ch_f2l0" descr="image.png"/>
+          <p:cNvPicPr>
+            <a:picLocks noChangeAspect="1"/>
+          </p:cNvPicPr>
+          <p:nvPr/>
+        </p:nvPicPr>
+        <p:blipFill>
+          <a:blip r:embed="rId13"/>
           <a:stretch>
             <a:fillRect/>
           </a:stretch>
@@ -38132,14 +38540,14 @@
       </p:pic>
       <p:pic>
         <p:nvPicPr>
-          <p:cNvPr id="14" name="!!ch_f2b0" descr="image.png"/>
-          <p:cNvPicPr>
-            <a:picLocks noChangeAspect="1"/>
-          </p:cNvPicPr>
-          <p:nvPr/>
-        </p:nvPicPr>
-        <p:blipFill>
-          <a:blip r:embed="rId13"/>
+          <p:cNvPr id="15" name="!!ch_f2b0" descr="image.png"/>
+          <p:cNvPicPr>
+            <a:picLocks noChangeAspect="1"/>
+          </p:cNvPicPr>
+          <p:nvPr/>
+        </p:nvPicPr>
+        <p:blipFill>
+          <a:blip r:embed="rId14"/>
           <a:stretch>
             <a:fillRect/>
           </a:stretch>
@@ -38156,21 +38564,21 @@
       </p:pic>
       <p:pic>
         <p:nvPicPr>
-          <p:cNvPr id="15" name="!!ch_f2k0" descr="image.png"/>
-          <p:cNvPicPr>
-            <a:picLocks noChangeAspect="1"/>
-          </p:cNvPicPr>
-          <p:nvPr/>
-        </p:nvPicPr>
-        <p:blipFill>
-          <a:blip r:embed="rId14"/>
-          <a:stretch>
-            <a:fillRect/>
-          </a:stretch>
-        </p:blipFill>
-        <p:spPr>
-          <a:xfrm>
-            <a:off x="7734300" y="406400"/>
+          <p:cNvPr id="16" name="!!ch_f2k0" descr="image.png"/>
+          <p:cNvPicPr>
+            <a:picLocks noChangeAspect="1"/>
+          </p:cNvPicPr>
+          <p:nvPr/>
+        </p:nvPicPr>
+        <p:blipFill>
+          <a:blip r:embed="rId15"/>
+          <a:stretch>
+            <a:fillRect/>
+          </a:stretch>
+        </p:blipFill>
+        <p:spPr>
+          <a:xfrm>
+            <a:off x="7658100" y="406400"/>
             <a:ext cx="203200" cy="177800"/>
           </a:xfrm>
           <a:prstGeom prst="rect">
@@ -38180,14 +38588,14 @@
       </p:pic>
       <p:pic>
         <p:nvPicPr>
-          <p:cNvPr id="16" name="!!ch_f2l1" descr="image.png"/>
-          <p:cNvPicPr>
-            <a:picLocks noChangeAspect="1"/>
-          </p:cNvPicPr>
-          <p:nvPr/>
-        </p:nvPicPr>
-        <p:blipFill>
-          <a:blip r:embed="rId15"/>
+          <p:cNvPr id="17" name="!!ch_f2l1" descr="image.png"/>
+          <p:cNvPicPr>
+            <a:picLocks noChangeAspect="1"/>
+          </p:cNvPicPr>
+          <p:nvPr/>
+        </p:nvPicPr>
+        <p:blipFill>
+          <a:blip r:embed="rId16"/>
           <a:stretch>
             <a:fillRect/>
           </a:stretch>
@@ -38204,14 +38612,14 @@
       </p:pic>
       <p:pic>
         <p:nvPicPr>
-          <p:cNvPr id="17" name="!!ch_f2b1" descr="image.png"/>
-          <p:cNvPicPr>
-            <a:picLocks noChangeAspect="1"/>
-          </p:cNvPicPr>
-          <p:nvPr/>
-        </p:nvPicPr>
-        <p:blipFill>
-          <a:blip r:embed="rId16"/>
+          <p:cNvPr id="18" name="!!ch_f2b1" descr="image.png"/>
+          <p:cNvPicPr>
+            <a:picLocks noChangeAspect="1"/>
+          </p:cNvPicPr>
+          <p:nvPr/>
+        </p:nvPicPr>
+        <p:blipFill>
+          <a:blip r:embed="rId17"/>
           <a:stretch>
             <a:fillRect/>
           </a:stretch>
@@ -38228,21 +38636,21 @@
       </p:pic>
       <p:pic>
         <p:nvPicPr>
-          <p:cNvPr id="18" name="!!ch_f2k1" descr="image.png"/>
-          <p:cNvPicPr>
-            <a:picLocks noChangeAspect="1"/>
-          </p:cNvPicPr>
-          <p:nvPr/>
-        </p:nvPicPr>
-        <p:blipFill>
-          <a:blip r:embed="rId14"/>
-          <a:stretch>
-            <a:fillRect/>
-          </a:stretch>
-        </p:blipFill>
-        <p:spPr>
-          <a:xfrm>
-            <a:off x="7734300" y="749300"/>
+          <p:cNvPr id="19" name="!!ch_f2k1" descr="image.png"/>
+          <p:cNvPicPr>
+            <a:picLocks noChangeAspect="1"/>
+          </p:cNvPicPr>
+          <p:nvPr/>
+        </p:nvPicPr>
+        <p:blipFill>
+          <a:blip r:embed="rId15"/>
+          <a:stretch>
+            <a:fillRect/>
+          </a:stretch>
+        </p:blipFill>
+        <p:spPr>
+          <a:xfrm>
+            <a:off x="6197600" y="749300"/>
             <a:ext cx="203200" cy="177800"/>
           </a:xfrm>
           <a:prstGeom prst="rect">
@@ -38252,14 +38660,14 @@
       </p:pic>
       <p:pic>
         <p:nvPicPr>
-          <p:cNvPr id="19" name="!!ch_f2l2" descr="image.png"/>
-          <p:cNvPicPr>
-            <a:picLocks noChangeAspect="1"/>
-          </p:cNvPicPr>
-          <p:nvPr/>
-        </p:nvPicPr>
-        <p:blipFill>
-          <a:blip r:embed="rId17"/>
+          <p:cNvPr id="20" name="!!ch_f2l2" descr="image.png"/>
+          <p:cNvPicPr>
+            <a:picLocks noChangeAspect="1"/>
+          </p:cNvPicPr>
+          <p:nvPr/>
+        </p:nvPicPr>
+        <p:blipFill>
+          <a:blip r:embed="rId18"/>
           <a:stretch>
             <a:fillRect/>
           </a:stretch>
@@ -38276,14 +38684,14 @@
       </p:pic>
       <p:pic>
         <p:nvPicPr>
-          <p:cNvPr id="20" name="!!ch_f2b2" descr="image.png"/>
-          <p:cNvPicPr>
-            <a:picLocks noChangeAspect="1"/>
-          </p:cNvPicPr>
-          <p:nvPr/>
-        </p:nvPicPr>
-        <p:blipFill>
-          <a:blip r:embed="rId18"/>
+          <p:cNvPr id="21" name="!!ch_f2b2" descr="image.png"/>
+          <p:cNvPicPr>
+            <a:picLocks noChangeAspect="1"/>
+          </p:cNvPicPr>
+          <p:nvPr/>
+        </p:nvPicPr>
+        <p:blipFill>
+          <a:blip r:embed="rId19"/>
           <a:stretch>
             <a:fillRect/>
           </a:stretch>
@@ -38300,21 +38708,21 @@
       </p:pic>
       <p:pic>
         <p:nvPicPr>
-          <p:cNvPr id="21" name="!!ch_f2k2" descr="image.png"/>
-          <p:cNvPicPr>
-            <a:picLocks noChangeAspect="1"/>
-          </p:cNvPicPr>
-          <p:nvPr/>
-        </p:nvPicPr>
-        <p:blipFill>
-          <a:blip r:embed="rId14"/>
-          <a:stretch>
-            <a:fillRect/>
-          </a:stretch>
-        </p:blipFill>
-        <p:spPr>
-          <a:xfrm>
-            <a:off x="7734300" y="1092200"/>
+          <p:cNvPr id="22" name="!!ch_f2k2" descr="image.png"/>
+          <p:cNvPicPr>
+            <a:picLocks noChangeAspect="1"/>
+          </p:cNvPicPr>
+          <p:nvPr/>
+        </p:nvPicPr>
+        <p:blipFill>
+          <a:blip r:embed="rId15"/>
+          <a:stretch>
+            <a:fillRect/>
+          </a:stretch>
+        </p:blipFill>
+        <p:spPr>
+          <a:xfrm>
+            <a:off x="6007100" y="1092200"/>
             <a:ext cx="203200" cy="177800"/>
           </a:xfrm>
           <a:prstGeom prst="rect">
@@ -38324,14 +38732,14 @@
       </p:pic>
       <p:pic>
         <p:nvPicPr>
-          <p:cNvPr id="22" name="!!ch_f2l3" descr="image.png"/>
-          <p:cNvPicPr>
-            <a:picLocks noChangeAspect="1"/>
-          </p:cNvPicPr>
-          <p:nvPr/>
-        </p:nvPicPr>
-        <p:blipFill>
-          <a:blip r:embed="rId19"/>
+          <p:cNvPr id="23" name="!!ch_f2l3" descr="image.png"/>
+          <p:cNvPicPr>
+            <a:picLocks noChangeAspect="1"/>
+          </p:cNvPicPr>
+          <p:nvPr/>
+        </p:nvPicPr>
+        <p:blipFill>
+          <a:blip r:embed="rId20"/>
           <a:stretch>
             <a:fillRect/>
           </a:stretch>
@@ -38348,14 +38756,14 @@
       </p:pic>
       <p:pic>
         <p:nvPicPr>
-          <p:cNvPr id="23" name="!!ch_f2b3" descr="image.png"/>
-          <p:cNvPicPr>
-            <a:picLocks noChangeAspect="1"/>
-          </p:cNvPicPr>
-          <p:nvPr/>
-        </p:nvPicPr>
-        <p:blipFill>
-          <a:blip r:embed="rId20"/>
+          <p:cNvPr id="24" name="!!ch_f2b3" descr="image.png"/>
+          <p:cNvPicPr>
+            <a:picLocks noChangeAspect="1"/>
+          </p:cNvPicPr>
+          <p:nvPr/>
+        </p:nvPicPr>
+        <p:blipFill>
+          <a:blip r:embed="rId21"/>
           <a:stretch>
             <a:fillRect/>
           </a:stretch>
@@ -38372,21 +38780,21 @@
       </p:pic>
       <p:pic>
         <p:nvPicPr>
-          <p:cNvPr id="24" name="!!ch_f2k3" descr="image.png"/>
-          <p:cNvPicPr>
-            <a:picLocks noChangeAspect="1"/>
-          </p:cNvPicPr>
-          <p:nvPr/>
-        </p:nvPicPr>
-        <p:blipFill>
-          <a:blip r:embed="rId14"/>
-          <a:stretch>
-            <a:fillRect/>
-          </a:stretch>
-        </p:blipFill>
-        <p:spPr>
-          <a:xfrm>
-            <a:off x="7734300" y="1435100"/>
+          <p:cNvPr id="25" name="!!ch_f2k3" descr="image.png"/>
+          <p:cNvPicPr>
+            <a:picLocks noChangeAspect="1"/>
+          </p:cNvPicPr>
+          <p:nvPr/>
+        </p:nvPicPr>
+        <p:blipFill>
+          <a:blip r:embed="rId15"/>
+          <a:stretch>
+            <a:fillRect/>
+          </a:stretch>
+        </p:blipFill>
+        <p:spPr>
+          <a:xfrm>
+            <a:off x="5499100" y="1435100"/>
             <a:ext cx="203200" cy="177800"/>
           </a:xfrm>
           <a:prstGeom prst="rect">
@@ -38396,14 +38804,14 @@
       </p:pic>
       <p:pic>
         <p:nvPicPr>
-          <p:cNvPr id="25" name="!!ch_f2l4" descr="image.png"/>
-          <p:cNvPicPr>
-            <a:picLocks noChangeAspect="1"/>
-          </p:cNvPicPr>
-          <p:nvPr/>
-        </p:nvPicPr>
-        <p:blipFill>
-          <a:blip r:embed="rId21"/>
+          <p:cNvPr id="26" name="!!ch_f2l4" descr="image.png"/>
+          <p:cNvPicPr>
+            <a:picLocks noChangeAspect="1"/>
+          </p:cNvPicPr>
+          <p:nvPr/>
+        </p:nvPicPr>
+        <p:blipFill>
+          <a:blip r:embed="rId22"/>
           <a:stretch>
             <a:fillRect/>
           </a:stretch>
@@ -38420,14 +38828,14 @@
       </p:pic>
       <p:pic>
         <p:nvPicPr>
-          <p:cNvPr id="26" name="!!ch_f2b4" descr="image.png"/>
-          <p:cNvPicPr>
-            <a:picLocks noChangeAspect="1"/>
-          </p:cNvPicPr>
-          <p:nvPr/>
-        </p:nvPicPr>
-        <p:blipFill>
-          <a:blip r:embed="rId22"/>
+          <p:cNvPr id="27" name="!!ch_f2b4" descr="image.png"/>
+          <p:cNvPicPr>
+            <a:picLocks noChangeAspect="1"/>
+          </p:cNvPicPr>
+          <p:nvPr/>
+        </p:nvPicPr>
+        <p:blipFill>
+          <a:blip r:embed="rId23"/>
           <a:stretch>
             <a:fillRect/>
           </a:stretch>
@@ -38444,21 +38852,21 @@
       </p:pic>
       <p:pic>
         <p:nvPicPr>
-          <p:cNvPr id="27" name="!!ch_f2k4" descr="image.png"/>
-          <p:cNvPicPr>
-            <a:picLocks noChangeAspect="1"/>
-          </p:cNvPicPr>
-          <p:nvPr/>
-        </p:nvPicPr>
-        <p:blipFill>
-          <a:blip r:embed="rId14"/>
-          <a:stretch>
-            <a:fillRect/>
-          </a:stretch>
-        </p:blipFill>
-        <p:spPr>
-          <a:xfrm>
-            <a:off x="7734300" y="1778000"/>
+          <p:cNvPr id="28" name="!!ch_f2k4" descr="image.png"/>
+          <p:cNvPicPr>
+            <a:picLocks noChangeAspect="1"/>
+          </p:cNvPicPr>
+          <p:nvPr/>
+        </p:nvPicPr>
+        <p:blipFill>
+          <a:blip r:embed="rId15"/>
+          <a:stretch>
+            <a:fillRect/>
+          </a:stretch>
+        </p:blipFill>
+        <p:spPr>
+          <a:xfrm>
+            <a:off x="5181600" y="1778000"/>
             <a:ext cx="203200" cy="177800"/>
           </a:xfrm>
           <a:prstGeom prst="rect">
@@ -38468,14 +38876,14 @@
       </p:pic>
       <p:pic>
         <p:nvPicPr>
-          <p:cNvPr id="28" name="!!ch_f2l5" descr="image.png"/>
-          <p:cNvPicPr>
-            <a:picLocks noChangeAspect="1"/>
-          </p:cNvPicPr>
-          <p:nvPr/>
-        </p:nvPicPr>
-        <p:blipFill>
-          <a:blip r:embed="rId23"/>
+          <p:cNvPr id="29" name="!!ch_f2l5" descr="image.png"/>
+          <p:cNvPicPr>
+            <a:picLocks noChangeAspect="1"/>
+          </p:cNvPicPr>
+          <p:nvPr/>
+        </p:nvPicPr>
+        <p:blipFill>
+          <a:blip r:embed="rId24"/>
           <a:stretch>
             <a:fillRect/>
           </a:stretch>
@@ -38492,14 +38900,14 @@
       </p:pic>
       <p:pic>
         <p:nvPicPr>
-          <p:cNvPr id="29" name="!!ch_f2b5" descr="image.png"/>
-          <p:cNvPicPr>
-            <a:picLocks noChangeAspect="1"/>
-          </p:cNvPicPr>
-          <p:nvPr/>
-        </p:nvPicPr>
-        <p:blipFill>
-          <a:blip r:embed="rId24"/>
+          <p:cNvPr id="30" name="!!ch_f2b5" descr="image.png"/>
+          <p:cNvPicPr>
+            <a:picLocks noChangeAspect="1"/>
+          </p:cNvPicPr>
+          <p:nvPr/>
+        </p:nvPicPr>
+        <p:blipFill>
+          <a:blip r:embed="rId25"/>
           <a:stretch>
             <a:fillRect/>
           </a:stretch>
@@ -38516,21 +38924,21 @@
       </p:pic>
       <p:pic>
         <p:nvPicPr>
-          <p:cNvPr id="30" name="!!ch_f2k5" descr="image.png"/>
-          <p:cNvPicPr>
-            <a:picLocks noChangeAspect="1"/>
-          </p:cNvPicPr>
-          <p:nvPr/>
-        </p:nvPicPr>
-        <p:blipFill>
-          <a:blip r:embed="rId14"/>
-          <a:stretch>
-            <a:fillRect/>
-          </a:stretch>
-        </p:blipFill>
-        <p:spPr>
-          <a:xfrm>
-            <a:off x="7734300" y="2120900"/>
+          <p:cNvPr id="31" name="!!ch_f2k5" descr="image.png"/>
+          <p:cNvPicPr>
+            <a:picLocks noChangeAspect="1"/>
+          </p:cNvPicPr>
+          <p:nvPr/>
+        </p:nvPicPr>
+        <p:blipFill>
+          <a:blip r:embed="rId15"/>
+          <a:stretch>
+            <a:fillRect/>
+          </a:stretch>
+        </p:blipFill>
+        <p:spPr>
+          <a:xfrm>
+            <a:off x="4927600" y="2120900"/>
             <a:ext cx="203200" cy="177800"/>
           </a:xfrm>
           <a:prstGeom prst="rect">
@@ -38540,14 +38948,14 @@
       </p:pic>
       <p:pic>
         <p:nvPicPr>
-          <p:cNvPr id="31" name="!!ch_f2l6" descr="image.png"/>
-          <p:cNvPicPr>
-            <a:picLocks noChangeAspect="1"/>
-          </p:cNvPicPr>
-          <p:nvPr/>
-        </p:nvPicPr>
-        <p:blipFill>
-          <a:blip r:embed="rId25"/>
+          <p:cNvPr id="32" name="!!ch_f2l6" descr="image.png"/>
+          <p:cNvPicPr>
+            <a:picLocks noChangeAspect="1"/>
+          </p:cNvPicPr>
+          <p:nvPr/>
+        </p:nvPicPr>
+        <p:blipFill>
+          <a:blip r:embed="rId26"/>
           <a:stretch>
             <a:fillRect/>
           </a:stretch>
@@ -38564,14 +38972,14 @@
       </p:pic>
       <p:pic>
         <p:nvPicPr>
-          <p:cNvPr id="32" name="!!ch_f2b6" descr="image.png"/>
-          <p:cNvPicPr>
-            <a:picLocks noChangeAspect="1"/>
-          </p:cNvPicPr>
-          <p:nvPr/>
-        </p:nvPicPr>
-        <p:blipFill>
-          <a:blip r:embed="rId24"/>
+          <p:cNvPr id="33" name="!!ch_f2b6" descr="image.png"/>
+          <p:cNvPicPr>
+            <a:picLocks noChangeAspect="1"/>
+          </p:cNvPicPr>
+          <p:nvPr/>
+        </p:nvPicPr>
+        <p:blipFill>
+          <a:blip r:embed="rId25"/>
           <a:stretch>
             <a:fillRect/>
           </a:stretch>
@@ -38588,21 +38996,21 @@
       </p:pic>
       <p:pic>
         <p:nvPicPr>
-          <p:cNvPr id="33" name="!!ch_f2k6" descr="image.png"/>
-          <p:cNvPicPr>
-            <a:picLocks noChangeAspect="1"/>
-          </p:cNvPicPr>
-          <p:nvPr/>
-        </p:nvPicPr>
-        <p:blipFill>
-          <a:blip r:embed="rId14"/>
-          <a:stretch>
-            <a:fillRect/>
-          </a:stretch>
-        </p:blipFill>
-        <p:spPr>
-          <a:xfrm>
-            <a:off x="7734300" y="2463800"/>
+          <p:cNvPr id="34" name="!!ch_f2k6" descr="image.png"/>
+          <p:cNvPicPr>
+            <a:picLocks noChangeAspect="1"/>
+          </p:cNvPicPr>
+          <p:nvPr/>
+        </p:nvPicPr>
+        <p:blipFill>
+          <a:blip r:embed="rId15"/>
+          <a:stretch>
+            <a:fillRect/>
+          </a:stretch>
+        </p:blipFill>
+        <p:spPr>
+          <a:xfrm>
+            <a:off x="4927600" y="2463800"/>
             <a:ext cx="203200" cy="177800"/>
           </a:xfrm>
           <a:prstGeom prst="rect">
@@ -38612,14 +39020,14 @@
       </p:pic>
       <p:pic>
         <p:nvPicPr>
-          <p:cNvPr id="34" name="!!ch_f2l7" descr="image.png"/>
-          <p:cNvPicPr>
-            <a:picLocks noChangeAspect="1"/>
-          </p:cNvPicPr>
-          <p:nvPr/>
-        </p:nvPicPr>
-        <p:blipFill>
-          <a:blip r:embed="rId26"/>
+          <p:cNvPr id="35" name="!!ch_f2l7" descr="image.png"/>
+          <p:cNvPicPr>
+            <a:picLocks noChangeAspect="1"/>
+          </p:cNvPicPr>
+          <p:nvPr/>
+        </p:nvPicPr>
+        <p:blipFill>
+          <a:blip r:embed="rId27"/>
           <a:stretch>
             <a:fillRect/>
           </a:stretch>
@@ -38636,14 +39044,14 @@
       </p:pic>
       <p:pic>
         <p:nvPicPr>
-          <p:cNvPr id="35" name="!!ch_f2b7" descr="image.png"/>
-          <p:cNvPicPr>
-            <a:picLocks noChangeAspect="1"/>
-          </p:cNvPicPr>
-          <p:nvPr/>
-        </p:nvPicPr>
-        <p:blipFill>
-          <a:blip r:embed="rId27"/>
+          <p:cNvPr id="36" name="!!ch_f2b7" descr="image.png"/>
+          <p:cNvPicPr>
+            <a:picLocks noChangeAspect="1"/>
+          </p:cNvPicPr>
+          <p:nvPr/>
+        </p:nvPicPr>
+        <p:blipFill>
+          <a:blip r:embed="rId28"/>
           <a:stretch>
             <a:fillRect/>
           </a:stretch>
@@ -38660,14 +39068,14 @@
       </p:pic>
       <p:pic>
         <p:nvPicPr>
-          <p:cNvPr id="36" name="!!ch_f2l8" descr="image.png"/>
-          <p:cNvPicPr>
-            <a:picLocks noChangeAspect="1"/>
-          </p:cNvPicPr>
-          <p:nvPr/>
-        </p:nvPicPr>
-        <p:blipFill>
-          <a:blip r:embed="rId28"/>
+          <p:cNvPr id="37" name="!!ch_f2l8" descr="image.png"/>
+          <p:cNvPicPr>
+            <a:picLocks noChangeAspect="1"/>
+          </p:cNvPicPr>
+          <p:nvPr/>
+        </p:nvPicPr>
+        <p:blipFill>
+          <a:blip r:embed="rId29"/>
           <a:stretch>
             <a:fillRect/>
           </a:stretch>
@@ -38684,14 +39092,14 @@
       </p:pic>
       <p:pic>
         <p:nvPicPr>
-          <p:cNvPr id="37" name="!!ch_f2b8" descr="image.png"/>
-          <p:cNvPicPr>
-            <a:picLocks noChangeAspect="1"/>
-          </p:cNvPicPr>
-          <p:nvPr/>
-        </p:nvPicPr>
-        <p:blipFill>
-          <a:blip r:embed="rId29"/>
+          <p:cNvPr id="38" name="!!ch_f2b8" descr="image.png"/>
+          <p:cNvPicPr>
+            <a:picLocks noChangeAspect="1"/>
+          </p:cNvPicPr>
+          <p:nvPr/>
+        </p:nvPicPr>
+        <p:blipFill>
+          <a:blip r:embed="rId30"/>
           <a:stretch>
             <a:fillRect/>
           </a:stretch>
@@ -38708,21 +39116,21 @@
       </p:pic>
       <p:pic>
         <p:nvPicPr>
-          <p:cNvPr id="38" name="!!ch_f2k8" descr="image.png"/>
-          <p:cNvPicPr>
-            <a:picLocks noChangeAspect="1"/>
-          </p:cNvPicPr>
-          <p:nvPr/>
-        </p:nvPicPr>
-        <p:blipFill>
-          <a:blip r:embed="rId14"/>
-          <a:stretch>
-            <a:fillRect/>
-          </a:stretch>
-        </p:blipFill>
-        <p:spPr>
-          <a:xfrm>
-            <a:off x="7734300" y="3149600"/>
+          <p:cNvPr id="39" name="!!ch_f2k8" descr="image.png"/>
+          <p:cNvPicPr>
+            <a:picLocks noChangeAspect="1"/>
+          </p:cNvPicPr>
+          <p:nvPr/>
+        </p:nvPicPr>
+        <p:blipFill>
+          <a:blip r:embed="rId15"/>
+          <a:stretch>
+            <a:fillRect/>
+          </a:stretch>
+        </p:blipFill>
+        <p:spPr>
+          <a:xfrm>
+            <a:off x="4711700" y="3149600"/>
             <a:ext cx="203200" cy="177800"/>
           </a:xfrm>
           <a:prstGeom prst="rect">
@@ -38732,14 +39140,14 @@
       </p:pic>
       <p:pic>
         <p:nvPicPr>
-          <p:cNvPr id="39" name="!!ch_f2l9" descr="image.png"/>
-          <p:cNvPicPr>
-            <a:picLocks noChangeAspect="1"/>
-          </p:cNvPicPr>
-          <p:nvPr/>
-        </p:nvPicPr>
-        <p:blipFill>
-          <a:blip r:embed="rId30"/>
+          <p:cNvPr id="40" name="!!ch_f2l9" descr="image.png"/>
+          <p:cNvPicPr>
+            <a:picLocks noChangeAspect="1"/>
+          </p:cNvPicPr>
+          <p:nvPr/>
+        </p:nvPicPr>
+        <p:blipFill>
+          <a:blip r:embed="rId31"/>
           <a:stretch>
             <a:fillRect/>
           </a:stretch>
@@ -38756,14 +39164,14 @@
       </p:pic>
       <p:pic>
         <p:nvPicPr>
-          <p:cNvPr id="40" name="!!ch_f2b9" descr="image.png"/>
-          <p:cNvPicPr>
-            <a:picLocks noChangeAspect="1"/>
-          </p:cNvPicPr>
-          <p:nvPr/>
-        </p:nvPicPr>
-        <p:blipFill>
-          <a:blip r:embed="rId31"/>
+          <p:cNvPr id="41" name="!!ch_f2b9" descr="image.png"/>
+          <p:cNvPicPr>
+            <a:picLocks noChangeAspect="1"/>
+          </p:cNvPicPr>
+          <p:nvPr/>
+        </p:nvPicPr>
+        <p:blipFill>
+          <a:blip r:embed="rId32"/>
           <a:stretch>
             <a:fillRect/>
           </a:stretch>
@@ -38780,14 +39188,14 @@
       </p:pic>
       <p:pic>
         <p:nvPicPr>
-          <p:cNvPr id="41" name="!!ch_f2l10" descr="image.png"/>
-          <p:cNvPicPr>
-            <a:picLocks noChangeAspect="1"/>
-          </p:cNvPicPr>
-          <p:nvPr/>
-        </p:nvPicPr>
-        <p:blipFill>
-          <a:blip r:embed="rId32"/>
+          <p:cNvPr id="42" name="!!ch_f2l10" descr="image.png"/>
+          <p:cNvPicPr>
+            <a:picLocks noChangeAspect="1"/>
+          </p:cNvPicPr>
+          <p:nvPr/>
+        </p:nvPicPr>
+        <p:blipFill>
+          <a:blip r:embed="rId33"/>
           <a:stretch>
             <a:fillRect/>
           </a:stretch>
@@ -38804,14 +39212,14 @@
       </p:pic>
       <p:pic>
         <p:nvPicPr>
-          <p:cNvPr id="42" name="!!ch_f2b10" descr="image.png"/>
-          <p:cNvPicPr>
-            <a:picLocks noChangeAspect="1"/>
-          </p:cNvPicPr>
-          <p:nvPr/>
-        </p:nvPicPr>
-        <p:blipFill>
-          <a:blip r:embed="rId31"/>
+          <p:cNvPr id="43" name="!!ch_f2b10" descr="image.png"/>
+          <p:cNvPicPr>
+            <a:picLocks noChangeAspect="1"/>
+          </p:cNvPicPr>
+          <p:nvPr/>
+        </p:nvPicPr>
+        <p:blipFill>
+          <a:blip r:embed="rId32"/>
           <a:stretch>
             <a:fillRect/>
           </a:stretch>
@@ -38828,14 +39236,14 @@
       </p:pic>
       <p:pic>
         <p:nvPicPr>
-          <p:cNvPr id="43" name="!!ch_f2l11" descr="image.png"/>
-          <p:cNvPicPr>
-            <a:picLocks noChangeAspect="1"/>
-          </p:cNvPicPr>
-          <p:nvPr/>
-        </p:nvPicPr>
-        <p:blipFill>
-          <a:blip r:embed="rId33"/>
+          <p:cNvPr id="44" name="!!ch_f2l11" descr="image.png"/>
+          <p:cNvPicPr>
+            <a:picLocks noChangeAspect="1"/>
+          </p:cNvPicPr>
+          <p:nvPr/>
+        </p:nvPicPr>
+        <p:blipFill>
+          <a:blip r:embed="rId34"/>
           <a:stretch>
             <a:fillRect/>
           </a:stretch>
@@ -38852,14 +39260,14 @@
       </p:pic>
       <p:pic>
         <p:nvPicPr>
-          <p:cNvPr id="44" name="!!ch_f2b11" descr="image.png"/>
-          <p:cNvPicPr>
-            <a:picLocks noChangeAspect="1"/>
-          </p:cNvPicPr>
-          <p:nvPr/>
-        </p:nvPicPr>
-        <p:blipFill>
-          <a:blip r:embed="rId34"/>
+          <p:cNvPr id="45" name="!!ch_f2b11" descr="image.png"/>
+          <p:cNvPicPr>
+            <a:picLocks noChangeAspect="1"/>
+          </p:cNvPicPr>
+          <p:nvPr/>
+        </p:nvPicPr>
+        <p:blipFill>
+          <a:blip r:embed="rId35"/>
           <a:stretch>
             <a:fillRect/>
           </a:stretch>
@@ -38876,14 +39284,14 @@
       </p:pic>
       <p:pic>
         <p:nvPicPr>
-          <p:cNvPr id="45" name="!!ch_f2l12" descr="image.png"/>
-          <p:cNvPicPr>
-            <a:picLocks noChangeAspect="1"/>
-          </p:cNvPicPr>
-          <p:nvPr/>
-        </p:nvPicPr>
-        <p:blipFill>
-          <a:blip r:embed="rId35"/>
+          <p:cNvPr id="46" name="!!ch_f2l12" descr="image.png"/>
+          <p:cNvPicPr>
+            <a:picLocks noChangeAspect="1"/>
+          </p:cNvPicPr>
+          <p:nvPr/>
+        </p:nvPicPr>
+        <p:blipFill>
+          <a:blip r:embed="rId36"/>
           <a:stretch>
             <a:fillRect/>
           </a:stretch>
@@ -38900,14 +39308,14 @@
       </p:pic>
       <p:pic>
         <p:nvPicPr>
-          <p:cNvPr id="46" name="!!ch_f2b12" descr="image.png"/>
-          <p:cNvPicPr>
-            <a:picLocks noChangeAspect="1"/>
-          </p:cNvPicPr>
-          <p:nvPr/>
-        </p:nvPicPr>
-        <p:blipFill>
-          <a:blip r:embed="rId34"/>
+          <p:cNvPr id="47" name="!!ch_f2b12" descr="image.png"/>
+          <p:cNvPicPr>
+            <a:picLocks noChangeAspect="1"/>
+          </p:cNvPicPr>
+          <p:nvPr/>
+        </p:nvPicPr>
+        <p:blipFill>
+          <a:blip r:embed="rId35"/>
           <a:stretch>
             <a:fillRect/>
           </a:stretch>
@@ -38924,14 +39332,14 @@
       </p:pic>
       <p:pic>
         <p:nvPicPr>
-          <p:cNvPr id="47" name="!!ch_f2l13" descr="image.png"/>
-          <p:cNvPicPr>
-            <a:picLocks noChangeAspect="1"/>
-          </p:cNvPicPr>
-          <p:nvPr/>
-        </p:nvPicPr>
-        <p:blipFill>
-          <a:blip r:embed="rId36"/>
+          <p:cNvPr id="48" name="!!ch_f2l13" descr="image.png"/>
+          <p:cNvPicPr>
+            <a:picLocks noChangeAspect="1"/>
+          </p:cNvPicPr>
+          <p:nvPr/>
+        </p:nvPicPr>
+        <p:blipFill>
+          <a:blip r:embed="rId37"/>
           <a:stretch>
             <a:fillRect/>
           </a:stretch>
@@ -38948,14 +39356,14 @@
       </p:pic>
       <p:pic>
         <p:nvPicPr>
-          <p:cNvPr id="48" name="!!ch_f2b13" descr="image.png"/>
-          <p:cNvPicPr>
-            <a:picLocks noChangeAspect="1"/>
-          </p:cNvPicPr>
-          <p:nvPr/>
-        </p:nvPicPr>
-        <p:blipFill>
-          <a:blip r:embed="rId37"/>
+          <p:cNvPr id="49" name="!!ch_f2b13" descr="image.png"/>
+          <p:cNvPicPr>
+            <a:picLocks noChangeAspect="1"/>
+          </p:cNvPicPr>
+          <p:nvPr/>
+        </p:nvPicPr>
+        <p:blipFill>
+          <a:blip r:embed="rId38"/>
           <a:stretch>
             <a:fillRect/>
           </a:stretch>
@@ -38972,14 +39380,14 @@
       </p:pic>
       <p:pic>
         <p:nvPicPr>
-          <p:cNvPr id="49" name="!!ch_f2l14" descr="image.png"/>
-          <p:cNvPicPr>
-            <a:picLocks noChangeAspect="1"/>
-          </p:cNvPicPr>
-          <p:nvPr/>
-        </p:nvPicPr>
-        <p:blipFill>
-          <a:blip r:embed="rId38"/>
+          <p:cNvPr id="50" name="!!ch_f2l14" descr="image.png"/>
+          <p:cNvPicPr>
+            <a:picLocks noChangeAspect="1"/>
+          </p:cNvPicPr>
+          <p:nvPr/>
+        </p:nvPicPr>
+        <p:blipFill>
+          <a:blip r:embed="rId39"/>
           <a:stretch>
             <a:fillRect/>
           </a:stretch>
@@ -38996,14 +39404,14 @@
       </p:pic>
       <p:pic>
         <p:nvPicPr>
-          <p:cNvPr id="50" name="!!ch_f2b14" descr="image.png"/>
-          <p:cNvPicPr>
-            <a:picLocks noChangeAspect="1"/>
-          </p:cNvPicPr>
-          <p:nvPr/>
-        </p:nvPicPr>
-        <p:blipFill>
-          <a:blip r:embed="rId39"/>
+          <p:cNvPr id="51" name="!!ch_f2b14" descr="image.png"/>
+          <p:cNvPicPr>
+            <a:picLocks noChangeAspect="1"/>
+          </p:cNvPicPr>
+          <p:nvPr/>
+        </p:nvPicPr>
+        <p:blipFill>
+          <a:blip r:embed="rId40"/>
           <a:stretch>
             <a:fillRect/>
           </a:stretch>
@@ -39020,14 +39428,14 @@
       </p:pic>
       <p:pic>
         <p:nvPicPr>
-          <p:cNvPr id="51" name="!!ch_f2l15" descr="image.png"/>
-          <p:cNvPicPr>
-            <a:picLocks noChangeAspect="1"/>
-          </p:cNvPicPr>
-          <p:nvPr/>
-        </p:nvPicPr>
-        <p:blipFill>
-          <a:blip r:embed="rId40"/>
+          <p:cNvPr id="52" name="!!ch_f2l15" descr="image.png"/>
+          <p:cNvPicPr>
+            <a:picLocks noChangeAspect="1"/>
+          </p:cNvPicPr>
+          <p:nvPr/>
+        </p:nvPicPr>
+        <p:blipFill>
+          <a:blip r:embed="rId41"/>
           <a:stretch>
             <a:fillRect/>
           </a:stretch>
@@ -39044,14 +39452,14 @@
       </p:pic>
       <p:pic>
         <p:nvPicPr>
-          <p:cNvPr id="52" name="!!ch_f2b15" descr="image.png"/>
-          <p:cNvPicPr>
-            <a:picLocks noChangeAspect="1"/>
-          </p:cNvPicPr>
-          <p:nvPr/>
-        </p:nvPicPr>
-        <p:blipFill>
-          <a:blip r:embed="rId39"/>
+          <p:cNvPr id="53" name="!!ch_f2b15" descr="image.png"/>
+          <p:cNvPicPr>
+            <a:picLocks noChangeAspect="1"/>
+          </p:cNvPicPr>
+          <p:nvPr/>
+        </p:nvPicPr>
+        <p:blipFill>
+          <a:blip r:embed="rId40"/>
           <a:stretch>
             <a:fillRect/>
           </a:stretch>
@@ -39068,21 +39476,21 @@
       </p:pic>
       <p:pic>
         <p:nvPicPr>
-          <p:cNvPr id="53" name="!!ch_f2kk" descr="image.png"/>
-          <p:cNvPicPr>
-            <a:picLocks noChangeAspect="1"/>
-          </p:cNvPicPr>
-          <p:nvPr/>
-        </p:nvPicPr>
-        <p:blipFill>
-          <a:blip r:embed="rId14"/>
-          <a:stretch>
-            <a:fillRect/>
-          </a:stretch>
-        </p:blipFill>
-        <p:spPr>
-          <a:xfrm>
-            <a:off x="6858000" y="5194300"/>
+          <p:cNvPr id="54" name="!!ch_f2kk" descr="image.png"/>
+          <p:cNvPicPr>
+            <a:picLocks noChangeAspect="1"/>
+          </p:cNvPicPr>
+          <p:nvPr/>
+        </p:nvPicPr>
+        <p:blipFill>
+          <a:blip r:embed="rId15"/>
+          <a:stretch>
+            <a:fillRect/>
+          </a:stretch>
+        </p:blipFill>
+        <p:spPr>
+          <a:xfrm>
+            <a:off x="6388100" y="1574800"/>
             <a:ext cx="203200" cy="177800"/>
           </a:xfrm>
           <a:prstGeom prst="rect">
@@ -39092,21 +39500,21 @@
       </p:pic>
       <p:pic>
         <p:nvPicPr>
-          <p:cNvPr id="54" name="!!ch_f2kt" descr="image.png"/>
-          <p:cNvPicPr>
-            <a:picLocks noChangeAspect="1"/>
-          </p:cNvPicPr>
-          <p:nvPr/>
-        </p:nvPicPr>
-        <p:blipFill>
-          <a:blip r:embed="rId41"/>
-          <a:stretch>
-            <a:fillRect/>
-          </a:stretch>
-        </p:blipFill>
-        <p:spPr>
-          <a:xfrm>
-            <a:off x="7137400" y="5143500"/>
+          <p:cNvPr id="55" name="!!ch_f2kt" descr="image.png"/>
+          <p:cNvPicPr>
+            <a:picLocks noChangeAspect="1"/>
+          </p:cNvPicPr>
+          <p:nvPr/>
+        </p:nvPicPr>
+        <p:blipFill>
+          <a:blip r:embed="rId42"/>
+          <a:stretch>
+            <a:fillRect/>
+          </a:stretch>
+        </p:blipFill>
+        <p:spPr>
+          <a:xfrm>
+            <a:off x="6692900" y="1524000"/>
             <a:ext cx="2006600" cy="673100"/>
           </a:xfrm>
           <a:prstGeom prst="rect">
@@ -39116,14 +39524,14 @@
       </p:pic>
       <p:pic>
         <p:nvPicPr>
-          <p:cNvPr id="55" name="!!robot" descr="image.png"/>
-          <p:cNvPicPr>
-            <a:picLocks noChangeAspect="1"/>
-          </p:cNvPicPr>
-          <p:nvPr/>
-        </p:nvPicPr>
-        <p:blipFill>
-          <a:blip r:embed="rId42"/>
+          <p:cNvPr id="56" name="!!robot" descr="image.png"/>
+          <p:cNvPicPr>
+            <a:picLocks noChangeAspect="1"/>
+          </p:cNvPicPr>
+          <p:nvPr/>
+        </p:nvPicPr>
+        <p:blipFill>
+          <a:blip r:embed="rId43"/>
           <a:stretch>
             <a:fillRect/>
           </a:stretch>
@@ -39140,14 +39548,14 @@
       </p:pic>
       <p:pic>
         <p:nvPicPr>
-          <p:cNvPr id="56" name="!!cue" descr="image.png"/>
-          <p:cNvPicPr>
-            <a:picLocks noChangeAspect="1"/>
-          </p:cNvPicPr>
-          <p:nvPr/>
-        </p:nvPicPr>
-        <p:blipFill>
-          <a:blip r:embed="rId43"/>
+          <p:cNvPr id="57" name="!!cue" descr="image.png"/>
+          <p:cNvPicPr>
+            <a:picLocks noChangeAspect="1"/>
+          </p:cNvPicPr>
+          <p:nvPr/>
+        </p:nvPicPr>
+        <p:blipFill>
+          <a:blip r:embed="rId44"/>
           <a:stretch>
             <a:fillRect/>
           </a:stretch>
@@ -39351,8 +39759,8 @@
         </p:blipFill>
         <p:spPr>
           <a:xfrm>
-            <a:off x="952500" y="4699000"/>
-            <a:ext cx="2286000" cy="920750"/>
+            <a:off x="762000" y="4699000"/>
+            <a:ext cx="2698750" cy="1047750"/>
           </a:xfrm>
           <a:prstGeom prst="rect">
             <a:avLst/>
@@ -39376,7 +39784,7 @@
         <p:spPr>
           <a:xfrm>
             <a:off x="3683000" y="4699000"/>
-            <a:ext cx="2286000" cy="920750"/>
+            <a:ext cx="2286000" cy="1047750"/>
           </a:xfrm>
           <a:prstGeom prst="rect">
             <a:avLst/>
@@ -39400,7 +39808,7 @@
         <p:spPr>
           <a:xfrm>
             <a:off x="6413500" y="4699000"/>
-            <a:ext cx="2286000" cy="920750"/>
+            <a:ext cx="2286000" cy="1047750"/>
           </a:xfrm>
           <a:prstGeom prst="rect">
             <a:avLst/>
@@ -39424,7 +39832,7 @@
         <p:spPr>
           <a:xfrm>
             <a:off x="9144000" y="4699000"/>
-            <a:ext cx="2286000" cy="920750"/>
+            <a:ext cx="2286000" cy="1047750"/>
           </a:xfrm>
           <a:prstGeom prst="rect">
             <a:avLst/>

</xml_diff>

<commit_message>
Deck: tinted walls per part, varied robot placement, three-decimal lean values, retest-cutoff gauge labels, single-rung highlight; talk: closing limited to the four reruns
</commit_message>
<xml_diff>
--- a/deck/IPHR_Reproduction.pptx
+++ b/deck/IPHR_Reproduction.pptx
@@ -5368,7 +5368,7 @@
           <a:p/>
           <a:p>
             <a:r>
-              <a:t>NEXT: Every model leans about as strongly as in the paper.</a:t>
+              <a:t>NEXT: Each of the four models we reran leans about as strongly as in the paper.</a:t>
             </a:r>
           </a:p>
         </p:txBody>
@@ -5438,7 +5438,7 @@
           <a:lstStyle/>
           <a:p>
             <a:r>
-              <a:t>Every model leans about as strongly as in the paper.</a:t>
+              <a:t>Each of the four models we reran leans about as strongly as in the paper.</a:t>
             </a:r>
           </a:p>
           <a:p/>
@@ -12133,7 +12133,7 @@
         </p:blipFill>
         <p:spPr>
           <a:xfrm>
-            <a:off x="5016500" y="304800"/>
+            <a:off x="5270500" y="304800"/>
             <a:ext cx="63500" cy="5918200"/>
           </a:xfrm>
           <a:prstGeom prst="rect">
@@ -12157,7 +12157,7 @@
         </p:blipFill>
         <p:spPr>
           <a:xfrm>
-            <a:off x="6223000" y="304800"/>
+            <a:off x="6350000" y="304800"/>
             <a:ext cx="63500" cy="5918200"/>
           </a:xfrm>
           <a:prstGeom prst="rect">
@@ -12181,7 +12181,7 @@
         </p:blipFill>
         <p:spPr>
           <a:xfrm>
-            <a:off x="3746500" y="304800"/>
+            <a:off x="4127500" y="304800"/>
             <a:ext cx="63500" cy="5918200"/>
           </a:xfrm>
           <a:prstGeom prst="rect">
@@ -12253,7 +12253,7 @@
         </p:blipFill>
         <p:spPr>
           <a:xfrm>
-            <a:off x="5168900" y="5842000"/>
+            <a:off x="5422900" y="5842000"/>
             <a:ext cx="457200" cy="254000"/>
           </a:xfrm>
           <a:prstGeom prst="rect">
@@ -12277,7 +12277,7 @@
         </p:blipFill>
         <p:spPr>
           <a:xfrm>
-            <a:off x="6375400" y="5842000"/>
+            <a:off x="6502400" y="5842000"/>
             <a:ext cx="558800" cy="254000"/>
           </a:xfrm>
           <a:prstGeom prst="rect">
@@ -12301,7 +12301,7 @@
         </p:blipFill>
         <p:spPr>
           <a:xfrm>
-            <a:off x="1676400" y="381000"/>
+            <a:off x="2057400" y="381000"/>
             <a:ext cx="1854200" cy="254000"/>
           </a:xfrm>
           <a:prstGeom prst="rect">
@@ -12325,7 +12325,7 @@
         </p:blipFill>
         <p:spPr>
           <a:xfrm>
-            <a:off x="2133600" y="749300"/>
+            <a:off x="2514600" y="749300"/>
             <a:ext cx="1397000" cy="254000"/>
           </a:xfrm>
           <a:prstGeom prst="rect">
@@ -12349,7 +12349,7 @@
         </p:blipFill>
         <p:spPr>
           <a:xfrm>
-            <a:off x="1371600" y="1117600"/>
+            <a:off x="1752600" y="1117600"/>
             <a:ext cx="2159000" cy="254000"/>
           </a:xfrm>
           <a:prstGeom prst="rect">
@@ -12373,7 +12373,7 @@
         </p:blipFill>
         <p:spPr>
           <a:xfrm>
-            <a:off x="2159000" y="1485900"/>
+            <a:off x="2540000" y="1485900"/>
             <a:ext cx="1371600" cy="304800"/>
           </a:xfrm>
           <a:prstGeom prst="rect">
@@ -12397,7 +12397,7 @@
         </p:blipFill>
         <p:spPr>
           <a:xfrm>
-            <a:off x="1498600" y="1854200"/>
+            <a:off x="1879600" y="1854200"/>
             <a:ext cx="2032000" cy="254000"/>
           </a:xfrm>
           <a:prstGeom prst="rect">
@@ -12421,7 +12421,7 @@
         </p:blipFill>
         <p:spPr>
           <a:xfrm>
-            <a:off x="1016000" y="2222500"/>
+            <a:off x="1397000" y="2222500"/>
             <a:ext cx="2514600" cy="254000"/>
           </a:xfrm>
           <a:prstGeom prst="rect">
@@ -12445,7 +12445,7 @@
         </p:blipFill>
         <p:spPr>
           <a:xfrm>
-            <a:off x="1397000" y="2590800"/>
+            <a:off x="1778000" y="2590800"/>
             <a:ext cx="2133600" cy="254000"/>
           </a:xfrm>
           <a:prstGeom prst="rect">
@@ -12469,7 +12469,7 @@
         </p:blipFill>
         <p:spPr>
           <a:xfrm>
-            <a:off x="1828800" y="2959100"/>
+            <a:off x="2209800" y="2959100"/>
             <a:ext cx="1701800" cy="254000"/>
           </a:xfrm>
           <a:prstGeom prst="rect">
@@ -12493,7 +12493,7 @@
         </p:blipFill>
         <p:spPr>
           <a:xfrm>
-            <a:off x="1447800" y="3327400"/>
+            <a:off x="1828800" y="3327400"/>
             <a:ext cx="2082800" cy="304800"/>
           </a:xfrm>
           <a:prstGeom prst="rect">
@@ -12517,7 +12517,7 @@
         </p:blipFill>
         <p:spPr>
           <a:xfrm>
-            <a:off x="1651000" y="3695700"/>
+            <a:off x="2032000" y="3695700"/>
             <a:ext cx="1879600" cy="254000"/>
           </a:xfrm>
           <a:prstGeom prst="rect">
@@ -12541,7 +12541,7 @@
         </p:blipFill>
         <p:spPr>
           <a:xfrm>
-            <a:off x="1320800" y="4064000"/>
+            <a:off x="1701800" y="4064000"/>
             <a:ext cx="2209800" cy="254000"/>
           </a:xfrm>
           <a:prstGeom prst="rect">
@@ -12565,7 +12565,7 @@
         </p:blipFill>
         <p:spPr>
           <a:xfrm>
-            <a:off x="1549400" y="4432300"/>
+            <a:off x="1930400" y="4432300"/>
             <a:ext cx="1981200" cy="304800"/>
           </a:xfrm>
           <a:prstGeom prst="rect">
@@ -12589,7 +12589,7 @@
         </p:blipFill>
         <p:spPr>
           <a:xfrm>
-            <a:off x="990600" y="4800600"/>
+            <a:off x="1371600" y="4800600"/>
             <a:ext cx="2540000" cy="254000"/>
           </a:xfrm>
           <a:prstGeom prst="rect">
@@ -12613,7 +12613,7 @@
         </p:blipFill>
         <p:spPr>
           <a:xfrm>
-            <a:off x="1168400" y="5168900"/>
+            <a:off x="1549400" y="5168900"/>
             <a:ext cx="2362200" cy="254000"/>
           </a:xfrm>
           <a:prstGeom prst="rect">
@@ -12637,7 +12637,7 @@
         </p:blipFill>
         <p:spPr>
           <a:xfrm>
-            <a:off x="1270000" y="5537200"/>
+            <a:off x="1651000" y="5537200"/>
             <a:ext cx="2260600" cy="254000"/>
           </a:xfrm>
           <a:prstGeom prst="rect">
@@ -12661,7 +12661,7 @@
         </p:blipFill>
         <p:spPr>
           <a:xfrm>
-            <a:off x="1447800" y="5905500"/>
+            <a:off x="1828800" y="5905500"/>
             <a:ext cx="2082800" cy="254000"/>
           </a:xfrm>
           <a:prstGeom prst="rect">
@@ -12843,7 +12843,7 @@
         </p:blipFill>
         <p:spPr>
           <a:xfrm>
-            <a:off x="5016500" y="304800"/>
+            <a:off x="5270500" y="304800"/>
             <a:ext cx="63500" cy="5918200"/>
           </a:xfrm>
           <a:prstGeom prst="rect">
@@ -12867,7 +12867,7 @@
         </p:blipFill>
         <p:spPr>
           <a:xfrm>
-            <a:off x="6223000" y="304800"/>
+            <a:off x="6350000" y="304800"/>
             <a:ext cx="63500" cy="5918200"/>
           </a:xfrm>
           <a:prstGeom prst="rect">
@@ -12891,7 +12891,7 @@
         </p:blipFill>
         <p:spPr>
           <a:xfrm>
-            <a:off x="3746500" y="304800"/>
+            <a:off x="4127500" y="304800"/>
             <a:ext cx="63500" cy="5918200"/>
           </a:xfrm>
           <a:prstGeom prst="rect">
@@ -12963,7 +12963,7 @@
         </p:blipFill>
         <p:spPr>
           <a:xfrm>
-            <a:off x="5168900" y="5842000"/>
+            <a:off x="5422900" y="5842000"/>
             <a:ext cx="457200" cy="254000"/>
           </a:xfrm>
           <a:prstGeom prst="rect">
@@ -12987,7 +12987,7 @@
         </p:blipFill>
         <p:spPr>
           <a:xfrm>
-            <a:off x="6375400" y="5842000"/>
+            <a:off x="6502400" y="5842000"/>
             <a:ext cx="558800" cy="254000"/>
           </a:xfrm>
           <a:prstGeom prst="rect">
@@ -13035,7 +13035,7 @@
         </p:blipFill>
         <p:spPr>
           <a:xfrm>
-            <a:off x="1676400" y="381000"/>
+            <a:off x="2057400" y="381000"/>
             <a:ext cx="1854200" cy="254000"/>
           </a:xfrm>
           <a:prstGeom prst="rect">
@@ -13059,8 +13059,8 @@
         </p:blipFill>
         <p:spPr>
           <a:xfrm>
-            <a:off x="3810000" y="406400"/>
-            <a:ext cx="3238500" cy="190500"/>
+            <a:off x="4191000" y="406400"/>
+            <a:ext cx="2921000" cy="190500"/>
           </a:xfrm>
           <a:prstGeom prst="rect">
             <a:avLst/>
@@ -13083,7 +13083,7 @@
         </p:blipFill>
         <p:spPr>
           <a:xfrm>
-            <a:off x="2133600" y="749300"/>
+            <a:off x="2514600" y="749300"/>
             <a:ext cx="1397000" cy="254000"/>
           </a:xfrm>
           <a:prstGeom prst="rect">
@@ -13107,8 +13107,8 @@
         </p:blipFill>
         <p:spPr>
           <a:xfrm>
-            <a:off x="3810000" y="774700"/>
-            <a:ext cx="1778000" cy="190500"/>
+            <a:off x="4191000" y="774700"/>
+            <a:ext cx="1587500" cy="190500"/>
           </a:xfrm>
           <a:prstGeom prst="rect">
             <a:avLst/>
@@ -13131,7 +13131,7 @@
         </p:blipFill>
         <p:spPr>
           <a:xfrm>
-            <a:off x="1371600" y="1117600"/>
+            <a:off x="1752600" y="1117600"/>
             <a:ext cx="2159000" cy="254000"/>
           </a:xfrm>
           <a:prstGeom prst="rect">
@@ -13155,8 +13155,8 @@
         </p:blipFill>
         <p:spPr>
           <a:xfrm>
-            <a:off x="3810000" y="1143000"/>
-            <a:ext cx="1587500" cy="190500"/>
+            <a:off x="4191000" y="1143000"/>
+            <a:ext cx="1397000" cy="190500"/>
           </a:xfrm>
           <a:prstGeom prst="rect">
             <a:avLst/>
@@ -13179,7 +13179,7 @@
         </p:blipFill>
         <p:spPr>
           <a:xfrm>
-            <a:off x="2159000" y="1485900"/>
+            <a:off x="2540000" y="1485900"/>
             <a:ext cx="1371600" cy="304800"/>
           </a:xfrm>
           <a:prstGeom prst="rect">
@@ -13203,8 +13203,8 @@
         </p:blipFill>
         <p:spPr>
           <a:xfrm>
-            <a:off x="3810000" y="1511300"/>
-            <a:ext cx="1079500" cy="190500"/>
+            <a:off x="4191000" y="1511300"/>
+            <a:ext cx="952500" cy="190500"/>
           </a:xfrm>
           <a:prstGeom prst="rect">
             <a:avLst/>
@@ -13227,7 +13227,7 @@
         </p:blipFill>
         <p:spPr>
           <a:xfrm>
-            <a:off x="1498600" y="1854200"/>
+            <a:off x="1879600" y="1854200"/>
             <a:ext cx="2032000" cy="254000"/>
           </a:xfrm>
           <a:prstGeom prst="rect">
@@ -13251,8 +13251,8 @@
         </p:blipFill>
         <p:spPr>
           <a:xfrm>
-            <a:off x="3810000" y="1879600"/>
-            <a:ext cx="762000" cy="190500"/>
+            <a:off x="4191000" y="1879600"/>
+            <a:ext cx="698500" cy="190500"/>
           </a:xfrm>
           <a:prstGeom prst="rect">
             <a:avLst/>
@@ -13275,7 +13275,7 @@
         </p:blipFill>
         <p:spPr>
           <a:xfrm>
-            <a:off x="1016000" y="2222500"/>
+            <a:off x="1397000" y="2222500"/>
             <a:ext cx="2514600" cy="254000"/>
           </a:xfrm>
           <a:prstGeom prst="rect">
@@ -13299,8 +13299,8 @@
         </p:blipFill>
         <p:spPr>
           <a:xfrm>
-            <a:off x="3810000" y="2247900"/>
-            <a:ext cx="508000" cy="190500"/>
+            <a:off x="4191000" y="2247900"/>
+            <a:ext cx="444500" cy="190500"/>
           </a:xfrm>
           <a:prstGeom prst="rect">
             <a:avLst/>
@@ -13323,7 +13323,7 @@
         </p:blipFill>
         <p:spPr>
           <a:xfrm>
-            <a:off x="1397000" y="2590800"/>
+            <a:off x="1778000" y="2590800"/>
             <a:ext cx="2133600" cy="254000"/>
           </a:xfrm>
           <a:prstGeom prst="rect">
@@ -13347,8 +13347,8 @@
         </p:blipFill>
         <p:spPr>
           <a:xfrm>
-            <a:off x="3810000" y="2616200"/>
-            <a:ext cx="508000" cy="190500"/>
+            <a:off x="4191000" y="2616200"/>
+            <a:ext cx="444500" cy="190500"/>
           </a:xfrm>
           <a:prstGeom prst="rect">
             <a:avLst/>
@@ -13371,7 +13371,7 @@
         </p:blipFill>
         <p:spPr>
           <a:xfrm>
-            <a:off x="1828800" y="2959100"/>
+            <a:off x="2209800" y="2959100"/>
             <a:ext cx="1701800" cy="254000"/>
           </a:xfrm>
           <a:prstGeom prst="rect">
@@ -13395,8 +13395,8 @@
         </p:blipFill>
         <p:spPr>
           <a:xfrm>
-            <a:off x="3810000" y="2984500"/>
-            <a:ext cx="444500" cy="190500"/>
+            <a:off x="4191000" y="2984500"/>
+            <a:ext cx="381000" cy="190500"/>
           </a:xfrm>
           <a:prstGeom prst="rect">
             <a:avLst/>
@@ -13419,7 +13419,7 @@
         </p:blipFill>
         <p:spPr>
           <a:xfrm>
-            <a:off x="1447800" y="3327400"/>
+            <a:off x="1828800" y="3327400"/>
             <a:ext cx="2082800" cy="304800"/>
           </a:xfrm>
           <a:prstGeom prst="rect">
@@ -13443,8 +13443,8 @@
         </p:blipFill>
         <p:spPr>
           <a:xfrm>
-            <a:off x="3810000" y="3352800"/>
-            <a:ext cx="292100" cy="190500"/>
+            <a:off x="4191000" y="3352800"/>
+            <a:ext cx="266700" cy="190500"/>
           </a:xfrm>
           <a:prstGeom prst="rect">
             <a:avLst/>
@@ -13467,7 +13467,7 @@
         </p:blipFill>
         <p:spPr>
           <a:xfrm>
-            <a:off x="1651000" y="3695700"/>
+            <a:off x="2032000" y="3695700"/>
             <a:ext cx="1879600" cy="254000"/>
           </a:xfrm>
           <a:prstGeom prst="rect">
@@ -13491,8 +13491,8 @@
         </p:blipFill>
         <p:spPr>
           <a:xfrm>
-            <a:off x="3810000" y="3721100"/>
-            <a:ext cx="114300" cy="190500"/>
+            <a:off x="4191000" y="3721100"/>
+            <a:ext cx="101600" cy="190500"/>
           </a:xfrm>
           <a:prstGeom prst="rect">
             <a:avLst/>
@@ -13515,7 +13515,7 @@
         </p:blipFill>
         <p:spPr>
           <a:xfrm>
-            <a:off x="1320800" y="4064000"/>
+            <a:off x="1701800" y="4064000"/>
             <a:ext cx="2209800" cy="254000"/>
           </a:xfrm>
           <a:prstGeom prst="rect">
@@ -13539,8 +13539,8 @@
         </p:blipFill>
         <p:spPr>
           <a:xfrm>
-            <a:off x="3810000" y="4089400"/>
-            <a:ext cx="114300" cy="190500"/>
+            <a:off x="4191000" y="4089400"/>
+            <a:ext cx="101600" cy="190500"/>
           </a:xfrm>
           <a:prstGeom prst="rect">
             <a:avLst/>
@@ -13563,7 +13563,7 @@
         </p:blipFill>
         <p:spPr>
           <a:xfrm>
-            <a:off x="1549400" y="4432300"/>
+            <a:off x="1930400" y="4432300"/>
             <a:ext cx="1981200" cy="304800"/>
           </a:xfrm>
           <a:prstGeom prst="rect">
@@ -13587,8 +13587,8 @@
         </p:blipFill>
         <p:spPr>
           <a:xfrm>
-            <a:off x="3810000" y="4457700"/>
-            <a:ext cx="88900" cy="190500"/>
+            <a:off x="4191000" y="4457700"/>
+            <a:ext cx="76200" cy="190500"/>
           </a:xfrm>
           <a:prstGeom prst="rect">
             <a:avLst/>
@@ -13611,7 +13611,7 @@
         </p:blipFill>
         <p:spPr>
           <a:xfrm>
-            <a:off x="990600" y="4800600"/>
+            <a:off x="1371600" y="4800600"/>
             <a:ext cx="2540000" cy="254000"/>
           </a:xfrm>
           <a:prstGeom prst="rect">
@@ -13635,8 +13635,8 @@
         </p:blipFill>
         <p:spPr>
           <a:xfrm>
-            <a:off x="3810000" y="4826000"/>
-            <a:ext cx="88900" cy="190500"/>
+            <a:off x="4191000" y="4826000"/>
+            <a:ext cx="76200" cy="190500"/>
           </a:xfrm>
           <a:prstGeom prst="rect">
             <a:avLst/>
@@ -13659,7 +13659,7 @@
         </p:blipFill>
         <p:spPr>
           <a:xfrm>
-            <a:off x="1168400" y="5168900"/>
+            <a:off x="1549400" y="5168900"/>
             <a:ext cx="2362200" cy="254000"/>
           </a:xfrm>
           <a:prstGeom prst="rect">
@@ -13683,8 +13683,8 @@
         </p:blipFill>
         <p:spPr>
           <a:xfrm>
-            <a:off x="3810000" y="5194300"/>
-            <a:ext cx="63500" cy="190500"/>
+            <a:off x="4191000" y="5194300"/>
+            <a:ext cx="50800" cy="190500"/>
           </a:xfrm>
           <a:prstGeom prst="rect">
             <a:avLst/>
@@ -13707,7 +13707,7 @@
         </p:blipFill>
         <p:spPr>
           <a:xfrm>
-            <a:off x="1270000" y="5537200"/>
+            <a:off x="1651000" y="5537200"/>
             <a:ext cx="2260600" cy="254000"/>
           </a:xfrm>
           <a:prstGeom prst="rect">
@@ -13731,7 +13731,7 @@
         </p:blipFill>
         <p:spPr>
           <a:xfrm>
-            <a:off x="3810000" y="5562600"/>
+            <a:off x="4191000" y="5562600"/>
             <a:ext cx="38100" cy="190500"/>
           </a:xfrm>
           <a:prstGeom prst="rect">
@@ -13755,7 +13755,7 @@
         </p:blipFill>
         <p:spPr>
           <a:xfrm>
-            <a:off x="1447800" y="5905500"/>
+            <a:off x="1828800" y="5905500"/>
             <a:ext cx="2082800" cy="254000"/>
           </a:xfrm>
           <a:prstGeom prst="rect">
@@ -13779,7 +13779,7 @@
         </p:blipFill>
         <p:spPr>
           <a:xfrm>
-            <a:off x="3810000" y="5930900"/>
+            <a:off x="4191000" y="5930900"/>
             <a:ext cx="38100" cy="190500"/>
           </a:xfrm>
           <a:prstGeom prst="rect">
@@ -13961,7 +13961,7 @@
         </p:blipFill>
         <p:spPr>
           <a:xfrm>
-            <a:off x="5016500" y="304800"/>
+            <a:off x="5270500" y="304800"/>
             <a:ext cx="63500" cy="5918200"/>
           </a:xfrm>
           <a:prstGeom prst="rect">
@@ -13985,7 +13985,7 @@
         </p:blipFill>
         <p:spPr>
           <a:xfrm>
-            <a:off x="6223000" y="304800"/>
+            <a:off x="6350000" y="304800"/>
             <a:ext cx="63500" cy="5918200"/>
           </a:xfrm>
           <a:prstGeom prst="rect">
@@ -14009,7 +14009,7 @@
         </p:blipFill>
         <p:spPr>
           <a:xfrm>
-            <a:off x="3746500" y="304800"/>
+            <a:off x="4127500" y="304800"/>
             <a:ext cx="63500" cy="5918200"/>
           </a:xfrm>
           <a:prstGeom prst="rect">
@@ -14033,7 +14033,7 @@
         </p:blipFill>
         <p:spPr>
           <a:xfrm>
-            <a:off x="1574800" y="355600"/>
+            <a:off x="1955800" y="355600"/>
             <a:ext cx="2082800" cy="292100"/>
           </a:xfrm>
           <a:prstGeom prst="rect">
@@ -14105,7 +14105,7 @@
         </p:blipFill>
         <p:spPr>
           <a:xfrm>
-            <a:off x="5168900" y="5842000"/>
+            <a:off x="5422900" y="5842000"/>
             <a:ext cx="457200" cy="254000"/>
           </a:xfrm>
           <a:prstGeom prst="rect">
@@ -14129,7 +14129,7 @@
         </p:blipFill>
         <p:spPr>
           <a:xfrm>
-            <a:off x="6375400" y="5842000"/>
+            <a:off x="6502400" y="5842000"/>
             <a:ext cx="558800" cy="254000"/>
           </a:xfrm>
           <a:prstGeom prst="rect">
@@ -14177,7 +14177,7 @@
         </p:blipFill>
         <p:spPr>
           <a:xfrm>
-            <a:off x="1676400" y="381000"/>
+            <a:off x="2057400" y="381000"/>
             <a:ext cx="1854200" cy="254000"/>
           </a:xfrm>
           <a:prstGeom prst="rect">
@@ -14201,8 +14201,8 @@
         </p:blipFill>
         <p:spPr>
           <a:xfrm>
-            <a:off x="3810000" y="406400"/>
-            <a:ext cx="3238500" cy="190500"/>
+            <a:off x="4191000" y="406400"/>
+            <a:ext cx="2921000" cy="190500"/>
           </a:xfrm>
           <a:prstGeom prst="rect">
             <a:avLst/>
@@ -14225,8 +14225,8 @@
         </p:blipFill>
         <p:spPr>
           <a:xfrm>
-            <a:off x="7239000" y="812800"/>
-            <a:ext cx="1219200" cy="279400"/>
+            <a:off x="7315200" y="812800"/>
+            <a:ext cx="1016000" cy="279400"/>
           </a:xfrm>
           <a:prstGeom prst="rect">
             <a:avLst/>
@@ -14249,7 +14249,7 @@
         </p:blipFill>
         <p:spPr>
           <a:xfrm>
-            <a:off x="2133600" y="749300"/>
+            <a:off x="2514600" y="749300"/>
             <a:ext cx="1397000" cy="254000"/>
           </a:xfrm>
           <a:prstGeom prst="rect">
@@ -14273,8 +14273,8 @@
         </p:blipFill>
         <p:spPr>
           <a:xfrm>
-            <a:off x="3810000" y="774700"/>
-            <a:ext cx="1778000" cy="190500"/>
+            <a:off x="4191000" y="774700"/>
+            <a:ext cx="1587500" cy="190500"/>
           </a:xfrm>
           <a:prstGeom prst="rect">
             <a:avLst/>
@@ -14297,7 +14297,7 @@
         </p:blipFill>
         <p:spPr>
           <a:xfrm>
-            <a:off x="1371600" y="1117600"/>
+            <a:off x="1752600" y="1117600"/>
             <a:ext cx="2159000" cy="254000"/>
           </a:xfrm>
           <a:prstGeom prst="rect">
@@ -14321,8 +14321,8 @@
         </p:blipFill>
         <p:spPr>
           <a:xfrm>
-            <a:off x="3810000" y="1143000"/>
-            <a:ext cx="1587500" cy="190500"/>
+            <a:off x="4191000" y="1143000"/>
+            <a:ext cx="1397000" cy="190500"/>
           </a:xfrm>
           <a:prstGeom prst="rect">
             <a:avLst/>
@@ -14345,7 +14345,7 @@
         </p:blipFill>
         <p:spPr>
           <a:xfrm>
-            <a:off x="2159000" y="1485900"/>
+            <a:off x="2540000" y="1485900"/>
             <a:ext cx="1371600" cy="304800"/>
           </a:xfrm>
           <a:prstGeom prst="rect">
@@ -14369,8 +14369,8 @@
         </p:blipFill>
         <p:spPr>
           <a:xfrm>
-            <a:off x="3810000" y="1511300"/>
-            <a:ext cx="1079500" cy="190500"/>
+            <a:off x="4191000" y="1511300"/>
+            <a:ext cx="952500" cy="190500"/>
           </a:xfrm>
           <a:prstGeom prst="rect">
             <a:avLst/>
@@ -14393,7 +14393,7 @@
         </p:blipFill>
         <p:spPr>
           <a:xfrm>
-            <a:off x="1498600" y="1854200"/>
+            <a:off x="1879600" y="1854200"/>
             <a:ext cx="2032000" cy="254000"/>
           </a:xfrm>
           <a:prstGeom prst="rect">
@@ -14417,8 +14417,8 @@
         </p:blipFill>
         <p:spPr>
           <a:xfrm>
-            <a:off x="3810000" y="1879600"/>
-            <a:ext cx="762000" cy="190500"/>
+            <a:off x="4191000" y="1879600"/>
+            <a:ext cx="698500" cy="190500"/>
           </a:xfrm>
           <a:prstGeom prst="rect">
             <a:avLst/>
@@ -14441,7 +14441,7 @@
         </p:blipFill>
         <p:spPr>
           <a:xfrm>
-            <a:off x="1016000" y="2222500"/>
+            <a:off x="1397000" y="2222500"/>
             <a:ext cx="2514600" cy="254000"/>
           </a:xfrm>
           <a:prstGeom prst="rect">
@@ -14465,8 +14465,8 @@
         </p:blipFill>
         <p:spPr>
           <a:xfrm>
-            <a:off x="3810000" y="2247900"/>
-            <a:ext cx="508000" cy="190500"/>
+            <a:off x="4191000" y="2247900"/>
+            <a:ext cx="444500" cy="190500"/>
           </a:xfrm>
           <a:prstGeom prst="rect">
             <a:avLst/>
@@ -14489,7 +14489,7 @@
         </p:blipFill>
         <p:spPr>
           <a:xfrm>
-            <a:off x="1397000" y="2590800"/>
+            <a:off x="1778000" y="2590800"/>
             <a:ext cx="2133600" cy="254000"/>
           </a:xfrm>
           <a:prstGeom prst="rect">
@@ -14513,8 +14513,8 @@
         </p:blipFill>
         <p:spPr>
           <a:xfrm>
-            <a:off x="3810000" y="2616200"/>
-            <a:ext cx="508000" cy="190500"/>
+            <a:off x="4191000" y="2616200"/>
+            <a:ext cx="444500" cy="190500"/>
           </a:xfrm>
           <a:prstGeom prst="rect">
             <a:avLst/>
@@ -14537,7 +14537,7 @@
         </p:blipFill>
         <p:spPr>
           <a:xfrm>
-            <a:off x="1828800" y="2959100"/>
+            <a:off x="2209800" y="2959100"/>
             <a:ext cx="1701800" cy="254000"/>
           </a:xfrm>
           <a:prstGeom prst="rect">
@@ -14561,8 +14561,8 @@
         </p:blipFill>
         <p:spPr>
           <a:xfrm>
-            <a:off x="3810000" y="2984500"/>
-            <a:ext cx="444500" cy="190500"/>
+            <a:off x="4191000" y="2984500"/>
+            <a:ext cx="381000" cy="190500"/>
           </a:xfrm>
           <a:prstGeom prst="rect">
             <a:avLst/>
@@ -14585,7 +14585,7 @@
         </p:blipFill>
         <p:spPr>
           <a:xfrm>
-            <a:off x="1447800" y="3327400"/>
+            <a:off x="1828800" y="3327400"/>
             <a:ext cx="2082800" cy="304800"/>
           </a:xfrm>
           <a:prstGeom prst="rect">
@@ -14609,8 +14609,8 @@
         </p:blipFill>
         <p:spPr>
           <a:xfrm>
-            <a:off x="3810000" y="3352800"/>
-            <a:ext cx="292100" cy="190500"/>
+            <a:off x="4191000" y="3352800"/>
+            <a:ext cx="266700" cy="190500"/>
           </a:xfrm>
           <a:prstGeom prst="rect">
             <a:avLst/>
@@ -14633,7 +14633,7 @@
         </p:blipFill>
         <p:spPr>
           <a:xfrm>
-            <a:off x="1651000" y="3695700"/>
+            <a:off x="2032000" y="3695700"/>
             <a:ext cx="1879600" cy="254000"/>
           </a:xfrm>
           <a:prstGeom prst="rect">
@@ -14657,8 +14657,8 @@
         </p:blipFill>
         <p:spPr>
           <a:xfrm>
-            <a:off x="3810000" y="3721100"/>
-            <a:ext cx="114300" cy="190500"/>
+            <a:off x="4191000" y="3721100"/>
+            <a:ext cx="101600" cy="190500"/>
           </a:xfrm>
           <a:prstGeom prst="rect">
             <a:avLst/>
@@ -14681,7 +14681,7 @@
         </p:blipFill>
         <p:spPr>
           <a:xfrm>
-            <a:off x="1320800" y="4064000"/>
+            <a:off x="1701800" y="4064000"/>
             <a:ext cx="2209800" cy="254000"/>
           </a:xfrm>
           <a:prstGeom prst="rect">
@@ -14705,8 +14705,8 @@
         </p:blipFill>
         <p:spPr>
           <a:xfrm>
-            <a:off x="3810000" y="4089400"/>
-            <a:ext cx="114300" cy="190500"/>
+            <a:off x="4191000" y="4089400"/>
+            <a:ext cx="101600" cy="190500"/>
           </a:xfrm>
           <a:prstGeom prst="rect">
             <a:avLst/>
@@ -14729,7 +14729,7 @@
         </p:blipFill>
         <p:spPr>
           <a:xfrm>
-            <a:off x="1549400" y="4432300"/>
+            <a:off x="1930400" y="4432300"/>
             <a:ext cx="1981200" cy="304800"/>
           </a:xfrm>
           <a:prstGeom prst="rect">
@@ -14753,8 +14753,8 @@
         </p:blipFill>
         <p:spPr>
           <a:xfrm>
-            <a:off x="3810000" y="4457700"/>
-            <a:ext cx="88900" cy="190500"/>
+            <a:off x="4191000" y="4457700"/>
+            <a:ext cx="76200" cy="190500"/>
           </a:xfrm>
           <a:prstGeom prst="rect">
             <a:avLst/>
@@ -14777,7 +14777,7 @@
         </p:blipFill>
         <p:spPr>
           <a:xfrm>
-            <a:off x="990600" y="4800600"/>
+            <a:off x="1371600" y="4800600"/>
             <a:ext cx="2540000" cy="254000"/>
           </a:xfrm>
           <a:prstGeom prst="rect">
@@ -14801,8 +14801,8 @@
         </p:blipFill>
         <p:spPr>
           <a:xfrm>
-            <a:off x="3810000" y="4826000"/>
-            <a:ext cx="88900" cy="190500"/>
+            <a:off x="4191000" y="4826000"/>
+            <a:ext cx="76200" cy="190500"/>
           </a:xfrm>
           <a:prstGeom prst="rect">
             <a:avLst/>
@@ -14825,7 +14825,7 @@
         </p:blipFill>
         <p:spPr>
           <a:xfrm>
-            <a:off x="1168400" y="5168900"/>
+            <a:off x="1549400" y="5168900"/>
             <a:ext cx="2362200" cy="254000"/>
           </a:xfrm>
           <a:prstGeom prst="rect">
@@ -14849,8 +14849,8 @@
         </p:blipFill>
         <p:spPr>
           <a:xfrm>
-            <a:off x="3810000" y="5194300"/>
-            <a:ext cx="63500" cy="190500"/>
+            <a:off x="4191000" y="5194300"/>
+            <a:ext cx="50800" cy="190500"/>
           </a:xfrm>
           <a:prstGeom prst="rect">
             <a:avLst/>
@@ -14873,7 +14873,7 @@
         </p:blipFill>
         <p:spPr>
           <a:xfrm>
-            <a:off x="1270000" y="5537200"/>
+            <a:off x="1651000" y="5537200"/>
             <a:ext cx="2260600" cy="254000"/>
           </a:xfrm>
           <a:prstGeom prst="rect">
@@ -14897,7 +14897,7 @@
         </p:blipFill>
         <p:spPr>
           <a:xfrm>
-            <a:off x="3810000" y="5562600"/>
+            <a:off x="4191000" y="5562600"/>
             <a:ext cx="38100" cy="190500"/>
           </a:xfrm>
           <a:prstGeom prst="rect">
@@ -14921,7 +14921,7 @@
         </p:blipFill>
         <p:spPr>
           <a:xfrm>
-            <a:off x="1447800" y="5905500"/>
+            <a:off x="1828800" y="5905500"/>
             <a:ext cx="2082800" cy="254000"/>
           </a:xfrm>
           <a:prstGeom prst="rect">
@@ -14945,7 +14945,7 @@
         </p:blipFill>
         <p:spPr>
           <a:xfrm>
-            <a:off x="3810000" y="5930900"/>
+            <a:off x="4191000" y="5930900"/>
             <a:ext cx="38100" cy="190500"/>
           </a:xfrm>
           <a:prstGeom prst="rect">
@@ -14993,8 +14993,8 @@
         </p:blipFill>
         <p:spPr>
           <a:xfrm>
-            <a:off x="7080250" y="190500"/>
-            <a:ext cx="2349500" cy="4222750"/>
+            <a:off x="7048500" y="190500"/>
+            <a:ext cx="2381250" cy="4222750"/>
           </a:xfrm>
           <a:prstGeom prst="rect">
             <a:avLst/>
@@ -15151,7 +15151,7 @@
         </p:blipFill>
         <p:spPr>
           <a:xfrm>
-            <a:off x="5016500" y="304800"/>
+            <a:off x="5270500" y="304800"/>
             <a:ext cx="63500" cy="5918200"/>
           </a:xfrm>
           <a:prstGeom prst="rect">
@@ -15175,7 +15175,7 @@
         </p:blipFill>
         <p:spPr>
           <a:xfrm>
-            <a:off x="6223000" y="304800"/>
+            <a:off x="6350000" y="304800"/>
             <a:ext cx="63500" cy="5918200"/>
           </a:xfrm>
           <a:prstGeom prst="rect">
@@ -15199,7 +15199,7 @@
         </p:blipFill>
         <p:spPr>
           <a:xfrm>
-            <a:off x="3746500" y="304800"/>
+            <a:off x="4127500" y="304800"/>
             <a:ext cx="63500" cy="5918200"/>
           </a:xfrm>
           <a:prstGeom prst="rect">
@@ -15223,7 +15223,7 @@
         </p:blipFill>
         <p:spPr>
           <a:xfrm>
-            <a:off x="3911600" y="304800"/>
+            <a:off x="4267200" y="304800"/>
             <a:ext cx="63500" cy="6007100"/>
           </a:xfrm>
           <a:prstGeom prst="rect">
@@ -15247,7 +15247,7 @@
         </p:blipFill>
         <p:spPr>
           <a:xfrm>
-            <a:off x="4978400" y="1409700"/>
+            <a:off x="5359400" y="1409700"/>
             <a:ext cx="3073400" cy="393700"/>
           </a:xfrm>
           <a:prstGeom prst="rect">
@@ -15319,7 +15319,7 @@
         </p:blipFill>
         <p:spPr>
           <a:xfrm>
-            <a:off x="5168900" y="5842000"/>
+            <a:off x="5422900" y="5842000"/>
             <a:ext cx="457200" cy="254000"/>
           </a:xfrm>
           <a:prstGeom prst="rect">
@@ -15343,7 +15343,7 @@
         </p:blipFill>
         <p:spPr>
           <a:xfrm>
-            <a:off x="6375400" y="5842000"/>
+            <a:off x="6502400" y="5842000"/>
             <a:ext cx="558800" cy="254000"/>
           </a:xfrm>
           <a:prstGeom prst="rect">
@@ -15391,7 +15391,7 @@
         </p:blipFill>
         <p:spPr>
           <a:xfrm>
-            <a:off x="1676400" y="381000"/>
+            <a:off x="2057400" y="381000"/>
             <a:ext cx="1854200" cy="254000"/>
           </a:xfrm>
           <a:prstGeom prst="rect">
@@ -15415,8 +15415,8 @@
         </p:blipFill>
         <p:spPr>
           <a:xfrm>
-            <a:off x="3810000" y="406400"/>
-            <a:ext cx="3238500" cy="190500"/>
+            <a:off x="4191000" y="406400"/>
+            <a:ext cx="2921000" cy="190500"/>
           </a:xfrm>
           <a:prstGeom prst="rect">
             <a:avLst/>
@@ -15439,7 +15439,7 @@
         </p:blipFill>
         <p:spPr>
           <a:xfrm>
-            <a:off x="2133600" y="749300"/>
+            <a:off x="2514600" y="749300"/>
             <a:ext cx="1397000" cy="254000"/>
           </a:xfrm>
           <a:prstGeom prst="rect">
@@ -15463,8 +15463,8 @@
         </p:blipFill>
         <p:spPr>
           <a:xfrm>
-            <a:off x="3810000" y="774700"/>
-            <a:ext cx="1778000" cy="190500"/>
+            <a:off x="4191000" y="774700"/>
+            <a:ext cx="1587500" cy="190500"/>
           </a:xfrm>
           <a:prstGeom prst="rect">
             <a:avLst/>
@@ -15487,7 +15487,7 @@
         </p:blipFill>
         <p:spPr>
           <a:xfrm>
-            <a:off x="1371600" y="1117600"/>
+            <a:off x="1752600" y="1117600"/>
             <a:ext cx="2159000" cy="254000"/>
           </a:xfrm>
           <a:prstGeom prst="rect">
@@ -15511,8 +15511,8 @@
         </p:blipFill>
         <p:spPr>
           <a:xfrm>
-            <a:off x="3810000" y="1143000"/>
-            <a:ext cx="1587500" cy="190500"/>
+            <a:off x="4191000" y="1143000"/>
+            <a:ext cx="1397000" cy="190500"/>
           </a:xfrm>
           <a:prstGeom prst="rect">
             <a:avLst/>
@@ -15535,7 +15535,7 @@
         </p:blipFill>
         <p:spPr>
           <a:xfrm>
-            <a:off x="1778000" y="1524000"/>
+            <a:off x="2159000" y="1524000"/>
             <a:ext cx="254000" cy="203200"/>
           </a:xfrm>
           <a:prstGeom prst="rect">
@@ -15559,7 +15559,7 @@
         </p:blipFill>
         <p:spPr>
           <a:xfrm>
-            <a:off x="2159000" y="1485900"/>
+            <a:off x="2540000" y="1485900"/>
             <a:ext cx="1371600" cy="304800"/>
           </a:xfrm>
           <a:prstGeom prst="rect">
@@ -15583,8 +15583,8 @@
         </p:blipFill>
         <p:spPr>
           <a:xfrm>
-            <a:off x="3810000" y="1511300"/>
-            <a:ext cx="1079500" cy="190500"/>
+            <a:off x="4191000" y="1511300"/>
+            <a:ext cx="952500" cy="190500"/>
           </a:xfrm>
           <a:prstGeom prst="rect">
             <a:avLst/>
@@ -15607,7 +15607,7 @@
         </p:blipFill>
         <p:spPr>
           <a:xfrm>
-            <a:off x="1498600" y="1854200"/>
+            <a:off x="1879600" y="1854200"/>
             <a:ext cx="2032000" cy="254000"/>
           </a:xfrm>
           <a:prstGeom prst="rect">
@@ -15631,8 +15631,8 @@
         </p:blipFill>
         <p:spPr>
           <a:xfrm>
-            <a:off x="3810000" y="1879600"/>
-            <a:ext cx="762000" cy="190500"/>
+            <a:off x="4191000" y="1879600"/>
+            <a:ext cx="698500" cy="190500"/>
           </a:xfrm>
           <a:prstGeom prst="rect">
             <a:avLst/>
@@ -15655,7 +15655,7 @@
         </p:blipFill>
         <p:spPr>
           <a:xfrm>
-            <a:off x="635000" y="2260600"/>
+            <a:off x="1016000" y="2260600"/>
             <a:ext cx="254000" cy="203200"/>
           </a:xfrm>
           <a:prstGeom prst="rect">
@@ -15679,7 +15679,7 @@
         </p:blipFill>
         <p:spPr>
           <a:xfrm>
-            <a:off x="1016000" y="2222500"/>
+            <a:off x="1397000" y="2222500"/>
             <a:ext cx="2514600" cy="254000"/>
           </a:xfrm>
           <a:prstGeom prst="rect">
@@ -15703,8 +15703,8 @@
         </p:blipFill>
         <p:spPr>
           <a:xfrm>
-            <a:off x="3810000" y="2247900"/>
-            <a:ext cx="508000" cy="190500"/>
+            <a:off x="4191000" y="2247900"/>
+            <a:ext cx="444500" cy="190500"/>
           </a:xfrm>
           <a:prstGeom prst="rect">
             <a:avLst/>
@@ -15727,7 +15727,7 @@
         </p:blipFill>
         <p:spPr>
           <a:xfrm>
-            <a:off x="1397000" y="2590800"/>
+            <a:off x="1778000" y="2590800"/>
             <a:ext cx="2133600" cy="254000"/>
           </a:xfrm>
           <a:prstGeom prst="rect">
@@ -15751,8 +15751,8 @@
         </p:blipFill>
         <p:spPr>
           <a:xfrm>
-            <a:off x="3810000" y="2616200"/>
-            <a:ext cx="508000" cy="190500"/>
+            <a:off x="4191000" y="2616200"/>
+            <a:ext cx="444500" cy="190500"/>
           </a:xfrm>
           <a:prstGeom prst="rect">
             <a:avLst/>
@@ -15775,7 +15775,7 @@
         </p:blipFill>
         <p:spPr>
           <a:xfrm>
-            <a:off x="1828800" y="2959100"/>
+            <a:off x="2209800" y="2959100"/>
             <a:ext cx="1701800" cy="254000"/>
           </a:xfrm>
           <a:prstGeom prst="rect">
@@ -15799,8 +15799,8 @@
         </p:blipFill>
         <p:spPr>
           <a:xfrm>
-            <a:off x="3810000" y="2984500"/>
-            <a:ext cx="444500" cy="190500"/>
+            <a:off x="4191000" y="2984500"/>
+            <a:ext cx="381000" cy="190500"/>
           </a:xfrm>
           <a:prstGeom prst="rect">
             <a:avLst/>
@@ -15823,7 +15823,7 @@
         </p:blipFill>
         <p:spPr>
           <a:xfrm>
-            <a:off x="1447800" y="3327400"/>
+            <a:off x="1828800" y="3327400"/>
             <a:ext cx="2082800" cy="304800"/>
           </a:xfrm>
           <a:prstGeom prst="rect">
@@ -15847,8 +15847,8 @@
         </p:blipFill>
         <p:spPr>
           <a:xfrm>
-            <a:off x="3810000" y="3352800"/>
-            <a:ext cx="292100" cy="190500"/>
+            <a:off x="4191000" y="3352800"/>
+            <a:ext cx="266700" cy="190500"/>
           </a:xfrm>
           <a:prstGeom prst="rect">
             <a:avLst/>
@@ -15871,7 +15871,7 @@
         </p:blipFill>
         <p:spPr>
           <a:xfrm>
-            <a:off x="1651000" y="3695700"/>
+            <a:off x="2032000" y="3695700"/>
             <a:ext cx="1879600" cy="254000"/>
           </a:xfrm>
           <a:prstGeom prst="rect">
@@ -15895,8 +15895,8 @@
         </p:blipFill>
         <p:spPr>
           <a:xfrm>
-            <a:off x="3810000" y="3721100"/>
-            <a:ext cx="114300" cy="190500"/>
+            <a:off x="4191000" y="3721100"/>
+            <a:ext cx="101600" cy="190500"/>
           </a:xfrm>
           <a:prstGeom prst="rect">
             <a:avLst/>
@@ -15919,7 +15919,7 @@
         </p:blipFill>
         <p:spPr>
           <a:xfrm>
-            <a:off x="1320800" y="4064000"/>
+            <a:off x="1701800" y="4064000"/>
             <a:ext cx="2209800" cy="254000"/>
           </a:xfrm>
           <a:prstGeom prst="rect">
@@ -15943,8 +15943,8 @@
         </p:blipFill>
         <p:spPr>
           <a:xfrm>
-            <a:off x="3810000" y="4089400"/>
-            <a:ext cx="114300" cy="190500"/>
+            <a:off x="4191000" y="4089400"/>
+            <a:ext cx="101600" cy="190500"/>
           </a:xfrm>
           <a:prstGeom prst="rect">
             <a:avLst/>
@@ -15967,7 +15967,7 @@
         </p:blipFill>
         <p:spPr>
           <a:xfrm>
-            <a:off x="1168400" y="4470400"/>
+            <a:off x="1549400" y="4470400"/>
             <a:ext cx="254000" cy="203200"/>
           </a:xfrm>
           <a:prstGeom prst="rect">
@@ -15991,7 +15991,7 @@
         </p:blipFill>
         <p:spPr>
           <a:xfrm>
-            <a:off x="1549400" y="4432300"/>
+            <a:off x="1930400" y="4432300"/>
             <a:ext cx="1981200" cy="304800"/>
           </a:xfrm>
           <a:prstGeom prst="rect">
@@ -16015,8 +16015,8 @@
         </p:blipFill>
         <p:spPr>
           <a:xfrm>
-            <a:off x="3810000" y="4457700"/>
-            <a:ext cx="88900" cy="190500"/>
+            <a:off x="4191000" y="4457700"/>
+            <a:ext cx="76200" cy="190500"/>
           </a:xfrm>
           <a:prstGeom prst="rect">
             <a:avLst/>
@@ -16039,7 +16039,7 @@
         </p:blipFill>
         <p:spPr>
           <a:xfrm>
-            <a:off x="990600" y="4800600"/>
+            <a:off x="1371600" y="4800600"/>
             <a:ext cx="2540000" cy="254000"/>
           </a:xfrm>
           <a:prstGeom prst="rect">
@@ -16063,8 +16063,8 @@
         </p:blipFill>
         <p:spPr>
           <a:xfrm>
-            <a:off x="3810000" y="4826000"/>
-            <a:ext cx="88900" cy="190500"/>
+            <a:off x="4191000" y="4826000"/>
+            <a:ext cx="76200" cy="190500"/>
           </a:xfrm>
           <a:prstGeom prst="rect">
             <a:avLst/>
@@ -16087,7 +16087,7 @@
         </p:blipFill>
         <p:spPr>
           <a:xfrm>
-            <a:off x="787400" y="5207000"/>
+            <a:off x="1168400" y="5207000"/>
             <a:ext cx="254000" cy="203200"/>
           </a:xfrm>
           <a:prstGeom prst="rect">
@@ -16111,7 +16111,7 @@
         </p:blipFill>
         <p:spPr>
           <a:xfrm>
-            <a:off x="1168400" y="5168900"/>
+            <a:off x="1549400" y="5168900"/>
             <a:ext cx="2362200" cy="254000"/>
           </a:xfrm>
           <a:prstGeom prst="rect">
@@ -16135,8 +16135,8 @@
         </p:blipFill>
         <p:spPr>
           <a:xfrm>
-            <a:off x="3810000" y="5194300"/>
-            <a:ext cx="63500" cy="190500"/>
+            <a:off x="4191000" y="5194300"/>
+            <a:ext cx="50800" cy="190500"/>
           </a:xfrm>
           <a:prstGeom prst="rect">
             <a:avLst/>
@@ -16159,7 +16159,7 @@
         </p:blipFill>
         <p:spPr>
           <a:xfrm>
-            <a:off x="889000" y="5575300"/>
+            <a:off x="1270000" y="5575300"/>
             <a:ext cx="254000" cy="203200"/>
           </a:xfrm>
           <a:prstGeom prst="rect">
@@ -16183,7 +16183,7 @@
         </p:blipFill>
         <p:spPr>
           <a:xfrm>
-            <a:off x="1270000" y="5537200"/>
+            <a:off x="1651000" y="5537200"/>
             <a:ext cx="2260600" cy="254000"/>
           </a:xfrm>
           <a:prstGeom prst="rect">
@@ -16207,7 +16207,7 @@
         </p:blipFill>
         <p:spPr>
           <a:xfrm>
-            <a:off x="3810000" y="5562600"/>
+            <a:off x="4191000" y="5562600"/>
             <a:ext cx="38100" cy="190500"/>
           </a:xfrm>
           <a:prstGeom prst="rect">
@@ -16231,7 +16231,7 @@
         </p:blipFill>
         <p:spPr>
           <a:xfrm>
-            <a:off x="1066800" y="5943600"/>
+            <a:off x="1447800" y="5943600"/>
             <a:ext cx="254000" cy="203200"/>
           </a:xfrm>
           <a:prstGeom prst="rect">
@@ -16255,7 +16255,7 @@
         </p:blipFill>
         <p:spPr>
           <a:xfrm>
-            <a:off x="1447800" y="5905500"/>
+            <a:off x="1828800" y="5905500"/>
             <a:ext cx="2082800" cy="254000"/>
           </a:xfrm>
           <a:prstGeom prst="rect">
@@ -16279,7 +16279,7 @@
         </p:blipFill>
         <p:spPr>
           <a:xfrm>
-            <a:off x="3810000" y="5930900"/>
+            <a:off x="4191000" y="5930900"/>
             <a:ext cx="38100" cy="190500"/>
           </a:xfrm>
           <a:prstGeom prst="rect">
@@ -16303,7 +16303,7 @@
         </p:blipFill>
         <p:spPr>
           <a:xfrm>
-            <a:off x="5130800" y="1524000"/>
+            <a:off x="5511800" y="1524000"/>
             <a:ext cx="254000" cy="203200"/>
           </a:xfrm>
           <a:prstGeom prst="rect">
@@ -16327,7 +16327,7 @@
         </p:blipFill>
         <p:spPr>
           <a:xfrm>
-            <a:off x="5511800" y="1485900"/>
+            <a:off x="5892800" y="1485900"/>
             <a:ext cx="2336800" cy="304800"/>
           </a:xfrm>
           <a:prstGeom prst="rect">
@@ -16351,7 +16351,7 @@
         </p:blipFill>
         <p:spPr>
           <a:xfrm>
-            <a:off x="4216400" y="3683000"/>
+            <a:off x="4572000" y="3683000"/>
             <a:ext cx="190500" cy="2476500"/>
           </a:xfrm>
           <a:prstGeom prst="rect">
@@ -16375,7 +16375,7 @@
         </p:blipFill>
         <p:spPr>
           <a:xfrm>
-            <a:off x="4495800" y="4521200"/>
+            <a:off x="4851400" y="4521200"/>
             <a:ext cx="1117600" cy="787400"/>
           </a:xfrm>
           <a:prstGeom prst="rect">
@@ -17104,7 +17104,7 @@
         </p:blipFill>
         <p:spPr>
           <a:xfrm>
-            <a:off x="8699500" y="5842000"/>
+            <a:off x="317500" y="5842000"/>
             <a:ext cx="3175000" cy="190500"/>
           </a:xfrm>
           <a:prstGeom prst="rect">
@@ -17128,7 +17128,7 @@
         </p:blipFill>
         <p:spPr>
           <a:xfrm>
-            <a:off x="698500" y="444500"/>
+            <a:off x="3492500" y="444500"/>
             <a:ext cx="7747000" cy="4953000"/>
           </a:xfrm>
           <a:prstGeom prst="rect">
@@ -17152,7 +17152,7 @@
         </p:blipFill>
         <p:spPr>
           <a:xfrm>
-            <a:off x="762000" y="5365750"/>
+            <a:off x="3556000" y="5365750"/>
             <a:ext cx="7620000" cy="476250"/>
           </a:xfrm>
           <a:prstGeom prst="rect">
@@ -17176,7 +17176,7 @@
         </p:blipFill>
         <p:spPr>
           <a:xfrm>
-            <a:off x="1968500" y="711200"/>
+            <a:off x="4762500" y="711200"/>
             <a:ext cx="4648200" cy="304800"/>
           </a:xfrm>
           <a:prstGeom prst="rect">
@@ -17200,7 +17200,7 @@
         </p:blipFill>
         <p:spPr>
           <a:xfrm>
-            <a:off x="4089400" y="1422400"/>
+            <a:off x="6883400" y="1422400"/>
             <a:ext cx="965200" cy="254000"/>
           </a:xfrm>
           <a:prstGeom prst="rect">
@@ -17224,7 +17224,7 @@
         </p:blipFill>
         <p:spPr>
           <a:xfrm>
-            <a:off x="5715000" y="1422400"/>
+            <a:off x="8509000" y="1422400"/>
             <a:ext cx="736600" cy="203200"/>
           </a:xfrm>
           <a:prstGeom prst="rect">
@@ -17248,7 +17248,7 @@
         </p:blipFill>
         <p:spPr>
           <a:xfrm>
-            <a:off x="1143000" y="1905000"/>
+            <a:off x="3937000" y="1905000"/>
             <a:ext cx="1397000" cy="254000"/>
           </a:xfrm>
           <a:prstGeom prst="rect">
@@ -17272,7 +17272,7 @@
         </p:blipFill>
         <p:spPr>
           <a:xfrm>
-            <a:off x="4470400" y="1905000"/>
+            <a:off x="7264400" y="1905000"/>
             <a:ext cx="584200" cy="254000"/>
           </a:xfrm>
           <a:prstGeom prst="rect">
@@ -17296,7 +17296,7 @@
         </p:blipFill>
         <p:spPr>
           <a:xfrm>
-            <a:off x="5867400" y="1905000"/>
+            <a:off x="8661400" y="1905000"/>
             <a:ext cx="584200" cy="254000"/>
           </a:xfrm>
           <a:prstGeom prst="rect">
@@ -17320,7 +17320,7 @@
         </p:blipFill>
         <p:spPr>
           <a:xfrm>
-            <a:off x="6731000" y="1879600"/>
+            <a:off x="9525000" y="1879600"/>
             <a:ext cx="406400" cy="355600"/>
           </a:xfrm>
           <a:prstGeom prst="rect">
@@ -17344,7 +17344,7 @@
         </p:blipFill>
         <p:spPr>
           <a:xfrm>
-            <a:off x="1143000" y="2336800"/>
+            <a:off x="3937000" y="2336800"/>
             <a:ext cx="2082800" cy="304800"/>
           </a:xfrm>
           <a:prstGeom prst="rect">
@@ -17368,7 +17368,7 @@
         </p:blipFill>
         <p:spPr>
           <a:xfrm>
-            <a:off x="4699000" y="2336800"/>
+            <a:off x="7493000" y="2336800"/>
             <a:ext cx="355600" cy="254000"/>
           </a:xfrm>
           <a:prstGeom prst="rect">
@@ -17392,7 +17392,7 @@
         </p:blipFill>
         <p:spPr>
           <a:xfrm>
-            <a:off x="6096000" y="2336800"/>
+            <a:off x="8890000" y="2336800"/>
             <a:ext cx="355600" cy="254000"/>
           </a:xfrm>
           <a:prstGeom prst="rect">
@@ -17416,7 +17416,7 @@
         </p:blipFill>
         <p:spPr>
           <a:xfrm>
-            <a:off x="6731000" y="2311400"/>
+            <a:off x="9525000" y="2311400"/>
             <a:ext cx="406400" cy="355600"/>
           </a:xfrm>
           <a:prstGeom prst="rect">
@@ -17440,7 +17440,7 @@
         </p:blipFill>
         <p:spPr>
           <a:xfrm>
-            <a:off x="1143000" y="2768600"/>
+            <a:off x="3937000" y="2768600"/>
             <a:ext cx="1854200" cy="254000"/>
           </a:xfrm>
           <a:prstGeom prst="rect">
@@ -17464,7 +17464,7 @@
         </p:blipFill>
         <p:spPr>
           <a:xfrm>
-            <a:off x="4495800" y="2768600"/>
+            <a:off x="7289800" y="2768600"/>
             <a:ext cx="558800" cy="254000"/>
           </a:xfrm>
           <a:prstGeom prst="rect">
@@ -17488,7 +17488,7 @@
         </p:blipFill>
         <p:spPr>
           <a:xfrm>
-            <a:off x="5892800" y="2768600"/>
+            <a:off x="8686800" y="2768600"/>
             <a:ext cx="558800" cy="254000"/>
           </a:xfrm>
           <a:prstGeom prst="rect">
@@ -17512,7 +17512,7 @@
         </p:blipFill>
         <p:spPr>
           <a:xfrm>
-            <a:off x="6731000" y="2743200"/>
+            <a:off x="9525000" y="2743200"/>
             <a:ext cx="406400" cy="355600"/>
           </a:xfrm>
           <a:prstGeom prst="rect">
@@ -17536,7 +17536,7 @@
         </p:blipFill>
         <p:spPr>
           <a:xfrm>
-            <a:off x="1143000" y="3200400"/>
+            <a:off x="3937000" y="3200400"/>
             <a:ext cx="2159000" cy="254000"/>
           </a:xfrm>
           <a:prstGeom prst="rect">
@@ -17560,7 +17560,7 @@
         </p:blipFill>
         <p:spPr>
           <a:xfrm>
-            <a:off x="4495800" y="3200400"/>
+            <a:off x="7289800" y="3200400"/>
             <a:ext cx="558800" cy="254000"/>
           </a:xfrm>
           <a:prstGeom prst="rect">
@@ -17584,7 +17584,7 @@
         </p:blipFill>
         <p:spPr>
           <a:xfrm>
-            <a:off x="5892800" y="3200400"/>
+            <a:off x="8686800" y="3200400"/>
             <a:ext cx="558800" cy="254000"/>
           </a:xfrm>
           <a:prstGeom prst="rect">
@@ -17608,7 +17608,7 @@
         </p:blipFill>
         <p:spPr>
           <a:xfrm>
-            <a:off x="6731000" y="3175000"/>
+            <a:off x="9525000" y="3175000"/>
             <a:ext cx="406400" cy="355600"/>
           </a:xfrm>
           <a:prstGeom prst="rect">
@@ -17632,7 +17632,7 @@
         </p:blipFill>
         <p:spPr>
           <a:xfrm>
-            <a:off x="1143000" y="3632200"/>
+            <a:off x="3937000" y="3632200"/>
             <a:ext cx="2514600" cy="254000"/>
           </a:xfrm>
           <a:prstGeom prst="rect">
@@ -17656,7 +17656,7 @@
         </p:blipFill>
         <p:spPr>
           <a:xfrm>
-            <a:off x="4597400" y="3632200"/>
+            <a:off x="7391400" y="3632200"/>
             <a:ext cx="457200" cy="254000"/>
           </a:xfrm>
           <a:prstGeom prst="rect">
@@ -17680,7 +17680,7 @@
         </p:blipFill>
         <p:spPr>
           <a:xfrm>
-            <a:off x="5994400" y="3632200"/>
+            <a:off x="8788400" y="3632200"/>
             <a:ext cx="457200" cy="254000"/>
           </a:xfrm>
           <a:prstGeom prst="rect">
@@ -17704,7 +17704,7 @@
         </p:blipFill>
         <p:spPr>
           <a:xfrm>
-            <a:off x="6731000" y="3606800"/>
+            <a:off x="9525000" y="3606800"/>
             <a:ext cx="406400" cy="355600"/>
           </a:xfrm>
           <a:prstGeom prst="rect">
@@ -17728,7 +17728,7 @@
         </p:blipFill>
         <p:spPr>
           <a:xfrm>
-            <a:off x="1143000" y="4064000"/>
+            <a:off x="3937000" y="4064000"/>
             <a:ext cx="2032000" cy="254000"/>
           </a:xfrm>
           <a:prstGeom prst="rect">
@@ -17752,7 +17752,7 @@
         </p:blipFill>
         <p:spPr>
           <a:xfrm>
-            <a:off x="4597400" y="4064000"/>
+            <a:off x="7391400" y="4064000"/>
             <a:ext cx="457200" cy="254000"/>
           </a:xfrm>
           <a:prstGeom prst="rect">
@@ -17776,7 +17776,7 @@
         </p:blipFill>
         <p:spPr>
           <a:xfrm>
-            <a:off x="5994400" y="4064000"/>
+            <a:off x="8788400" y="4064000"/>
             <a:ext cx="457200" cy="254000"/>
           </a:xfrm>
           <a:prstGeom prst="rect">
@@ -17800,7 +17800,7 @@
         </p:blipFill>
         <p:spPr>
           <a:xfrm>
-            <a:off x="6731000" y="4038600"/>
+            <a:off x="9525000" y="4038600"/>
             <a:ext cx="406400" cy="355600"/>
           </a:xfrm>
           <a:prstGeom prst="rect">
@@ -17824,7 +17824,7 @@
         </p:blipFill>
         <p:spPr>
           <a:xfrm>
-            <a:off x="1143000" y="4495800"/>
+            <a:off x="3937000" y="4495800"/>
             <a:ext cx="2133600" cy="254000"/>
           </a:xfrm>
           <a:prstGeom prst="rect">
@@ -17848,7 +17848,7 @@
         </p:blipFill>
         <p:spPr>
           <a:xfrm>
-            <a:off x="4597400" y="4495800"/>
+            <a:off x="7391400" y="4495800"/>
             <a:ext cx="457200" cy="254000"/>
           </a:xfrm>
           <a:prstGeom prst="rect">
@@ -17872,7 +17872,7 @@
         </p:blipFill>
         <p:spPr>
           <a:xfrm>
-            <a:off x="5994400" y="4495800"/>
+            <a:off x="8788400" y="4495800"/>
             <a:ext cx="457200" cy="254000"/>
           </a:xfrm>
           <a:prstGeom prst="rect">
@@ -17896,7 +17896,7 @@
         </p:blipFill>
         <p:spPr>
           <a:xfrm>
-            <a:off x="6731000" y="4470400"/>
+            <a:off x="9525000" y="4470400"/>
             <a:ext cx="406400" cy="355600"/>
           </a:xfrm>
           <a:prstGeom prst="rect">
@@ -17920,7 +17920,7 @@
         </p:blipFill>
         <p:spPr>
           <a:xfrm>
-            <a:off x="1143000" y="4927600"/>
+            <a:off x="3937000" y="4927600"/>
             <a:ext cx="1371600" cy="304800"/>
           </a:xfrm>
           <a:prstGeom prst="rect">
@@ -17944,7 +17944,7 @@
         </p:blipFill>
         <p:spPr>
           <a:xfrm>
-            <a:off x="4495800" y="4927600"/>
+            <a:off x="7289800" y="4927600"/>
             <a:ext cx="558800" cy="254000"/>
           </a:xfrm>
           <a:prstGeom prst="rect">
@@ -17968,7 +17968,7 @@
         </p:blipFill>
         <p:spPr>
           <a:xfrm>
-            <a:off x="5892800" y="4927600"/>
+            <a:off x="8686800" y="4927600"/>
             <a:ext cx="558800" cy="254000"/>
           </a:xfrm>
           <a:prstGeom prst="rect">
@@ -17992,7 +17992,7 @@
         </p:blipFill>
         <p:spPr>
           <a:xfrm>
-            <a:off x="6731000" y="4902200"/>
+            <a:off x="9525000" y="4902200"/>
             <a:ext cx="406400" cy="355600"/>
           </a:xfrm>
           <a:prstGeom prst="rect">
@@ -18016,7 +18016,7 @@
         </p:blipFill>
         <p:spPr>
           <a:xfrm>
-            <a:off x="8699500" y="3111500"/>
+            <a:off x="317500" y="3111500"/>
             <a:ext cx="3556000" cy="2730500"/>
           </a:xfrm>
           <a:prstGeom prst="rect">
@@ -18898,7 +18898,7 @@
         </p:blipFill>
         <p:spPr>
           <a:xfrm>
-            <a:off x="6350000" y="5842000"/>
+            <a:off x="6477000" y="5842000"/>
             <a:ext cx="3175000" cy="190500"/>
           </a:xfrm>
           <a:prstGeom prst="rect">
@@ -18932,7 +18932,7 @@
       </p:pic>
       <p:pic>
         <p:nvPicPr>
-          <p:cNvPr id="6" name="!!dial" descr="image.png"/>
+          <p:cNvPr id="6" name="!!panel_dial" descr="image.png"/>
           <p:cNvPicPr>
             <a:picLocks noChangeAspect="1"/>
           </p:cNvPicPr>
@@ -18970,7 +18970,7 @@
         </p:blipFill>
         <p:spPr>
           <a:xfrm>
-            <a:off x="6350000" y="3111500"/>
+            <a:off x="6477000" y="3111500"/>
             <a:ext cx="3556000" cy="2730500"/>
           </a:xfrm>
           <a:prstGeom prst="rect">
@@ -18994,7 +18994,7 @@
         </p:blipFill>
         <p:spPr>
           <a:xfrm>
-            <a:off x="825500" y="2000250"/>
+            <a:off x="571500" y="1555750"/>
             <a:ext cx="1968500" cy="635000"/>
           </a:xfrm>
           <a:prstGeom prst="rect">
@@ -19018,7 +19018,7 @@
         </p:blipFill>
         <p:spPr>
           <a:xfrm>
-            <a:off x="5080000" y="2000250"/>
+            <a:off x="5334000" y="1555750"/>
             <a:ext cx="2349500" cy="635000"/>
           </a:xfrm>
           <a:prstGeom prst="rect">
@@ -19042,7 +19042,7 @@
         </p:blipFill>
         <p:spPr>
           <a:xfrm>
-            <a:off x="1524000" y="5207000"/>
+            <a:off x="2032000" y="4413250"/>
             <a:ext cx="635000" cy="317500"/>
           </a:xfrm>
           <a:prstGeom prst="rect">
@@ -19052,7 +19052,7 @@
       </p:pic>
       <p:pic>
         <p:nvPicPr>
-          <p:cNvPr id="11" name="!!t_tick6" descr="image.png"/>
+          <p:cNvPr id="11" name="!!t_tick4" descr="image.png"/>
           <p:cNvPicPr>
             <a:picLocks noChangeAspect="1"/>
           </p:cNvPicPr>
@@ -19066,7 +19066,55 @@
         </p:blipFill>
         <p:spPr>
           <a:xfrm>
-            <a:off x="5969000" y="5207000"/>
+            <a:off x="2540000" y="2508250"/>
+            <a:ext cx="603250" cy="317500"/>
+          </a:xfrm>
+          <a:prstGeom prst="rect">
+            <a:avLst/>
+          </a:prstGeom>
+        </p:spPr>
+      </p:pic>
+      <p:pic>
+        <p:nvPicPr>
+          <p:cNvPr id="12" name="!!t_tick5" descr="image.png"/>
+          <p:cNvPicPr>
+            <a:picLocks noChangeAspect="1"/>
+          </p:cNvPicPr>
+          <p:nvPr/>
+        </p:nvPicPr>
+        <p:blipFill>
+          <a:blip r:embed="rId12"/>
+          <a:stretch>
+            <a:fillRect/>
+          </a:stretch>
+        </p:blipFill>
+        <p:spPr>
+          <a:xfrm>
+            <a:off x="5048250" y="2508250"/>
+            <a:ext cx="603250" cy="317500"/>
+          </a:xfrm>
+          <a:prstGeom prst="rect">
+            <a:avLst/>
+          </a:prstGeom>
+        </p:spPr>
+      </p:pic>
+      <p:pic>
+        <p:nvPicPr>
+          <p:cNvPr id="13" name="!!t_tick6" descr="image.png"/>
+          <p:cNvPicPr>
+            <a:picLocks noChangeAspect="1"/>
+          </p:cNvPicPr>
+          <p:nvPr/>
+        </p:nvPicPr>
+        <p:blipFill>
+          <a:blip r:embed="rId13"/>
+          <a:stretch>
+            <a:fillRect/>
+          </a:stretch>
+        </p:blipFill>
+        <p:spPr>
+          <a:xfrm>
+            <a:off x="5461000" y="4413250"/>
             <a:ext cx="635000" cy="317500"/>
           </a:xfrm>
           <a:prstGeom prst="rect">
@@ -19076,14 +19124,38 @@
       </p:pic>
       <p:pic>
         <p:nvPicPr>
-          <p:cNvPr id="12" name="!!cue" descr="image.png"/>
-          <p:cNvPicPr>
-            <a:picLocks noChangeAspect="1"/>
-          </p:cNvPicPr>
-          <p:nvPr/>
-        </p:nvPicPr>
-        <p:blipFill>
-          <a:blip r:embed="rId12"/>
+          <p:cNvPr id="14" name="!!t_gname" descr="image.png"/>
+          <p:cNvPicPr>
+            <a:picLocks noChangeAspect="1"/>
+          </p:cNvPicPr>
+          <p:nvPr/>
+        </p:nvPicPr>
+        <p:blipFill>
+          <a:blip r:embed="rId14"/>
+          <a:stretch>
+            <a:fillRect/>
+          </a:stretch>
+        </p:blipFill>
+        <p:spPr>
+          <a:xfrm>
+            <a:off x="2667000" y="1143000"/>
+            <a:ext cx="2825750" cy="317500"/>
+          </a:xfrm>
+          <a:prstGeom prst="rect">
+            <a:avLst/>
+          </a:prstGeom>
+        </p:spPr>
+      </p:pic>
+      <p:pic>
+        <p:nvPicPr>
+          <p:cNvPr id="15" name="!!cue" descr="image.png"/>
+          <p:cNvPicPr>
+            <a:picLocks noChangeAspect="1"/>
+          </p:cNvPicPr>
+          <p:nvPr/>
+        </p:nvPicPr>
+        <p:blipFill>
+          <a:blip r:embed="rId15"/>
           <a:stretch>
             <a:fillRect/>
           </a:stretch>
@@ -20616,7 +20688,7 @@
       </p:pic>
       <p:pic>
         <p:nvPicPr>
-          <p:cNvPr id="32" name="!!swap" descr="image.png"/>
+          <p:cNvPr id="32" name="!!cue" descr="image.png"/>
           <p:cNvPicPr>
             <a:picLocks noChangeAspect="1"/>
           </p:cNvPicPr>
@@ -20624,30 +20696,6 @@
         </p:nvPicPr>
         <p:blipFill>
           <a:blip r:embed="rId15"/>
-          <a:stretch>
-            <a:fillRect/>
-          </a:stretch>
-        </p:blipFill>
-        <p:spPr>
-          <a:xfrm>
-            <a:off x="8636000" y="4508500"/>
-            <a:ext cx="1270000" cy="952500"/>
-          </a:xfrm>
-          <a:prstGeom prst="rect">
-            <a:avLst/>
-          </a:prstGeom>
-        </p:spPr>
-      </p:pic>
-      <p:pic>
-        <p:nvPicPr>
-          <p:cNvPr id="33" name="!!cue" descr="image.png"/>
-          <p:cNvPicPr>
-            <a:picLocks noChangeAspect="1"/>
-          </p:cNvPicPr>
-          <p:nvPr/>
-        </p:nvPicPr>
-        <p:blipFill>
-          <a:blip r:embed="rId16"/>
           <a:stretch>
             <a:fillRect/>
           </a:stretch>
@@ -22433,8 +22481,8 @@
         </p:blipFill>
         <p:spPr>
           <a:xfrm>
-            <a:off x="762000" y="4699000"/>
-            <a:ext cx="2698750" cy="1047750"/>
+            <a:off x="730250" y="4699000"/>
+            <a:ext cx="2730500" cy="1047750"/>
           </a:xfrm>
           <a:prstGeom prst="rect">
             <a:avLst/>
@@ -25144,7 +25192,7 @@
         <p:spPr>
           <a:xfrm>
             <a:off x="3276600" y="3937000"/>
-            <a:ext cx="4953000" cy="304800"/>
+            <a:ext cx="6426200" cy="304800"/>
           </a:xfrm>
           <a:prstGeom prst="rect">
             <a:avLst/>
@@ -26161,7 +26209,7 @@
         <p:spPr>
           <a:xfrm>
             <a:off x="4064000" y="4597400"/>
-            <a:ext cx="6553200" cy="304800"/>
+            <a:ext cx="6908800" cy="304800"/>
           </a:xfrm>
           <a:prstGeom prst="rect">
             <a:avLst/>
@@ -26799,7 +26847,7 @@
         <p:spPr>
           <a:xfrm>
             <a:off x="4064000" y="4597400"/>
-            <a:ext cx="6553200" cy="304800"/>
+            <a:ext cx="6908800" cy="304800"/>
           </a:xfrm>
           <a:prstGeom prst="rect">
             <a:avLst/>
@@ -30641,8 +30689,8 @@
         </p:blipFill>
         <p:spPr>
           <a:xfrm>
-            <a:off x="476250" y="5270500"/>
-            <a:ext cx="3524250" cy="381000"/>
+            <a:off x="539750" y="5270500"/>
+            <a:ext cx="3397250" cy="381000"/>
           </a:xfrm>
           <a:prstGeom prst="rect">
             <a:avLst/>
@@ -30919,7 +30967,7 @@
         </p:blipFill>
         <p:spPr>
           <a:xfrm>
-            <a:off x="3778250" y="3111500"/>
+            <a:off x="3524250" y="3111500"/>
             <a:ext cx="3556000" cy="2730500"/>
           </a:xfrm>
           <a:prstGeom prst="rect">
@@ -30943,8 +30991,8 @@
         </p:blipFill>
         <p:spPr>
           <a:xfrm>
-            <a:off x="476250" y="5270500"/>
-            <a:ext cx="3524250" cy="381000"/>
+            <a:off x="539750" y="5270500"/>
+            <a:ext cx="3397250" cy="381000"/>
           </a:xfrm>
           <a:prstGeom prst="rect">
             <a:avLst/>
@@ -30991,8 +31039,8 @@
         </p:blipFill>
         <p:spPr>
           <a:xfrm>
-            <a:off x="7810500" y="5302250"/>
-            <a:ext cx="2857500" cy="317500"/>
+            <a:off x="7874000" y="5302250"/>
+            <a:ext cx="2730500" cy="317500"/>
           </a:xfrm>
           <a:prstGeom prst="rect">
             <a:avLst/>
@@ -31135,7 +31183,7 @@
       </p:pic>
       <p:pic>
         <p:nvPicPr>
-          <p:cNvPr id="5" name="!!fact" descr="image.png"/>
+          <p:cNvPr id="5" name="!!tripod" descr="image.png"/>
           <p:cNvPicPr>
             <a:picLocks noChangeAspect="1"/>
           </p:cNvPicPr>
@@ -31143,6 +31191,30 @@
         </p:nvPicPr>
         <p:blipFill>
           <a:blip r:embed="rId5"/>
+          <a:stretch>
+            <a:fillRect/>
+          </a:stretch>
+        </p:blipFill>
+        <p:spPr>
+          <a:xfrm>
+            <a:off x="317500" y="4191000"/>
+            <a:ext cx="1143000" cy="1651000"/>
+          </a:xfrm>
+          <a:prstGeom prst="rect">
+            <a:avLst/>
+          </a:prstGeom>
+        </p:spPr>
+      </p:pic>
+      <p:pic>
+        <p:nvPicPr>
+          <p:cNvPr id="6" name="!!fact" descr="image.png"/>
+          <p:cNvPicPr>
+            <a:picLocks noChangeAspect="1"/>
+          </p:cNvPicPr>
+          <p:nvPr/>
+        </p:nvPicPr>
+        <p:blipFill>
+          <a:blip r:embed="rId6"/>
           <a:stretch>
             <a:fillRect/>
           </a:stretch>
@@ -31159,14 +31231,14 @@
       </p:pic>
       <p:pic>
         <p:nvPicPr>
-          <p:cNvPr id="6" name="!!compass" descr="image.png"/>
-          <p:cNvPicPr>
-            <a:picLocks noChangeAspect="1"/>
-          </p:cNvPicPr>
-          <p:nvPr/>
-        </p:nvPicPr>
-        <p:blipFill>
-          <a:blip r:embed="rId6"/>
+          <p:cNvPr id="7" name="!!compass" descr="image.png"/>
+          <p:cNvPicPr>
+            <a:picLocks noChangeAspect="1"/>
+          </p:cNvPicPr>
+          <p:nvPr/>
+        </p:nvPicPr>
+        <p:blipFill>
+          <a:blip r:embed="rId7"/>
           <a:stretch>
             <a:fillRect/>
           </a:stretch>
@@ -31183,14 +31255,14 @@
       </p:pic>
       <p:pic>
         <p:nvPicPr>
-          <p:cNvPr id="7" name="!!robot" descr="image.png"/>
-          <p:cNvPicPr>
-            <a:picLocks noChangeAspect="1"/>
-          </p:cNvPicPr>
-          <p:nvPr/>
-        </p:nvPicPr>
-        <p:blipFill>
-          <a:blip r:embed="rId7"/>
+          <p:cNvPr id="8" name="!!robot" descr="image.png"/>
+          <p:cNvPicPr>
+            <a:picLocks noChangeAspect="1"/>
+          </p:cNvPicPr>
+          <p:nvPr/>
+        </p:nvPicPr>
+        <p:blipFill>
+          <a:blip r:embed="rId8"/>
           <a:stretch>
             <a:fillRect/>
           </a:stretch>
@@ -31207,14 +31279,14 @@
       </p:pic>
       <p:pic>
         <p:nvPicPr>
-          <p:cNvPr id="8" name="!!t_v1" descr="image.png"/>
-          <p:cNvPicPr>
-            <a:picLocks noChangeAspect="1"/>
-          </p:cNvPicPr>
-          <p:nvPr/>
-        </p:nvPicPr>
-        <p:blipFill>
-          <a:blip r:embed="rId8"/>
+          <p:cNvPr id="9" name="!!t_v1" descr="image.png"/>
+          <p:cNvPicPr>
+            <a:picLocks noChangeAspect="1"/>
+          </p:cNvPicPr>
+          <p:nvPr/>
+        </p:nvPicPr>
+        <p:blipFill>
+          <a:blip r:embed="rId9"/>
           <a:stretch>
             <a:fillRect/>
           </a:stretch>
@@ -31231,14 +31303,14 @@
       </p:pic>
       <p:pic>
         <p:nvPicPr>
-          <p:cNvPr id="9" name="!!t_v2" descr="image.png"/>
-          <p:cNvPicPr>
-            <a:picLocks noChangeAspect="1"/>
-          </p:cNvPicPr>
-          <p:nvPr/>
-        </p:nvPicPr>
-        <p:blipFill>
-          <a:blip r:embed="rId9"/>
+          <p:cNvPr id="10" name="!!t_v2" descr="image.png"/>
+          <p:cNvPicPr>
+            <a:picLocks noChangeAspect="1"/>
+          </p:cNvPicPr>
+          <p:nvPr/>
+        </p:nvPicPr>
+        <p:blipFill>
+          <a:blip r:embed="rId10"/>
           <a:stretch>
             <a:fillRect/>
           </a:stretch>
@@ -31255,14 +31327,14 @@
       </p:pic>
       <p:pic>
         <p:nvPicPr>
-          <p:cNvPr id="10" name="!!cue" descr="image.png"/>
-          <p:cNvPicPr>
-            <a:picLocks noChangeAspect="1"/>
-          </p:cNvPicPr>
-          <p:nvPr/>
-        </p:nvPicPr>
-        <p:blipFill>
-          <a:blip r:embed="rId10"/>
+          <p:cNvPr id="11" name="!!cue" descr="image.png"/>
+          <p:cNvPicPr>
+            <a:picLocks noChangeAspect="1"/>
+          </p:cNvPicPr>
+          <p:nvPr/>
+        </p:nvPicPr>
+        <p:blipFill>
+          <a:blip r:embed="rId11"/>
           <a:stretch>
             <a:fillRect/>
           </a:stretch>
@@ -39471,8 +39543,8 @@
         </p:blipFill>
         <p:spPr>
           <a:xfrm>
-            <a:off x="8699500" y="5842000"/>
-            <a:ext cx="3175000" cy="190500"/>
+            <a:off x="-190500" y="5842000"/>
+            <a:ext cx="3968750" cy="190500"/>
           </a:xfrm>
           <a:prstGeom prst="rect">
             <a:avLst/>
@@ -39495,7 +39567,7 @@
         </p:blipFill>
         <p:spPr>
           <a:xfrm>
-            <a:off x="698500" y="444500"/>
+            <a:off x="3492500" y="444500"/>
             <a:ext cx="7874000" cy="5080000"/>
           </a:xfrm>
           <a:prstGeom prst="rect">
@@ -39519,7 +39591,7 @@
         </p:blipFill>
         <p:spPr>
           <a:xfrm>
-            <a:off x="762000" y="5334000"/>
+            <a:off x="3556000" y="5334000"/>
             <a:ext cx="7620000" cy="508000"/>
           </a:xfrm>
           <a:prstGeom prst="rect">
@@ -39543,7 +39615,7 @@
         </p:blipFill>
         <p:spPr>
           <a:xfrm>
-            <a:off x="1117600" y="800100"/>
+            <a:off x="3911600" y="800100"/>
             <a:ext cx="5181600" cy="457200"/>
           </a:xfrm>
           <a:prstGeom prst="rect">
@@ -39567,7 +39639,7 @@
         </p:blipFill>
         <p:spPr>
           <a:xfrm>
-            <a:off x="1117600" y="1422400"/>
+            <a:off x="3911600" y="1422400"/>
             <a:ext cx="4495800" cy="304800"/>
           </a:xfrm>
           <a:prstGeom prst="rect">
@@ -39591,7 +39663,7 @@
         </p:blipFill>
         <p:spPr>
           <a:xfrm>
-            <a:off x="4953000" y="2413000"/>
+            <a:off x="7747000" y="2413000"/>
             <a:ext cx="1447800" cy="762000"/>
           </a:xfrm>
           <a:prstGeom prst="rect">
@@ -39615,7 +39687,7 @@
         </p:blipFill>
         <p:spPr>
           <a:xfrm>
-            <a:off x="4953000" y="3810000"/>
+            <a:off x="7747000" y="3810000"/>
             <a:ext cx="1879600" cy="812800"/>
           </a:xfrm>
           <a:prstGeom prst="rect">
@@ -39639,7 +39711,7 @@
         </p:blipFill>
         <p:spPr>
           <a:xfrm>
-            <a:off x="1143000" y="1968500"/>
+            <a:off x="3937000" y="1968500"/>
             <a:ext cx="3492500" cy="2222500"/>
           </a:xfrm>
           <a:prstGeom prst="rect">
@@ -39663,8 +39735,8 @@
         </p:blipFill>
         <p:spPr>
           <a:xfrm>
-            <a:off x="8699500" y="3111500"/>
-            <a:ext cx="3556000" cy="2730500"/>
+            <a:off x="-206375" y="2428875"/>
+            <a:ext cx="4445000" cy="3413125"/>
           </a:xfrm>
           <a:prstGeom prst="rect">
             <a:avLst/>
@@ -39788,8 +39860,8 @@
         </p:blipFill>
         <p:spPr>
           <a:xfrm>
-            <a:off x="8699500" y="5842000"/>
-            <a:ext cx="3175000" cy="190500"/>
+            <a:off x="-190500" y="5842000"/>
+            <a:ext cx="3968750" cy="190500"/>
           </a:xfrm>
           <a:prstGeom prst="rect">
             <a:avLst/>
@@ -39812,7 +39884,7 @@
         </p:blipFill>
         <p:spPr>
           <a:xfrm>
-            <a:off x="698500" y="444500"/>
+            <a:off x="3492500" y="444500"/>
             <a:ext cx="7874000" cy="5080000"/>
           </a:xfrm>
           <a:prstGeom prst="rect">
@@ -39836,7 +39908,7 @@
         </p:blipFill>
         <p:spPr>
           <a:xfrm>
-            <a:off x="762000" y="5334000"/>
+            <a:off x="3556000" y="5334000"/>
             <a:ext cx="7620000" cy="508000"/>
           </a:xfrm>
           <a:prstGeom prst="rect">
@@ -39860,7 +39932,7 @@
         </p:blipFill>
         <p:spPr>
           <a:xfrm>
-            <a:off x="1117600" y="800100"/>
+            <a:off x="3911600" y="800100"/>
             <a:ext cx="5181600" cy="457200"/>
           </a:xfrm>
           <a:prstGeom prst="rect">
@@ -39884,7 +39956,7 @@
         </p:blipFill>
         <p:spPr>
           <a:xfrm>
-            <a:off x="1117600" y="1422400"/>
+            <a:off x="3911600" y="1422400"/>
             <a:ext cx="4495800" cy="304800"/>
           </a:xfrm>
           <a:prstGeom prst="rect">
@@ -39908,7 +39980,7 @@
         </p:blipFill>
         <p:spPr>
           <a:xfrm>
-            <a:off x="4953000" y="2413000"/>
+            <a:off x="7747000" y="2413000"/>
             <a:ext cx="1447800" cy="762000"/>
           </a:xfrm>
           <a:prstGeom prst="rect">
@@ -39932,7 +40004,7 @@
         </p:blipFill>
         <p:spPr>
           <a:xfrm>
-            <a:off x="4953000" y="3810000"/>
+            <a:off x="7747000" y="3810000"/>
             <a:ext cx="1879600" cy="812800"/>
           </a:xfrm>
           <a:prstGeom prst="rect">
@@ -39956,7 +40028,7 @@
         </p:blipFill>
         <p:spPr>
           <a:xfrm>
-            <a:off x="1143000" y="1968500"/>
+            <a:off x="3937000" y="1968500"/>
             <a:ext cx="3492500" cy="2222500"/>
           </a:xfrm>
           <a:prstGeom prst="rect">
@@ -39980,8 +40052,8 @@
         </p:blipFill>
         <p:spPr>
           <a:xfrm>
-            <a:off x="8699500" y="3111500"/>
-            <a:ext cx="3556000" cy="2730500"/>
+            <a:off x="-206375" y="2428875"/>
+            <a:ext cx="4445000" cy="3413125"/>
           </a:xfrm>
           <a:prstGeom prst="rect">
             <a:avLst/>
@@ -40138,7 +40210,7 @@
         </p:blipFill>
         <p:spPr>
           <a:xfrm>
-            <a:off x="571500" y="114300"/>
+            <a:off x="571500" y="241300"/>
             <a:ext cx="8382000" cy="5994400"/>
           </a:xfrm>
           <a:prstGeom prst="rect">
@@ -40162,7 +40234,7 @@
         </p:blipFill>
         <p:spPr>
           <a:xfrm>
-            <a:off x="5016500" y="304800"/>
+            <a:off x="5016500" y="431800"/>
             <a:ext cx="63500" cy="5511800"/>
           </a:xfrm>
           <a:prstGeom prst="rect">
@@ -40186,7 +40258,7 @@
         </p:blipFill>
         <p:spPr>
           <a:xfrm>
-            <a:off x="6223000" y="304800"/>
+            <a:off x="6223000" y="431800"/>
             <a:ext cx="63500" cy="5511800"/>
           </a:xfrm>
           <a:prstGeom prst="rect">
@@ -40210,7 +40282,7 @@
         </p:blipFill>
         <p:spPr>
           <a:xfrm>
-            <a:off x="3746500" y="304800"/>
+            <a:off x="3746500" y="431800"/>
             <a:ext cx="63500" cy="5511800"/>
           </a:xfrm>
           <a:prstGeom prst="rect">
@@ -40234,7 +40306,7 @@
         </p:blipFill>
         <p:spPr>
           <a:xfrm>
-            <a:off x="6451600" y="3517900"/>
+            <a:off x="6451600" y="3644900"/>
             <a:ext cx="1981200" cy="457200"/>
           </a:xfrm>
           <a:prstGeom prst="rect">
@@ -40258,7 +40330,7 @@
         </p:blipFill>
         <p:spPr>
           <a:xfrm>
-            <a:off x="6451600" y="4013200"/>
+            <a:off x="6451600" y="4140200"/>
             <a:ext cx="2159000" cy="673100"/>
           </a:xfrm>
           <a:prstGeom prst="rect">
@@ -40282,7 +40354,7 @@
         </p:blipFill>
         <p:spPr>
           <a:xfrm>
-            <a:off x="5168900" y="5435600"/>
+            <a:off x="5168900" y="5562600"/>
             <a:ext cx="457200" cy="254000"/>
           </a:xfrm>
           <a:prstGeom prst="rect">
@@ -40306,7 +40378,7 @@
         </p:blipFill>
         <p:spPr>
           <a:xfrm>
-            <a:off x="6375400" y="5435600"/>
+            <a:off x="6375400" y="5562600"/>
             <a:ext cx="558800" cy="254000"/>
           </a:xfrm>
           <a:prstGeom prst="rect">
@@ -40330,7 +40402,7 @@
         </p:blipFill>
         <p:spPr>
           <a:xfrm>
-            <a:off x="6451600" y="4762500"/>
+            <a:off x="6451600" y="4889500"/>
             <a:ext cx="1524000" cy="254000"/>
           </a:xfrm>
           <a:prstGeom prst="rect">
@@ -40354,7 +40426,7 @@
         </p:blipFill>
         <p:spPr>
           <a:xfrm>
-            <a:off x="1676400" y="381000"/>
+            <a:off x="1676400" y="508000"/>
             <a:ext cx="1854200" cy="254000"/>
           </a:xfrm>
           <a:prstGeom prst="rect">
@@ -40378,7 +40450,7 @@
         </p:blipFill>
         <p:spPr>
           <a:xfrm>
-            <a:off x="3810000" y="406400"/>
+            <a:off x="3810000" y="533400"/>
             <a:ext cx="3238500" cy="190500"/>
           </a:xfrm>
           <a:prstGeom prst="rect">
@@ -40402,7 +40474,7 @@
         </p:blipFill>
         <p:spPr>
           <a:xfrm>
-            <a:off x="7150100" y="406400"/>
+            <a:off x="7150100" y="533400"/>
             <a:ext cx="203200" cy="177800"/>
           </a:xfrm>
           <a:prstGeom prst="rect">
@@ -40426,7 +40498,7 @@
         </p:blipFill>
         <p:spPr>
           <a:xfrm>
-            <a:off x="2133600" y="723900"/>
+            <a:off x="2133600" y="850900"/>
             <a:ext cx="1397000" cy="254000"/>
           </a:xfrm>
           <a:prstGeom prst="rect">
@@ -40450,7 +40522,7 @@
         </p:blipFill>
         <p:spPr>
           <a:xfrm>
-            <a:off x="3810000" y="749300"/>
+            <a:off x="3810000" y="876300"/>
             <a:ext cx="1778000" cy="190500"/>
           </a:xfrm>
           <a:prstGeom prst="rect">
@@ -40474,7 +40546,7 @@
         </p:blipFill>
         <p:spPr>
           <a:xfrm>
-            <a:off x="5689600" y="749300"/>
+            <a:off x="5689600" y="876300"/>
             <a:ext cx="203200" cy="177800"/>
           </a:xfrm>
           <a:prstGeom prst="rect">
@@ -40498,7 +40570,7 @@
         </p:blipFill>
         <p:spPr>
           <a:xfrm>
-            <a:off x="1371600" y="1066800"/>
+            <a:off x="1371600" y="1193800"/>
             <a:ext cx="2159000" cy="254000"/>
           </a:xfrm>
           <a:prstGeom prst="rect">
@@ -40522,7 +40594,7 @@
         </p:blipFill>
         <p:spPr>
           <a:xfrm>
-            <a:off x="3810000" y="1092200"/>
+            <a:off x="3810000" y="1219200"/>
             <a:ext cx="1587500" cy="190500"/>
           </a:xfrm>
           <a:prstGeom prst="rect">
@@ -40546,7 +40618,7 @@
         </p:blipFill>
         <p:spPr>
           <a:xfrm>
-            <a:off x="5499100" y="1092200"/>
+            <a:off x="5499100" y="1219200"/>
             <a:ext cx="203200" cy="177800"/>
           </a:xfrm>
           <a:prstGeom prst="rect">
@@ -40570,7 +40642,7 @@
         </p:blipFill>
         <p:spPr>
           <a:xfrm>
-            <a:off x="2159000" y="1409700"/>
+            <a:off x="2159000" y="1536700"/>
             <a:ext cx="1371600" cy="304800"/>
           </a:xfrm>
           <a:prstGeom prst="rect">
@@ -40594,7 +40666,7 @@
         </p:blipFill>
         <p:spPr>
           <a:xfrm>
-            <a:off x="3810000" y="1435100"/>
+            <a:off x="3810000" y="1562100"/>
             <a:ext cx="1079500" cy="190500"/>
           </a:xfrm>
           <a:prstGeom prst="rect">
@@ -40618,7 +40690,7 @@
         </p:blipFill>
         <p:spPr>
           <a:xfrm>
-            <a:off x="4991100" y="1435100"/>
+            <a:off x="4991100" y="1562100"/>
             <a:ext cx="203200" cy="177800"/>
           </a:xfrm>
           <a:prstGeom prst="rect">
@@ -40642,7 +40714,7 @@
         </p:blipFill>
         <p:spPr>
           <a:xfrm>
-            <a:off x="1498600" y="1752600"/>
+            <a:off x="1498600" y="1879600"/>
             <a:ext cx="2032000" cy="254000"/>
           </a:xfrm>
           <a:prstGeom prst="rect">
@@ -40666,7 +40738,7 @@
         </p:blipFill>
         <p:spPr>
           <a:xfrm>
-            <a:off x="3810000" y="1778000"/>
+            <a:off x="3810000" y="1905000"/>
             <a:ext cx="762000" cy="190500"/>
           </a:xfrm>
           <a:prstGeom prst="rect">
@@ -40690,7 +40762,7 @@
         </p:blipFill>
         <p:spPr>
           <a:xfrm>
-            <a:off x="4673600" y="1778000"/>
+            <a:off x="4673600" y="1905000"/>
             <a:ext cx="203200" cy="177800"/>
           </a:xfrm>
           <a:prstGeom prst="rect">
@@ -40714,7 +40786,7 @@
         </p:blipFill>
         <p:spPr>
           <a:xfrm>
-            <a:off x="1016000" y="2095500"/>
+            <a:off x="1016000" y="2222500"/>
             <a:ext cx="2514600" cy="254000"/>
           </a:xfrm>
           <a:prstGeom prst="rect">
@@ -40738,7 +40810,7 @@
         </p:blipFill>
         <p:spPr>
           <a:xfrm>
-            <a:off x="3810000" y="2120900"/>
+            <a:off x="3810000" y="2247900"/>
             <a:ext cx="508000" cy="190500"/>
           </a:xfrm>
           <a:prstGeom prst="rect">
@@ -40762,7 +40834,7 @@
         </p:blipFill>
         <p:spPr>
           <a:xfrm>
-            <a:off x="4419600" y="2120900"/>
+            <a:off x="4419600" y="2247900"/>
             <a:ext cx="203200" cy="177800"/>
           </a:xfrm>
           <a:prstGeom prst="rect">
@@ -40786,7 +40858,7 @@
         </p:blipFill>
         <p:spPr>
           <a:xfrm>
-            <a:off x="1397000" y="2438400"/>
+            <a:off x="1397000" y="2565400"/>
             <a:ext cx="2133600" cy="254000"/>
           </a:xfrm>
           <a:prstGeom prst="rect">
@@ -40810,7 +40882,7 @@
         </p:blipFill>
         <p:spPr>
           <a:xfrm>
-            <a:off x="3810000" y="2463800"/>
+            <a:off x="3810000" y="2590800"/>
             <a:ext cx="508000" cy="190500"/>
           </a:xfrm>
           <a:prstGeom prst="rect">
@@ -40834,7 +40906,7 @@
         </p:blipFill>
         <p:spPr>
           <a:xfrm>
-            <a:off x="4419600" y="2463800"/>
+            <a:off x="4419600" y="2590800"/>
             <a:ext cx="203200" cy="177800"/>
           </a:xfrm>
           <a:prstGeom prst="rect">
@@ -40858,7 +40930,7 @@
         </p:blipFill>
         <p:spPr>
           <a:xfrm>
-            <a:off x="1828800" y="2781300"/>
+            <a:off x="1828800" y="2908300"/>
             <a:ext cx="1701800" cy="254000"/>
           </a:xfrm>
           <a:prstGeom prst="rect">
@@ -40882,7 +40954,7 @@
         </p:blipFill>
         <p:spPr>
           <a:xfrm>
-            <a:off x="3810000" y="2806700"/>
+            <a:off x="3810000" y="2933700"/>
             <a:ext cx="444500" cy="190500"/>
           </a:xfrm>
           <a:prstGeom prst="rect">
@@ -40906,7 +40978,7 @@
         </p:blipFill>
         <p:spPr>
           <a:xfrm>
-            <a:off x="1447800" y="3124200"/>
+            <a:off x="1447800" y="3251200"/>
             <a:ext cx="2082800" cy="304800"/>
           </a:xfrm>
           <a:prstGeom prst="rect">
@@ -40930,7 +41002,7 @@
         </p:blipFill>
         <p:spPr>
           <a:xfrm>
-            <a:off x="3810000" y="3149600"/>
+            <a:off x="3810000" y="3276600"/>
             <a:ext cx="292100" cy="190500"/>
           </a:xfrm>
           <a:prstGeom prst="rect">
@@ -40954,7 +41026,7 @@
         </p:blipFill>
         <p:spPr>
           <a:xfrm>
-            <a:off x="4203700" y="3149600"/>
+            <a:off x="4203700" y="3276600"/>
             <a:ext cx="203200" cy="177800"/>
           </a:xfrm>
           <a:prstGeom prst="rect">
@@ -40978,7 +41050,7 @@
         </p:blipFill>
         <p:spPr>
           <a:xfrm>
-            <a:off x="1651000" y="3467100"/>
+            <a:off x="1651000" y="3594100"/>
             <a:ext cx="1879600" cy="254000"/>
           </a:xfrm>
           <a:prstGeom prst="rect">
@@ -41002,7 +41074,7 @@
         </p:blipFill>
         <p:spPr>
           <a:xfrm>
-            <a:off x="3810000" y="3492500"/>
+            <a:off x="3810000" y="3619500"/>
             <a:ext cx="114300" cy="190500"/>
           </a:xfrm>
           <a:prstGeom prst="rect">
@@ -41026,7 +41098,7 @@
         </p:blipFill>
         <p:spPr>
           <a:xfrm>
-            <a:off x="1320800" y="3810000"/>
+            <a:off x="1320800" y="3937000"/>
             <a:ext cx="2209800" cy="254000"/>
           </a:xfrm>
           <a:prstGeom prst="rect">
@@ -41050,7 +41122,7 @@
         </p:blipFill>
         <p:spPr>
           <a:xfrm>
-            <a:off x="3810000" y="3835400"/>
+            <a:off x="3810000" y="3962400"/>
             <a:ext cx="114300" cy="190500"/>
           </a:xfrm>
           <a:prstGeom prst="rect">
@@ -41074,7 +41146,7 @@
         </p:blipFill>
         <p:spPr>
           <a:xfrm>
-            <a:off x="1549400" y="4152900"/>
+            <a:off x="1549400" y="4279900"/>
             <a:ext cx="1981200" cy="304800"/>
           </a:xfrm>
           <a:prstGeom prst="rect">
@@ -41098,7 +41170,7 @@
         </p:blipFill>
         <p:spPr>
           <a:xfrm>
-            <a:off x="3810000" y="4178300"/>
+            <a:off x="3810000" y="4305300"/>
             <a:ext cx="88900" cy="190500"/>
           </a:xfrm>
           <a:prstGeom prst="rect">
@@ -41122,7 +41194,7 @@
         </p:blipFill>
         <p:spPr>
           <a:xfrm>
-            <a:off x="990600" y="4495800"/>
+            <a:off x="990600" y="4622800"/>
             <a:ext cx="2540000" cy="254000"/>
           </a:xfrm>
           <a:prstGeom prst="rect">
@@ -41146,7 +41218,7 @@
         </p:blipFill>
         <p:spPr>
           <a:xfrm>
-            <a:off x="3810000" y="4521200"/>
+            <a:off x="3810000" y="4648200"/>
             <a:ext cx="88900" cy="190500"/>
           </a:xfrm>
           <a:prstGeom prst="rect">
@@ -41170,7 +41242,7 @@
         </p:blipFill>
         <p:spPr>
           <a:xfrm>
-            <a:off x="1168400" y="4838700"/>
+            <a:off x="1168400" y="4965700"/>
             <a:ext cx="2362200" cy="254000"/>
           </a:xfrm>
           <a:prstGeom prst="rect">
@@ -41194,7 +41266,7 @@
         </p:blipFill>
         <p:spPr>
           <a:xfrm>
-            <a:off x="3810000" y="4864100"/>
+            <a:off x="3810000" y="4991100"/>
             <a:ext cx="63500" cy="190500"/>
           </a:xfrm>
           <a:prstGeom prst="rect">
@@ -41218,7 +41290,7 @@
         </p:blipFill>
         <p:spPr>
           <a:xfrm>
-            <a:off x="1270000" y="5181600"/>
+            <a:off x="1270000" y="5308600"/>
             <a:ext cx="2260600" cy="254000"/>
           </a:xfrm>
           <a:prstGeom prst="rect">
@@ -41242,7 +41314,7 @@
         </p:blipFill>
         <p:spPr>
           <a:xfrm>
-            <a:off x="3810000" y="5207000"/>
+            <a:off x="3810000" y="5334000"/>
             <a:ext cx="38100" cy="190500"/>
           </a:xfrm>
           <a:prstGeom prst="rect">
@@ -41266,7 +41338,7 @@
         </p:blipFill>
         <p:spPr>
           <a:xfrm>
-            <a:off x="1447800" y="5524500"/>
+            <a:off x="1447800" y="5651500"/>
             <a:ext cx="2082800" cy="254000"/>
           </a:xfrm>
           <a:prstGeom prst="rect">
@@ -41290,7 +41362,7 @@
         </p:blipFill>
         <p:spPr>
           <a:xfrm>
-            <a:off x="3810000" y="5549900"/>
+            <a:off x="3810000" y="5676900"/>
             <a:ext cx="38100" cy="190500"/>
           </a:xfrm>
           <a:prstGeom prst="rect">
@@ -41314,7 +41386,7 @@
         </p:blipFill>
         <p:spPr>
           <a:xfrm>
-            <a:off x="6324600" y="1574800"/>
+            <a:off x="6324600" y="1701800"/>
             <a:ext cx="203200" cy="177800"/>
           </a:xfrm>
           <a:prstGeom prst="rect">
@@ -41338,7 +41410,7 @@
         </p:blipFill>
         <p:spPr>
           <a:xfrm>
-            <a:off x="6629400" y="1524000"/>
+            <a:off x="6629400" y="1651000"/>
             <a:ext cx="2006600" cy="673100"/>
           </a:xfrm>
           <a:prstGeom prst="rect">
@@ -41607,8 +41679,8 @@
         </p:blipFill>
         <p:spPr>
           <a:xfrm>
-            <a:off x="762000" y="4699000"/>
-            <a:ext cx="2698750" cy="1047750"/>
+            <a:off x="730250" y="4699000"/>
+            <a:ext cx="2730500" cy="1047750"/>
           </a:xfrm>
           <a:prstGeom prst="rect">
             <a:avLst/>
@@ -41872,7 +41944,7 @@
         <p:spPr>
           <a:xfrm>
             <a:off x="254000" y="6159500"/>
-            <a:ext cx="6191250" cy="635000"/>
+            <a:ext cx="5746750" cy="635000"/>
           </a:xfrm>
           <a:prstGeom prst="rect">
             <a:avLst/>

</xml_diff>

<commit_message>
Team names in report, README and closing slide; noise_models docstring matches the code
</commit_message>
<xml_diff>
--- a/deck/IPHR_Reproduction.pptx
+++ b/deck/IPHR_Reproduction.pptx
@@ -47155,8 +47155,8 @@
         </p:blipFill>
         <p:spPr>
           <a:xfrm>
-            <a:off x="2825750" y="476250"/>
-            <a:ext cx="6508750" cy="1333500"/>
+            <a:off x="3460750" y="285750"/>
+            <a:ext cx="5270500" cy="1111250"/>
           </a:xfrm>
           <a:prstGeom prst="rect">
             <a:avLst/>
@@ -47179,17 +47179,17 @@
         </p:blipFill>
         <p:spPr>
           <a:xfrm>
-            <a:off x="2603500" y="1778000"/>
-            <a:ext cx="6985000" cy="539750"/>
-          </a:xfrm>
-          <a:prstGeom prst="rect">
-            <a:avLst/>
-          </a:prstGeom>
-        </p:spPr>
-      </p:pic>
-      <p:pic>
-        <p:nvPicPr>
-          <p:cNvPr id="11" name="!!t_thanks" descr="image.png"/>
+            <a:off x="2921000" y="1333500"/>
+            <a:ext cx="6318250" cy="508000"/>
+          </a:xfrm>
+          <a:prstGeom prst="rect">
+            <a:avLst/>
+          </a:prstGeom>
+        </p:spPr>
+      </p:pic>
+      <p:pic>
+        <p:nvPicPr>
+          <p:cNvPr id="11" name="!!panel_pl_names2" descr="image.png"/>
           <p:cNvPicPr>
             <a:picLocks noChangeAspect="1"/>
           </p:cNvPicPr>
@@ -47203,17 +47203,17 @@
         </p:blipFill>
         <p:spPr>
           <a:xfrm>
-            <a:off x="2952750" y="571500"/>
-            <a:ext cx="6254750" cy="1143000"/>
-          </a:xfrm>
-          <a:prstGeom prst="rect">
-            <a:avLst/>
-          </a:prstGeom>
-        </p:spPr>
-      </p:pic>
-      <p:pic>
-        <p:nvPicPr>
-          <p:cNvPr id="12" name="!!t_names" descr="image.png"/>
+            <a:off x="2952750" y="1746250"/>
+            <a:ext cx="6254750" cy="508000"/>
+          </a:xfrm>
+          <a:prstGeom prst="rect">
+            <a:avLst/>
+          </a:prstGeom>
+        </p:spPr>
+      </p:pic>
+      <p:pic>
+        <p:nvPicPr>
+          <p:cNvPr id="12" name="!!t_thanks" descr="image.png"/>
           <p:cNvPicPr>
             <a:picLocks noChangeAspect="1"/>
           </p:cNvPicPr>
@@ -47227,17 +47227,17 @@
         </p:blipFill>
         <p:spPr>
           <a:xfrm>
-            <a:off x="2730500" y="1873250"/>
-            <a:ext cx="6731000" cy="349250"/>
-          </a:xfrm>
-          <a:prstGeom prst="rect">
-            <a:avLst/>
-          </a:prstGeom>
-        </p:spPr>
-      </p:pic>
-      <p:pic>
-        <p:nvPicPr>
-          <p:cNvPr id="13" name="!!panel_pl_repo" descr="image.png"/>
+            <a:off x="3587750" y="381000"/>
+            <a:ext cx="5016500" cy="920750"/>
+          </a:xfrm>
+          <a:prstGeom prst="rect">
+            <a:avLst/>
+          </a:prstGeom>
+        </p:spPr>
+      </p:pic>
+      <p:pic>
+        <p:nvPicPr>
+          <p:cNvPr id="13" name="!!t_names" descr="image.png"/>
           <p:cNvPicPr>
             <a:picLocks noChangeAspect="1"/>
           </p:cNvPicPr>
@@ -47251,7 +47251,55 @@
         </p:blipFill>
         <p:spPr>
           <a:xfrm>
-            <a:off x="1016000" y="2317750"/>
+            <a:off x="3048000" y="1428750"/>
+            <a:ext cx="6064250" cy="317500"/>
+          </a:xfrm>
+          <a:prstGeom prst="rect">
+            <a:avLst/>
+          </a:prstGeom>
+        </p:spPr>
+      </p:pic>
+      <p:pic>
+        <p:nvPicPr>
+          <p:cNvPr id="14" name="!!t_names2" descr="image.png"/>
+          <p:cNvPicPr>
+            <a:picLocks noChangeAspect="1"/>
+          </p:cNvPicPr>
+          <p:nvPr/>
+        </p:nvPicPr>
+        <p:blipFill>
+          <a:blip r:embed="rId14"/>
+          <a:stretch>
+            <a:fillRect/>
+          </a:stretch>
+        </p:blipFill>
+        <p:spPr>
+          <a:xfrm>
+            <a:off x="3079750" y="1841500"/>
+            <a:ext cx="6000750" cy="317500"/>
+          </a:xfrm>
+          <a:prstGeom prst="rect">
+            <a:avLst/>
+          </a:prstGeom>
+        </p:spPr>
+      </p:pic>
+      <p:pic>
+        <p:nvPicPr>
+          <p:cNvPr id="15" name="!!panel_pl_repo" descr="image.png"/>
+          <p:cNvPicPr>
+            <a:picLocks noChangeAspect="1"/>
+          </p:cNvPicPr>
+          <p:nvPr/>
+        </p:nvPicPr>
+        <p:blipFill>
+          <a:blip r:embed="rId15"/>
+          <a:stretch>
+            <a:fillRect/>
+          </a:stretch>
+        </p:blipFill>
+        <p:spPr>
+          <a:xfrm>
+            <a:off x="1016000" y="2254250"/>
             <a:ext cx="10128250" cy="698500"/>
           </a:xfrm>
           <a:prstGeom prst="rect">
@@ -47261,21 +47309,21 @@
       </p:pic>
       <p:pic>
         <p:nvPicPr>
-          <p:cNvPr id="14" name="!!t_repo" descr="image.png"/>
-          <p:cNvPicPr>
-            <a:picLocks noChangeAspect="1"/>
-          </p:cNvPicPr>
-          <p:nvPr/>
-        </p:nvPicPr>
-        <p:blipFill>
-          <a:blip r:embed="rId14"/>
-          <a:stretch>
-            <a:fillRect/>
-          </a:stretch>
-        </p:blipFill>
-        <p:spPr>
-          <a:xfrm>
-            <a:off x="1158875" y="2413000"/>
+          <p:cNvPr id="16" name="!!t_repo" descr="image.png"/>
+          <p:cNvPicPr>
+            <a:picLocks noChangeAspect="1"/>
+          </p:cNvPicPr>
+          <p:nvPr/>
+        </p:nvPicPr>
+        <p:blipFill>
+          <a:blip r:embed="rId16"/>
+          <a:stretch>
+            <a:fillRect/>
+          </a:stretch>
+        </p:blipFill>
+        <p:spPr>
+          <a:xfrm>
+            <a:off x="1158875" y="2349500"/>
             <a:ext cx="9874250" cy="508000"/>
           </a:xfrm>
           <a:prstGeom prst="rect">

</xml_diff>